<commit_message>
Add real Railway metrics, business+technical impact framing, remove em dashes
</commit_message>
<xml_diff>
--- a/deck/AI-Recruiting-Automation-Portfolio.pptx
+++ b/deck/AI-Recruiting-Automation-Portfolio.pptx
@@ -1721,7 +1721,7 @@
                 <a:ea typeface="Calibri" pitchFamily="34" charset="-122"/>
                 <a:cs typeface="Calibri" pitchFamily="34" charset="-120"/>
               </a:rPr>
-              <a:t>An end-to-end LLM matching engine and a 14-service communications pipeline — designed, built, and documented from scratch, running in production.</a:t>
+              <a:t>An end-to-end LLM matching engine and a 14-service communications pipeline, designed, built, and documented from scratch, running in production.</a:t>
             </a:r>
             <a:endParaRPr lang="en-US" sz="1800" dirty="0"/>
           </a:p>
@@ -2212,7 +2212,7 @@
                 <a:ea typeface="Calibri" pitchFamily="34" charset="-122"/>
                 <a:cs typeface="Calibri" pitchFamily="34" charset="-120"/>
               </a:rPr>
-              <a:t>Hundreds of applicants per role, most not a fit — manual screening is hours of work.</a:t>
+              <a:t>Hundreds of applicants per role, most not a fit, manual screening is hours of work.</a:t>
             </a:r>
             <a:endParaRPr lang="en-US" sz="1350" dirty="0"/>
           </a:p>
@@ -2527,7 +2527,7 @@
                 <a:ea typeface="Calibri" pitchFamily="34" charset="-122"/>
                 <a:cs typeface="Calibri" pitchFamily="34" charset="-120"/>
               </a:rPr>
-              <a:t>A bare match score is useless — a recruiter needs to know WHY a candidate ranked.</a:t>
+              <a:t>A bare match score is useless, a recruiter needs to know WHY a candidate ranked.</a:t>
             </a:r>
             <a:endParaRPr lang="en-US" sz="1350" dirty="0"/>
           </a:p>
@@ -2925,7 +2925,7 @@
                 <a:ea typeface="Calibri" pitchFamily="34" charset="-122"/>
                 <a:cs typeface="Calibri" pitchFamily="34" charset="-120"/>
               </a:rPr>
-              <a:t>The comms &amp; data pipeline: batched email and WhatsApp outreach, transcript ingestion and scoring, and CV parsing — each isolated.</a:t>
+              <a:t>The comms &amp; data pipeline: batched email and WhatsApp outreach, transcript ingestion and scoring, and CV parsing, each isolated.</a:t>
             </a:r>
             <a:endParaRPr lang="en-US" sz="1400" dirty="0"/>
           </a:p>
@@ -2983,7 +2983,7 @@
               <a:buNone/>
             </a:pPr>
             <a:r>
-              <a:rPr lang="en-US" sz="3200" b="1" dirty="0">
+              <a:rPr lang="en-US" sz="3000" b="1" dirty="0">
                 <a:solidFill>
                   <a:srgbClr val="5EEAD4"/>
                 </a:solidFill>
@@ -2991,9 +2991,9 @@
                 <a:ea typeface="Georgia" pitchFamily="34" charset="-122"/>
                 <a:cs typeface="Georgia" pitchFamily="34" charset="-120"/>
               </a:rPr>
-              <a:t>14</a:t>
-            </a:r>
-            <a:endParaRPr lang="en-US" sz="3200" dirty="0"/>
+              <a:t>40,000</a:t>
+            </a:r>
+            <a:endParaRPr lang="en-US" sz="3000" dirty="0"/>
           </a:p>
         </p:txBody>
       </p:sp>
@@ -3030,7 +3030,7 @@
                 <a:ea typeface="Calibri" pitchFamily="34" charset="-122"/>
                 <a:cs typeface="Calibri" pitchFamily="34" charset="-120"/>
               </a:rPr>
-              <a:t>deployed services</a:t>
+              <a:t>rows scanned / run</a:t>
             </a:r>
             <a:endParaRPr lang="en-US" sz="1250" dirty="0"/>
           </a:p>
@@ -3088,7 +3088,7 @@
               <a:buNone/>
             </a:pPr>
             <a:r>
-              <a:rPr lang="en-US" sz="3200" b="1" dirty="0">
+              <a:rPr lang="en-US" sz="3000" b="1" dirty="0">
                 <a:solidFill>
                   <a:srgbClr val="5EEAD4"/>
                 </a:solidFill>
@@ -3096,9 +3096,9 @@
                 <a:ea typeface="Georgia" pitchFamily="34" charset="-122"/>
                 <a:cs typeface="Georgia" pitchFamily="34" charset="-120"/>
               </a:rPr>
-              <a:t>6</a:t>
-            </a:r>
-            <a:endParaRPr lang="en-US" sz="3200" dirty="0"/>
+              <a:t>~2 hrs</a:t>
+            </a:r>
+            <a:endParaRPr lang="en-US" sz="3000" dirty="0"/>
           </a:p>
         </p:txBody>
       </p:sp>
@@ -3135,7 +3135,7 @@
                 <a:ea typeface="Calibri" pitchFamily="34" charset="-122"/>
                 <a:cs typeface="Calibri" pitchFamily="34" charset="-120"/>
               </a:rPr>
-              <a:t>stage funnel</a:t>
+              <a:t>full run on Railway</a:t>
             </a:r>
             <a:endParaRPr lang="en-US" sz="1250" dirty="0"/>
           </a:p>
@@ -3193,7 +3193,7 @@
               <a:buNone/>
             </a:pPr>
             <a:r>
-              <a:rPr lang="en-US" sz="3200" b="1" dirty="0">
+              <a:rPr lang="en-US" sz="3000" b="1" dirty="0">
                 <a:solidFill>
                   <a:srgbClr val="5EEAD4"/>
                 </a:solidFill>
@@ -3201,9 +3201,9 @@
                 <a:ea typeface="Georgia" pitchFamily="34" charset="-122"/>
                 <a:cs typeface="Georgia" pitchFamily="34" charset="-120"/>
               </a:rPr>
-              <a:t>100s</a:t>
-            </a:r>
-            <a:endParaRPr lang="en-US" sz="3200" dirty="0"/>
+              <a:t>14</a:t>
+            </a:r>
+            <a:endParaRPr lang="en-US" sz="3000" dirty="0"/>
           </a:p>
         </p:txBody>
       </p:sp>
@@ -3240,7 +3240,7 @@
                 <a:ea typeface="Calibri" pitchFamily="34" charset="-122"/>
                 <a:cs typeface="Calibri" pitchFamily="34" charset="-120"/>
               </a:rPr>
-              <a:t>scored / run</a:t>
+              <a:t>services on Railway</a:t>
             </a:r>
             <a:endParaRPr lang="en-US" sz="1250" dirty="0"/>
           </a:p>
@@ -3298,7 +3298,7 @@
               <a:buNone/>
             </a:pPr>
             <a:r>
-              <a:rPr lang="en-US" sz="3200" b="1" dirty="0">
+              <a:rPr lang="en-US" sz="3000" b="1" dirty="0">
                 <a:solidFill>
                   <a:srgbClr val="5EEAD4"/>
                 </a:solidFill>
@@ -3306,9 +3306,9 @@
                 <a:ea typeface="Georgia" pitchFamily="34" charset="-122"/>
                 <a:cs typeface="Georgia" pitchFamily="34" charset="-120"/>
               </a:rPr>
-              <a:t>hrs→min</a:t>
-            </a:r>
-            <a:endParaRPr lang="en-US" sz="3200" dirty="0"/>
+              <a:t>weeks→hrs</a:t>
+            </a:r>
+            <a:endParaRPr lang="en-US" sz="3000" dirty="0"/>
           </a:p>
         </p:txBody>
       </p:sp>
@@ -3345,7 +3345,7 @@
                 <a:ea typeface="Calibri" pitchFamily="34" charset="-122"/>
                 <a:cs typeface="Calibri" pitchFamily="34" charset="-120"/>
               </a:rPr>
-              <a:t>manual work cut</a:t>
+              <a:t>screening per role</a:t>
             </a:r>
             <a:endParaRPr lang="en-US" sz="1250" dirty="0"/>
           </a:p>
@@ -3372,21 +3372,21 @@
           <a:bodyPr wrap="square" rtlCol="0" anchor="ctr"/>
           <a:lstStyle/>
           <a:p>
-            <a:pPr indent="0" marL="0">
-              <a:buNone/>
-            </a:pPr>
-            <a:r>
-              <a:rPr lang="en-US" sz="1250" i="1" dirty="0">
-                <a:solidFill>
-                  <a:srgbClr val="F0B86E"/>
+            <a:pPr algn="ctr" indent="0" marL="0">
+              <a:buNone/>
+            </a:pPr>
+            <a:r>
+              <a:rPr lang="en-US" sz="1300" i="1" dirty="0">
+                <a:solidFill>
+                  <a:srgbClr val="7D8896"/>
                 </a:solidFill>
                 <a:latin typeface="Calibri" pitchFamily="34" charset="0"/>
                 <a:ea typeface="Calibri" pitchFamily="34" charset="-122"/>
                 <a:cs typeface="Calibri" pitchFamily="34" charset="-120"/>
               </a:rPr>
-              <a:t>⚑  Placeholder figures — swap for your real, defensible numbers before presenting.</a:t>
-            </a:r>
-            <a:endParaRPr lang="en-US" sz="1250" dirty="0"/>
+              <a:t>Deployed on Railway, triggered by webhooks, runs unattended.</a:t>
+            </a:r>
+            <a:endParaRPr lang="en-US" sz="1300" dirty="0"/>
           </a:p>
         </p:txBody>
       </p:sp>
@@ -4851,7 +4851,7 @@
                 <a:ea typeface="Calibri" pitchFamily="34" charset="-122"/>
                 <a:cs typeface="Calibri" pitchFamily="34" charset="-120"/>
               </a:rPr>
-              <a:t>Cheap local filter drops no-signal candidates BEFORE any paid LLM call — top cost lever.</a:t>
+              <a:t>Cheap local filter drops no-signal candidates BEFORE any paid LLM call, top cost lever.</a:t>
             </a:r>
             <a:endParaRPr lang="en-US" sz="1250" dirty="0"/>
           </a:p>
@@ -5364,7 +5364,7 @@
                 <a:ea typeface="Calibri" pitchFamily="34" charset="-122"/>
                 <a:cs typeface="Calibri" pitchFamily="34" charset="-120"/>
               </a:rPr>
-              <a:t>0–100 + written rationale each, concurrency-capped, retried, failure-isolated.</a:t>
+              <a:t>0-100 + written rationale each, concurrency-capped, retried, failure-isolated.</a:t>
             </a:r>
             <a:endParaRPr lang="en-US" sz="1250" dirty="0"/>
           </a:p>
@@ -5535,7 +5535,7 @@
                 <a:ea typeface="Calibri" pitchFamily="34" charset="-122"/>
                 <a:cs typeface="Calibri" pitchFamily="34" charset="-120"/>
               </a:rPr>
-              <a:t>Link qualified first; backfill best below-threshold to hit target — logged.</a:t>
+              <a:t>Link qualified first; backfill best below-threshold to hit target, logged.</a:t>
             </a:r>
             <a:endParaRPr lang="en-US" sz="1250" dirty="0"/>
           </a:p>
@@ -5814,7 +5814,7 @@
                 <a:ea typeface="Calibri" pitchFamily="34" charset="-122"/>
                 <a:cs typeface="Calibri" pitchFamily="34" charset="-120"/>
               </a:rPr>
-              <a:t>Scored records skipped on re-run — no double-contact, no duplicate matches.</a:t>
+              <a:t>Scored records skipped on re-run, no double-contact, no duplicate matches.</a:t>
             </a:r>
             <a:endParaRPr lang="en-US" sz="1200" dirty="0"/>
           </a:p>
@@ -5983,7 +5983,7 @@
                 <a:ea typeface="Calibri" pitchFamily="34" charset="-122"/>
                 <a:cs typeface="Calibri" pitchFamily="34" charset="-120"/>
               </a:rPr>
-              <a:t>Sequential queue, concurrency cap, write delays — under quota by design.</a:t>
+              <a:t>Sequential queue, concurrency cap, write delays, under quota by design.</a:t>
             </a:r>
             <a:endParaRPr lang="en-US" sz="1200" dirty="0"/>
           </a:p>
@@ -6490,7 +6490,7 @@
                 <a:ea typeface="Calibri" pitchFamily="34" charset="-122"/>
                 <a:cs typeface="Calibri" pitchFamily="34" charset="-120"/>
               </a:rPr>
-              <a:t>Cheap filters first, candidate caps, TTL cache — minimal LLM spend.</a:t>
+              <a:t>Cheap filters first, candidate caps, TTL cache, minimal LLM spend.</a:t>
             </a:r>
             <a:endParaRPr lang="en-US" sz="1200" dirty="0"/>
           </a:p>
@@ -6659,7 +6659,7 @@
                 <a:ea typeface="Calibri" pitchFamily="34" charset="-122"/>
                 <a:cs typeface="Calibri" pitchFamily="34" charset="-120"/>
               </a:rPr>
-              <a:t>Logs keyed by id, email, stage, skip reason — debuggable from logs alone.</a:t>
+              <a:t>Logs keyed by id, email, stage, skip reason, debuggable from logs alone.</a:t>
             </a:r>
             <a:endParaRPr lang="en-US" sz="1200" dirty="0"/>
           </a:p>
@@ -6913,7 +6913,7 @@
                 <a:ea typeface="Calibri" pitchFamily="34" charset="-122"/>
                 <a:cs typeface="Calibri" pitchFamily="34" charset="-120"/>
               </a:rPr>
-              <a:t>One-table overview for managers, branch-level depth for engineers — same doc.</a:t>
+              <a:t>One-table overview for managers, branch-level depth for engineers, same doc.</a:t>
             </a:r>
             <a:endParaRPr lang="en-US" sz="1250" dirty="0"/>
           </a:p>
@@ -7309,7 +7309,7 @@
                 <a:ea typeface="Consolas" pitchFamily="34" charset="-122"/>
                 <a:cs typeface="Consolas" pitchFamily="34" charset="-120"/>
               </a:rPr>
-              <a:t>Candidate not considered for a role — check, in order:
+              <a:t>Candidate not considered for a role, check, in order:
 </a:t>
             </a:r>
             <a:pPr indent="0" marL="0">
@@ -7348,7 +7348,7 @@
                 <a:ea typeface="Consolas" pitchFamily="34" charset="-122"/>
                 <a:cs typeface="Consolas" pitchFamily="34" charset="-120"/>
               </a:rPr>
-              <a:t>Fewer qualified matches than target — expected:
+              <a:t>Fewer qualified matches than target, expected:
 </a:t>
             </a:r>
             <a:pPr indent="0" marL="0">
@@ -7574,8 +7574,8 @@
         </p:nvSpPr>
         <p:spPr>
           <a:xfrm>
-            <a:off x="1005840" y="2194560"/>
-            <a:ext cx="4572000" cy="868680"/>
+            <a:off x="1005840" y="2212848"/>
+            <a:ext cx="4572000" cy="822960"/>
           </a:xfrm>
           <a:prstGeom prst="rect">
             <a:avLst/>
@@ -7591,7 +7591,7 @@
               <a:buNone/>
             </a:pPr>
             <a:r>
-              <a:rPr lang="en-US" sz="4400" b="1" dirty="0">
+              <a:rPr lang="en-US" sz="3800" b="1" dirty="0">
                 <a:solidFill>
                   <a:srgbClr val="5EEAD4"/>
                 </a:solidFill>
@@ -7599,9 +7599,9 @@
                 <a:ea typeface="Georgia" pitchFamily="34" charset="-122"/>
                 <a:cs typeface="Georgia" pitchFamily="34" charset="-120"/>
               </a:rPr>
-              <a:t>100s</a:t>
-            </a:r>
-            <a:endParaRPr lang="en-US" sz="4400" dirty="0"/>
+              <a:t>40,000</a:t>
+            </a:r>
+            <a:endParaRPr lang="en-US" sz="3800" dirty="0"/>
           </a:p>
         </p:txBody>
       </p:sp>
@@ -7614,7 +7614,7 @@
         <p:spPr>
           <a:xfrm>
             <a:off x="1024128" y="3063240"/>
-            <a:ext cx="4480560" cy="457200"/>
+            <a:ext cx="4526280" cy="457200"/>
           </a:xfrm>
           <a:prstGeom prst="rect">
             <a:avLst/>
@@ -7630,7 +7630,7 @@
               <a:buNone/>
             </a:pPr>
             <a:r>
-              <a:rPr lang="en-US" sz="1450" dirty="0">
+              <a:rPr lang="en-US" sz="1400" dirty="0">
                 <a:solidFill>
                   <a:srgbClr val="9AA7B4"/>
                 </a:solidFill>
@@ -7638,9 +7638,9 @@
                 <a:ea typeface="Calibri" pitchFamily="34" charset="-122"/>
                 <a:cs typeface="Calibri" pitchFamily="34" charset="-120"/>
               </a:rPr>
-              <a:t>candidates scored per run, unattended</a:t>
-            </a:r>
-            <a:endParaRPr lang="en-US" sz="1450" dirty="0"/>
+              <a:t>candidate rows scanned per run, unattended</a:t>
+            </a:r>
+            <a:endParaRPr lang="en-US" sz="1400" dirty="0"/>
           </a:p>
         </p:txBody>
       </p:sp>
@@ -7679,8 +7679,8 @@
         </p:nvSpPr>
         <p:spPr>
           <a:xfrm>
-            <a:off x="6446520" y="2194560"/>
-            <a:ext cx="4572000" cy="868680"/>
+            <a:off x="6446520" y="2212848"/>
+            <a:ext cx="4572000" cy="822960"/>
           </a:xfrm>
           <a:prstGeom prst="rect">
             <a:avLst/>
@@ -7696,7 +7696,7 @@
               <a:buNone/>
             </a:pPr>
             <a:r>
-              <a:rPr lang="en-US" sz="4400" b="1" dirty="0">
+              <a:rPr lang="en-US" sz="3800" b="1" dirty="0">
                 <a:solidFill>
                   <a:srgbClr val="5EEAD4"/>
                 </a:solidFill>
@@ -7704,9 +7704,9 @@
                 <a:ea typeface="Georgia" pitchFamily="34" charset="-122"/>
                 <a:cs typeface="Georgia" pitchFamily="34" charset="-120"/>
               </a:rPr>
-              <a:t>hrs → min</a:t>
-            </a:r>
-            <a:endParaRPr lang="en-US" sz="4400" dirty="0"/>
+              <a:t>~2 hrs</a:t>
+            </a:r>
+            <a:endParaRPr lang="en-US" sz="3800" dirty="0"/>
           </a:p>
         </p:txBody>
       </p:sp>
@@ -7719,7 +7719,7 @@
         <p:spPr>
           <a:xfrm>
             <a:off x="6464808" y="3063240"/>
-            <a:ext cx="4480560" cy="457200"/>
+            <a:ext cx="4526280" cy="457200"/>
           </a:xfrm>
           <a:prstGeom prst="rect">
             <a:avLst/>
@@ -7735,7 +7735,7 @@
               <a:buNone/>
             </a:pPr>
             <a:r>
-              <a:rPr lang="en-US" sz="1450" dirty="0">
+              <a:rPr lang="en-US" sz="1400" dirty="0">
                 <a:solidFill>
                   <a:srgbClr val="9AA7B4"/>
                 </a:solidFill>
@@ -7743,9 +7743,9 @@
                 <a:ea typeface="Calibri" pitchFamily="34" charset="-122"/>
                 <a:cs typeface="Calibri" pitchFamily="34" charset="-120"/>
               </a:rPr>
-              <a:t>manual shortlisting per role, eliminated</a:t>
-            </a:r>
-            <a:endParaRPr lang="en-US" sz="1450" dirty="0"/>
+              <a:t>full run on Railway, webhook to shortlist</a:t>
+            </a:r>
+            <a:endParaRPr lang="en-US" sz="1400" dirty="0"/>
           </a:p>
         </p:txBody>
       </p:sp>
@@ -7784,8 +7784,8 @@
         </p:nvSpPr>
         <p:spPr>
           <a:xfrm>
-            <a:off x="1005840" y="4160520"/>
-            <a:ext cx="4572000" cy="868680"/>
+            <a:off x="1005840" y="4178808"/>
+            <a:ext cx="4572000" cy="822960"/>
           </a:xfrm>
           <a:prstGeom prst="rect">
             <a:avLst/>
@@ -7801,7 +7801,7 @@
               <a:buNone/>
             </a:pPr>
             <a:r>
-              <a:rPr lang="en-US" sz="4400" b="1" dirty="0">
+              <a:rPr lang="en-US" sz="3800" b="1" dirty="0">
                 <a:solidFill>
                   <a:srgbClr val="5EEAD4"/>
                 </a:solidFill>
@@ -7809,9 +7809,9 @@
                 <a:ea typeface="Georgia" pitchFamily="34" charset="-122"/>
                 <a:cs typeface="Georgia" pitchFamily="34" charset="-120"/>
               </a:rPr>
-              <a:t>14</a:t>
-            </a:r>
-            <a:endParaRPr lang="en-US" sz="4400" dirty="0"/>
+              <a:t>weeks→hrs</a:t>
+            </a:r>
+            <a:endParaRPr lang="en-US" sz="3800" dirty="0"/>
           </a:p>
         </p:txBody>
       </p:sp>
@@ -7824,7 +7824,7 @@
         <p:spPr>
           <a:xfrm>
             <a:off x="1024128" y="5029200"/>
-            <a:ext cx="4480560" cy="457200"/>
+            <a:ext cx="4526280" cy="457200"/>
           </a:xfrm>
           <a:prstGeom prst="rect">
             <a:avLst/>
@@ -7840,7 +7840,7 @@
               <a:buNone/>
             </a:pPr>
             <a:r>
-              <a:rPr lang="en-US" sz="1450" dirty="0">
+              <a:rPr lang="en-US" sz="1400" dirty="0">
                 <a:solidFill>
                   <a:srgbClr val="9AA7B4"/>
                 </a:solidFill>
@@ -7848,9 +7848,9 @@
                 <a:ea typeface="Calibri" pitchFamily="34" charset="-122"/>
                 <a:cs typeface="Calibri" pitchFamily="34" charset="-120"/>
               </a:rPr>
-              <a:t>integrations live with zero rate-limit incidents</a:t>
-            </a:r>
-            <a:endParaRPr lang="en-US" sz="1450" dirty="0"/>
+              <a:t>recruiter screening per role, collapsed</a:t>
+            </a:r>
+            <a:endParaRPr lang="en-US" sz="1400" dirty="0"/>
           </a:p>
         </p:txBody>
       </p:sp>
@@ -7889,8 +7889,8 @@
         </p:nvSpPr>
         <p:spPr>
           <a:xfrm>
-            <a:off x="6446520" y="4160520"/>
-            <a:ext cx="4572000" cy="868680"/>
+            <a:off x="6446520" y="4178808"/>
+            <a:ext cx="4572000" cy="822960"/>
           </a:xfrm>
           <a:prstGeom prst="rect">
             <a:avLst/>
@@ -7906,7 +7906,7 @@
               <a:buNone/>
             </a:pPr>
             <a:r>
-              <a:rPr lang="en-US" sz="4400" b="1" dirty="0">
+              <a:rPr lang="en-US" sz="3800" b="1" dirty="0">
                 <a:solidFill>
                   <a:srgbClr val="5EEAD4"/>
                 </a:solidFill>
@@ -7916,7 +7916,7 @@
               </a:rPr>
               <a:t>1</a:t>
             </a:r>
-            <a:endParaRPr lang="en-US" sz="4400" dirty="0"/>
+            <a:endParaRPr lang="en-US" sz="3800" dirty="0"/>
           </a:p>
         </p:txBody>
       </p:sp>
@@ -7929,7 +7929,7 @@
         <p:spPr>
           <a:xfrm>
             <a:off x="6464808" y="5029200"/>
-            <a:ext cx="4480560" cy="457200"/>
+            <a:ext cx="4526280" cy="457200"/>
           </a:xfrm>
           <a:prstGeom prst="rect">
             <a:avLst/>
@@ -7945,7 +7945,7 @@
               <a:buNone/>
             </a:pPr>
             <a:r>
-              <a:rPr lang="en-US" sz="1450" dirty="0">
+              <a:rPr lang="en-US" sz="1400" dirty="0">
                 <a:solidFill>
                   <a:srgbClr val="9AA7B4"/>
                 </a:solidFill>
@@ -7953,9 +7953,9 @@
                 <a:ea typeface="Calibri" pitchFamily="34" charset="-122"/>
                 <a:cs typeface="Calibri" pitchFamily="34" charset="-120"/>
               </a:rPr>
-              <a:t>explainable rationale on every single match</a:t>
-            </a:r>
-            <a:endParaRPr lang="en-US" sz="1450" dirty="0"/>
+              <a:t>written rationale on every single match</a:t>
+            </a:r>
+            <a:endParaRPr lang="en-US" sz="1400" dirty="0"/>
           </a:p>
         </p:txBody>
       </p:sp>
@@ -7980,19 +7980,19 @@
           <a:bodyPr wrap="square" rtlCol="0" anchor="ctr"/>
           <a:lstStyle/>
           <a:p>
-            <a:pPr indent="0" marL="0">
+            <a:pPr algn="ctr" indent="0" marL="0">
               <a:buNone/>
             </a:pPr>
             <a:r>
               <a:rPr lang="en-US" sz="1300" i="1" dirty="0">
                 <a:solidFill>
-                  <a:srgbClr val="F0B86E"/>
+                  <a:srgbClr val="7D8896"/>
                 </a:solidFill>
                 <a:latin typeface="Calibri" pitchFamily="34" charset="0"/>
                 <a:ea typeface="Calibri" pitchFamily="34" charset="-122"/>
                 <a:cs typeface="Calibri" pitchFamily="34" charset="-120"/>
               </a:rPr>
-              <a:t>⚑  Replace these with your real figures — one concrete, honest number is what a hiring manager remembers.</a:t>
+              <a:t>Business outcome above. The six-stage workflow that produces it is on the previous slides.</a:t>
             </a:r>
             <a:endParaRPr lang="en-US" sz="1300" dirty="0"/>
           </a:p>
@@ -8363,7 +8363,7 @@
                 <a:ea typeface="Calibri" pitchFamily="34" charset="-122"/>
                 <a:cs typeface="Calibri" pitchFamily="34" charset="-120"/>
               </a:rPr>
-              <a:t>A cost-aware, explainable, retried LLM scoring pipeline — not a single API call.</a:t>
+              <a:t>A cost-aware, explainable, retried LLM scoring pipeline, not a single API call.</a:t>
             </a:r>
             <a:endParaRPr lang="en-US" sz="1500" dirty="0"/>
           </a:p>

</xml_diff>

<commit_message>
Clarify webhook+cron triggers and env-var deployment model (Flash/Pro, 3x reminders); add Configurable by Design section/slide
</commit_message>
<xml_diff>
--- a/deck/AI-Recruiting-Automation-Portfolio.pptx
+++ b/deck/AI-Recruiting-Automation-Portfolio.pptx
@@ -14,9 +14,10 @@
     <p:sldId id="262" r:id="rId8"/>
     <p:sldId id="263" r:id="rId9"/>
     <p:sldId id="264" r:id="rId10"/>
+    <p:sldId id="265" r:id="rId11"/>
   </p:sldIdLst>
   <p:notesMasterIdLst>
-    <p:notesMasterId r:id="rId11"/>
+    <p:notesMasterId r:id="rId12"/>
   </p:notesMasterIdLst>
   <p:sldSz cx="12191695" cy="6858000"/>
   <p:notesSz cx="6858000" cy="12191695"/>
@@ -534,6 +535,94 @@
             <a:fld id="{F7021451-1387-4CA6-816F-3879F97B5CBC}" type="slidenum">
               <a:rPr lang="en-US"/>
               <a:t>1</a:t>
+            </a:fld>
+            <a:endParaRPr lang="en-US"/>
+          </a:p>
+        </p:txBody>
+      </p:sp>
+    </p:spTree>
+    <p:extLst>
+      <p:ext uri="{BB962C8B-B14F-4D97-AF65-F5344CB8AC3E}">
+        <p14:creationId xmlns:p14="http://schemas.microsoft.com/office/powerpoint/2010/main" val="1024086991"/>
+      </p:ext>
+    </p:extLst>
+  </p:cSld>
+  <p:clrMapOvr>
+    <a:masterClrMapping/>
+  </p:clrMapOvr>
+</p:notes>
+</file>
+
+<file path=ppt/notesSlides/notesSlide10.xml><?xml version="1.0" encoding="utf-8"?>
+<p:notes xmlns:a="http://schemas.openxmlformats.org/drawingml/2006/main" xmlns:r="http://schemas.openxmlformats.org/officeDocument/2006/relationships" xmlns:p="http://schemas.openxmlformats.org/presentationml/2006/main">
+  <p:cSld>
+    <p:spTree>
+      <p:nvGrpSpPr>
+        <p:cNvPr id="1" name=""/>
+        <p:cNvGrpSpPr/>
+        <p:nvPr/>
+      </p:nvGrpSpPr>
+      <p:grpSpPr>
+        <a:xfrm>
+          <a:off x="0" y="0"/>
+          <a:ext cx="0" cy="0"/>
+          <a:chOff x="0" y="0"/>
+          <a:chExt cx="0" cy="0"/>
+        </a:xfrm>
+      </p:grpSpPr>
+      <p:sp>
+        <p:nvSpPr>
+          <p:cNvPr id="2" name="Slide Image Placeholder 1"/>
+          <p:cNvSpPr>
+            <a:spLocks noGrp="1" noRot="1" noChangeAspect="1"/>
+          </p:cNvSpPr>
+          <p:nvPr>
+            <p:ph type="sldImg"/>
+          </p:nvPr>
+        </p:nvSpPr>
+        <p:spPr/>
+      </p:sp>
+      <p:sp>
+        <p:nvSpPr>
+          <p:cNvPr id="3" name="Notes Placeholder 2"/>
+          <p:cNvSpPr>
+            <a:spLocks noGrp="1"/>
+          </p:cNvSpPr>
+          <p:nvPr>
+            <p:ph type="body" idx="1"/>
+          </p:nvPr>
+        </p:nvSpPr>
+        <p:spPr/>
+        <p:txBody>
+          <a:bodyPr/>
+          <a:lstStyle/>
+          <a:p>
+            <a:r>
+              <a:rPr lang="en-US" dirty="0"/>
+              <a:t/>
+            </a:r>
+            <a:endParaRPr lang="en-US" dirty="0"/>
+          </a:p>
+        </p:txBody>
+      </p:sp>
+      <p:sp>
+        <p:nvSpPr>
+          <p:cNvPr id="4" name="Slide Number Placeholder 3"/>
+          <p:cNvSpPr>
+            <a:spLocks noGrp="1"/>
+          </p:cNvSpPr>
+          <p:nvPr>
+            <p:ph type="sldNum" sz="quarter" idx="10"/>
+          </p:nvPr>
+        </p:nvSpPr>
+        <p:spPr/>
+        <p:txBody>
+          <a:bodyPr/>
+          <a:lstStyle/>
+          <a:p>
+            <a:fld id="{F7021451-1387-4CA6-816F-3879F97B5CBC}" type="slidenum">
+              <a:rPr lang="en-US"/>
+              <a:t>10</a:t>
             </a:fld>
             <a:endParaRPr lang="en-US"/>
           </a:p>
@@ -1972,6 +2061,455 @@
 </p:sld>
 </file>
 
+<file path=ppt/slides/slide10.xml><?xml version="1.0" encoding="utf-8"?>
+<p:sld xmlns:a="http://schemas.openxmlformats.org/drawingml/2006/main" xmlns:r="http://schemas.openxmlformats.org/officeDocument/2006/relationships" xmlns:p="http://schemas.openxmlformats.org/presentationml/2006/main">
+  <p:cSld name="Slide 10">
+    <p:bg>
+      <p:bgPr>
+        <a:solidFill>
+          <a:srgbClr val="0D1117"/>
+        </a:solidFill>
+      </p:bgPr>
+    </p:bg>
+    <p:spTree>
+      <p:nvGrpSpPr>
+        <p:cNvPr id="1" name=""/>
+        <p:cNvGrpSpPr/>
+        <p:nvPr/>
+      </p:nvGrpSpPr>
+      <p:grpSpPr>
+        <a:xfrm>
+          <a:off x="0" y="0"/>
+          <a:ext cx="0" cy="0"/>
+          <a:chOff x="0" y="0"/>
+          <a:chExt cx="0" cy="0"/>
+        </a:xfrm>
+      </p:grpSpPr>
+      <p:sp>
+        <p:nvSpPr>
+          <p:cNvPr id="2" name="Text 0"/>
+          <p:cNvSpPr/>
+          <p:nvPr/>
+        </p:nvSpPr>
+        <p:spPr>
+          <a:xfrm>
+            <a:off x="640080" y="1097280"/>
+            <a:ext cx="10058400" cy="274320"/>
+          </a:xfrm>
+          <a:prstGeom prst="rect">
+            <a:avLst/>
+          </a:prstGeom>
+          <a:noFill/>
+          <a:ln/>
+        </p:spPr>
+        <p:txBody>
+          <a:bodyPr wrap="square" rtlCol="0" anchor="ctr"/>
+          <a:lstStyle/>
+          <a:p>
+            <a:pPr indent="0" marL="0">
+              <a:buNone/>
+            </a:pPr>
+            <a:r>
+              <a:rPr lang="en-US" sz="1200" spc="200" kern="0" dirty="0">
+                <a:solidFill>
+                  <a:srgbClr val="5EEAD4"/>
+                </a:solidFill>
+                <a:latin typeface="Consolas" pitchFamily="34" charset="0"/>
+                <a:ea typeface="Consolas" pitchFamily="34" charset="-122"/>
+                <a:cs typeface="Consolas" pitchFamily="34" charset="-120"/>
+              </a:rPr>
+              <a:t>WHAT THIS DEMONSTRATES</a:t>
+            </a:r>
+            <a:endParaRPr lang="en-US" sz="1200" dirty="0"/>
+          </a:p>
+        </p:txBody>
+      </p:sp>
+      <p:sp>
+        <p:nvSpPr>
+          <p:cNvPr id="3" name="Shape 1"/>
+          <p:cNvSpPr/>
+          <p:nvPr/>
+        </p:nvSpPr>
+        <p:spPr>
+          <a:xfrm>
+            <a:off x="640080" y="1691640"/>
+            <a:ext cx="109728" cy="914400"/>
+          </a:xfrm>
+          <a:prstGeom prst="roundRect">
+            <a:avLst>
+              <a:gd name="adj" fmla="val 50000"/>
+            </a:avLst>
+          </a:prstGeom>
+          <a:solidFill>
+            <a:srgbClr val="5EEAD4"/>
+          </a:solidFill>
+          <a:ln/>
+        </p:spPr>
+      </p:sp>
+      <p:sp>
+        <p:nvSpPr>
+          <p:cNvPr id="4" name="Text 2"/>
+          <p:cNvSpPr/>
+          <p:nvPr/>
+        </p:nvSpPr>
+        <p:spPr>
+          <a:xfrm>
+            <a:off x="1005840" y="1709928"/>
+            <a:ext cx="3657600" cy="411480"/>
+          </a:xfrm>
+          <a:prstGeom prst="rect">
+            <a:avLst/>
+          </a:prstGeom>
+          <a:noFill/>
+          <a:ln/>
+        </p:spPr>
+        <p:txBody>
+          <a:bodyPr wrap="square" rtlCol="0" anchor="ctr"/>
+          <a:lstStyle/>
+          <a:p>
+            <a:pPr indent="0" marL="0">
+              <a:buNone/>
+            </a:pPr>
+            <a:r>
+              <a:rPr lang="en-US" sz="2100" b="1" dirty="0">
+                <a:solidFill>
+                  <a:srgbClr val="E6EDF3"/>
+                </a:solidFill>
+                <a:latin typeface="Georgia" pitchFamily="34" charset="0"/>
+                <a:ea typeface="Georgia" pitchFamily="34" charset="-122"/>
+                <a:cs typeface="Georgia" pitchFamily="34" charset="-120"/>
+              </a:rPr>
+              <a:t>AI automation</a:t>
+            </a:r>
+            <a:endParaRPr lang="en-US" sz="2100" dirty="0"/>
+          </a:p>
+        </p:txBody>
+      </p:sp>
+      <p:sp>
+        <p:nvSpPr>
+          <p:cNvPr id="5" name="Text 3"/>
+          <p:cNvSpPr/>
+          <p:nvPr/>
+        </p:nvSpPr>
+        <p:spPr>
+          <a:xfrm>
+            <a:off x="1005840" y="2148840"/>
+            <a:ext cx="9601200" cy="548640"/>
+          </a:xfrm>
+          <a:prstGeom prst="rect">
+            <a:avLst/>
+          </a:prstGeom>
+          <a:noFill/>
+          <a:ln/>
+        </p:spPr>
+        <p:txBody>
+          <a:bodyPr wrap="square" rtlCol="0" anchor="ctr"/>
+          <a:lstStyle/>
+          <a:p>
+            <a:pPr indent="0" marL="0">
+              <a:buNone/>
+            </a:pPr>
+            <a:r>
+              <a:rPr lang="en-US" sz="1500" dirty="0">
+                <a:solidFill>
+                  <a:srgbClr val="9AA7B4"/>
+                </a:solidFill>
+                <a:latin typeface="Calibri" pitchFamily="34" charset="0"/>
+                <a:ea typeface="Calibri" pitchFamily="34" charset="-122"/>
+                <a:cs typeface="Calibri" pitchFamily="34" charset="-120"/>
+              </a:rPr>
+              <a:t>14 event-driven services, idempotent, rate-limited, running unattended in production.</a:t>
+            </a:r>
+            <a:endParaRPr lang="en-US" sz="1500" dirty="0"/>
+          </a:p>
+        </p:txBody>
+      </p:sp>
+      <p:sp>
+        <p:nvSpPr>
+          <p:cNvPr id="6" name="Shape 4"/>
+          <p:cNvSpPr/>
+          <p:nvPr/>
+        </p:nvSpPr>
+        <p:spPr>
+          <a:xfrm>
+            <a:off x="640080" y="2834640"/>
+            <a:ext cx="109728" cy="914400"/>
+          </a:xfrm>
+          <a:prstGeom prst="roundRect">
+            <a:avLst>
+              <a:gd name="adj" fmla="val 50000"/>
+            </a:avLst>
+          </a:prstGeom>
+          <a:solidFill>
+            <a:srgbClr val="5EEAD4"/>
+          </a:solidFill>
+          <a:ln/>
+        </p:spPr>
+      </p:sp>
+      <p:sp>
+        <p:nvSpPr>
+          <p:cNvPr id="7" name="Text 5"/>
+          <p:cNvSpPr/>
+          <p:nvPr/>
+        </p:nvSpPr>
+        <p:spPr>
+          <a:xfrm>
+            <a:off x="1005840" y="2852928"/>
+            <a:ext cx="3657600" cy="411480"/>
+          </a:xfrm>
+          <a:prstGeom prst="rect">
+            <a:avLst/>
+          </a:prstGeom>
+          <a:noFill/>
+          <a:ln/>
+        </p:spPr>
+        <p:txBody>
+          <a:bodyPr wrap="square" rtlCol="0" anchor="ctr"/>
+          <a:lstStyle/>
+          <a:p>
+            <a:pPr indent="0" marL="0">
+              <a:buNone/>
+            </a:pPr>
+            <a:r>
+              <a:rPr lang="en-US" sz="2100" b="1" dirty="0">
+                <a:solidFill>
+                  <a:srgbClr val="E6EDF3"/>
+                </a:solidFill>
+                <a:latin typeface="Georgia" pitchFamily="34" charset="0"/>
+                <a:ea typeface="Georgia" pitchFamily="34" charset="-122"/>
+                <a:cs typeface="Georgia" pitchFamily="34" charset="-120"/>
+              </a:rPr>
+              <a:t>Technical writing</a:t>
+            </a:r>
+            <a:endParaRPr lang="en-US" sz="2100" dirty="0"/>
+          </a:p>
+        </p:txBody>
+      </p:sp>
+      <p:sp>
+        <p:nvSpPr>
+          <p:cNvPr id="8" name="Text 6"/>
+          <p:cNvSpPr/>
+          <p:nvPr/>
+        </p:nvSpPr>
+        <p:spPr>
+          <a:xfrm>
+            <a:off x="1005840" y="3291840"/>
+            <a:ext cx="9601200" cy="548640"/>
+          </a:xfrm>
+          <a:prstGeom prst="rect">
+            <a:avLst/>
+          </a:prstGeom>
+          <a:noFill/>
+          <a:ln/>
+        </p:spPr>
+        <p:txBody>
+          <a:bodyPr wrap="square" rtlCol="0" anchor="ctr"/>
+          <a:lstStyle/>
+          <a:p>
+            <a:pPr indent="0" marL="0">
+              <a:buNone/>
+            </a:pPr>
+            <a:r>
+              <a:rPr lang="en-US" sz="1500" dirty="0">
+                <a:solidFill>
+                  <a:srgbClr val="9AA7B4"/>
+                </a:solidFill>
+                <a:latin typeface="Calibri" pitchFamily="34" charset="0"/>
+                <a:ea typeface="Calibri" pitchFamily="34" charset="-122"/>
+                <a:cs typeface="Calibri" pitchFamily="34" charset="-120"/>
+              </a:rPr>
+              <a:t>Audience-layered operational handbooks, failure-first troubleshooting, this case study.</a:t>
+            </a:r>
+            <a:endParaRPr lang="en-US" sz="1500" dirty="0"/>
+          </a:p>
+        </p:txBody>
+      </p:sp>
+      <p:sp>
+        <p:nvSpPr>
+          <p:cNvPr id="9" name="Shape 7"/>
+          <p:cNvSpPr/>
+          <p:nvPr/>
+        </p:nvSpPr>
+        <p:spPr>
+          <a:xfrm>
+            <a:off x="640080" y="3977640"/>
+            <a:ext cx="109728" cy="914400"/>
+          </a:xfrm>
+          <a:prstGeom prst="roundRect">
+            <a:avLst>
+              <a:gd name="adj" fmla="val 50000"/>
+            </a:avLst>
+          </a:prstGeom>
+          <a:solidFill>
+            <a:srgbClr val="5EEAD4"/>
+          </a:solidFill>
+          <a:ln/>
+        </p:spPr>
+      </p:sp>
+      <p:sp>
+        <p:nvSpPr>
+          <p:cNvPr id="10" name="Text 8"/>
+          <p:cNvSpPr/>
+          <p:nvPr/>
+        </p:nvSpPr>
+        <p:spPr>
+          <a:xfrm>
+            <a:off x="1005840" y="3995928"/>
+            <a:ext cx="3657600" cy="411480"/>
+          </a:xfrm>
+          <a:prstGeom prst="rect">
+            <a:avLst/>
+          </a:prstGeom>
+          <a:noFill/>
+          <a:ln/>
+        </p:spPr>
+        <p:txBody>
+          <a:bodyPr wrap="square" rtlCol="0" anchor="ctr"/>
+          <a:lstStyle/>
+          <a:p>
+            <a:pPr indent="0" marL="0">
+              <a:buNone/>
+            </a:pPr>
+            <a:r>
+              <a:rPr lang="en-US" sz="2100" b="1" dirty="0">
+                <a:solidFill>
+                  <a:srgbClr val="E6EDF3"/>
+                </a:solidFill>
+                <a:latin typeface="Georgia" pitchFamily="34" charset="0"/>
+                <a:ea typeface="Georgia" pitchFamily="34" charset="-122"/>
+                <a:cs typeface="Georgia" pitchFamily="34" charset="-120"/>
+              </a:rPr>
+              <a:t>Cost-aware AI</a:t>
+            </a:r>
+            <a:endParaRPr lang="en-US" sz="2100" dirty="0"/>
+          </a:p>
+        </p:txBody>
+      </p:sp>
+      <p:sp>
+        <p:nvSpPr>
+          <p:cNvPr id="11" name="Text 9"/>
+          <p:cNvSpPr/>
+          <p:nvPr/>
+        </p:nvSpPr>
+        <p:spPr>
+          <a:xfrm>
+            <a:off x="1005840" y="4434840"/>
+            <a:ext cx="9601200" cy="548640"/>
+          </a:xfrm>
+          <a:prstGeom prst="rect">
+            <a:avLst/>
+          </a:prstGeom>
+          <a:noFill/>
+          <a:ln/>
+        </p:spPr>
+        <p:txBody>
+          <a:bodyPr wrap="square" rtlCol="0" anchor="ctr"/>
+          <a:lstStyle/>
+          <a:p>
+            <a:pPr indent="0" marL="0">
+              <a:buNone/>
+            </a:pPr>
+            <a:r>
+              <a:rPr lang="en-US" sz="1500" dirty="0">
+                <a:solidFill>
+                  <a:srgbClr val="9AA7B4"/>
+                </a:solidFill>
+                <a:latin typeface="Calibri" pitchFamily="34" charset="0"/>
+                <a:ea typeface="Calibri" pitchFamily="34" charset="-122"/>
+                <a:cs typeface="Calibri" pitchFamily="34" charset="-120"/>
+              </a:rPr>
+              <a:t>DeepSeek on judgment-heavy steps, regex everywhere else. No wasted tokens.</a:t>
+            </a:r>
+            <a:endParaRPr lang="en-US" sz="1500" dirty="0"/>
+          </a:p>
+        </p:txBody>
+      </p:sp>
+      <p:sp>
+        <p:nvSpPr>
+          <p:cNvPr id="12" name="Text 10"/>
+          <p:cNvSpPr/>
+          <p:nvPr/>
+        </p:nvSpPr>
+        <p:spPr>
+          <a:xfrm>
+            <a:off x="640080" y="5486400"/>
+            <a:ext cx="6400800" cy="457200"/>
+          </a:xfrm>
+          <a:prstGeom prst="rect">
+            <a:avLst/>
+          </a:prstGeom>
+          <a:noFill/>
+          <a:ln/>
+        </p:spPr>
+        <p:txBody>
+          <a:bodyPr wrap="square" rtlCol="0" anchor="ctr"/>
+          <a:lstStyle/>
+          <a:p>
+            <a:pPr indent="0" marL="0">
+              <a:buNone/>
+            </a:pPr>
+            <a:r>
+              <a:rPr lang="en-US" sz="2200" b="1" dirty="0">
+                <a:solidFill>
+                  <a:srgbClr val="E6EDF3"/>
+                </a:solidFill>
+                <a:latin typeface="Georgia" pitchFamily="34" charset="0"/>
+                <a:ea typeface="Georgia" pitchFamily="34" charset="-122"/>
+                <a:cs typeface="Georgia" pitchFamily="34" charset="-120"/>
+              </a:rPr>
+              <a:t>Wessam Mandour</a:t>
+            </a:r>
+            <a:endParaRPr lang="en-US" sz="2200" dirty="0"/>
+          </a:p>
+        </p:txBody>
+      </p:sp>
+      <p:sp>
+        <p:nvSpPr>
+          <p:cNvPr id="13" name="Text 11"/>
+          <p:cNvSpPr/>
+          <p:nvPr/>
+        </p:nvSpPr>
+        <p:spPr>
+          <a:xfrm>
+            <a:off x="640080" y="5989320"/>
+            <a:ext cx="10972800" cy="365760"/>
+          </a:xfrm>
+          <a:prstGeom prst="rect">
+            <a:avLst/>
+          </a:prstGeom>
+          <a:noFill/>
+          <a:ln/>
+        </p:spPr>
+        <p:txBody>
+          <a:bodyPr wrap="square" rtlCol="0" anchor="ctr"/>
+          <a:lstStyle/>
+          <a:p>
+            <a:pPr indent="0" marL="0">
+              <a:buNone/>
+            </a:pPr>
+            <a:r>
+              <a:rPr lang="en-US" sz="1300" dirty="0">
+                <a:solidFill>
+                  <a:srgbClr val="9AA7B4"/>
+                </a:solidFill>
+                <a:latin typeface="Consolas" pitchFamily="34" charset="0"/>
+                <a:ea typeface="Consolas" pitchFamily="34" charset="-122"/>
+                <a:cs typeface="Consolas" pitchFamily="34" charset="-120"/>
+              </a:rPr>
+              <a:t>wessam.mandour94@gmail.com   ·   linkedin.com/in/wessam-mandour   ·   github.com/Wessam-Mandour</a:t>
+            </a:r>
+            <a:endParaRPr lang="en-US" sz="1300" dirty="0"/>
+          </a:p>
+        </p:txBody>
+      </p:sp>
+    </p:spTree>
+  </p:cSld>
+  <p:clrMapOvr>
+    <a:masterClrMapping/>
+  </p:clrMapOvr>
+</p:sld>
+</file>
+
 <file path=ppt/slides/slide2.xml><?xml version="1.0" encoding="utf-8"?>
 <p:sld xmlns:a="http://schemas.openxmlformats.org/drawingml/2006/main" xmlns:r="http://schemas.openxmlformats.org/officeDocument/2006/relationships" xmlns:p="http://schemas.openxmlformats.org/presentationml/2006/main">
   <p:cSld name="Slide 2">
@@ -2925,7 +3463,7 @@
                 <a:ea typeface="Calibri" pitchFamily="34" charset="-122"/>
                 <a:cs typeface="Calibri" pitchFamily="34" charset="-120"/>
               </a:rPr>
-              <a:t>2,000+ WhatsApp messages and emails a day (Twilio + Postmark), transcript scoring, and a CV parser that finishes in under a minute.</a:t>
+              <a:t>Webhook-triggered automations (CV parse, transcript scoring) plus cron-scheduled reminder sweeps. 2,000+ WhatsApp and email a day; CV parsed in under a minute.</a:t>
             </a:r>
             <a:endParaRPr lang="en-US" sz="1400" dirty="0"/>
           </a:p>
@@ -3384,7 +3922,7 @@
                 <a:ea typeface="Calibri" pitchFamily="34" charset="-122"/>
                 <a:cs typeface="Calibri" pitchFamily="34" charset="-120"/>
               </a:rPr>
-              <a:t>Deployed on Railway, triggered by webhooks, runs unattended, with Slack status to the whole team.</a:t>
+              <a:t>Deployed on Railway, triggered by webhooks and cron schedules, with Slack status to the whole team.</a:t>
             </a:r>
             <a:endParaRPr lang="en-US" sz="1300" dirty="0"/>
           </a:p>
@@ -6730,7 +7268,7 @@
                 <a:ea typeface="Consolas" pitchFamily="34" charset="-122"/>
                 <a:cs typeface="Consolas" pitchFamily="34" charset="-120"/>
               </a:rPr>
-              <a:t>TECHNICAL WRITING</a:t>
+              <a:t>CONFIGURABLE BY DESIGN</a:t>
             </a:r>
             <a:endParaRPr lang="en-US" sz="1100" dirty="0"/>
           </a:p>
@@ -6769,7 +7307,7 @@
                 <a:ea typeface="Georgia" pitchFamily="34" charset="-122"/>
                 <a:cs typeface="Georgia" pitchFamily="34" charset="-120"/>
               </a:rPr>
-              <a:t>The documentation is part of the deliverable</a:t>
+              <a:t>One codebase, many deployments, zero forks</a:t>
             </a:r>
             <a:endParaRPr lang="en-US" sz="3400" dirty="0"/>
           </a:p>
@@ -6783,8 +7321,8 @@
         </p:nvSpPr>
         <p:spPr>
           <a:xfrm>
-            <a:off x="640080" y="1691640"/>
-            <a:ext cx="4937760" cy="914400"/>
+            <a:off x="640080" y="1645920"/>
+            <a:ext cx="10881360" cy="640080"/>
           </a:xfrm>
           <a:prstGeom prst="rect">
             <a:avLst/>
@@ -6800,7 +7338,7 @@
               <a:buNone/>
             </a:pPr>
             <a:r>
-              <a:rPr lang="en-US" sz="1600" dirty="0">
+              <a:rPr lang="en-US" sz="1500" i="1" dirty="0">
                 <a:solidFill>
                   <a:srgbClr val="9AA7B4"/>
                 </a:solidFill>
@@ -6808,9 +7346,9 @@
                 <a:ea typeface="Calibri" pitchFamily="34" charset="-122"/>
                 <a:cs typeface="Calibri" pitchFamily="34" charset="-120"/>
               </a:rPr>
-              <a:t>Every service ships an operational handbook. For a system that runs unattended, the docs are the reliability layer.</a:t>
-            </a:r>
-            <a:endParaRPr lang="en-US" sz="1600" dirty="0"/>
+              <a:t>Nothing is hard-coded per client. Behavior is driven entirely by environment variables, so the same service is deployed many times, each tuned to a different goal, by changing config and redeploying.</a:t>
+            </a:r>
+            <a:endParaRPr lang="en-US" sz="1500" dirty="0"/>
           </a:p>
         </p:txBody>
       </p:sp>
@@ -6822,16 +7360,16 @@
         </p:nvSpPr>
         <p:spPr>
           <a:xfrm>
-            <a:off x="640080" y="2788920"/>
-            <a:ext cx="5029200" cy="914400"/>
+            <a:off x="640080" y="2468880"/>
+            <a:ext cx="3383280" cy="2468880"/>
           </a:xfrm>
           <a:prstGeom prst="roundRect">
             <a:avLst>
-              <a:gd name="adj" fmla="val 8000"/>
+              <a:gd name="adj" fmla="val 2963"/>
             </a:avLst>
           </a:prstGeom>
           <a:solidFill>
-            <a:srgbClr val="161B22"/>
+            <a:srgbClr val="1C2330"/>
           </a:solidFill>
           <a:ln w="12700">
             <a:solidFill>
@@ -6849,8 +7387,8 @@
         </p:nvSpPr>
         <p:spPr>
           <a:xfrm>
-            <a:off x="914400" y="2907792"/>
-            <a:ext cx="4572000" cy="320040"/>
+            <a:off x="914400" y="2743200"/>
+            <a:ext cx="2834640" cy="640080"/>
           </a:xfrm>
           <a:prstGeom prst="rect">
             <a:avLst/>
@@ -6866,7 +7404,7 @@
               <a:buNone/>
             </a:pPr>
             <a:r>
-              <a:rPr lang="en-US" sz="1500" b="1" dirty="0">
+              <a:rPr lang="en-US" sz="1600" b="1" dirty="0">
                 <a:solidFill>
                   <a:srgbClr val="5EEAD4"/>
                 </a:solidFill>
@@ -6874,9 +7412,9 @@
                 <a:ea typeface="Georgia" pitchFamily="34" charset="-122"/>
                 <a:cs typeface="Georgia" pitchFamily="34" charset="-120"/>
               </a:rPr>
-              <a:t>Audience-layered</a:t>
-            </a:r>
-            <a:endParaRPr lang="en-US" sz="1500" dirty="0"/>
+              <a:t>Same engine, Flash or Pro</a:t>
+            </a:r>
+            <a:endParaRPr lang="en-US" sz="1600" dirty="0"/>
           </a:p>
         </p:txBody>
       </p:sp>
@@ -6888,8 +7426,8 @@
         </p:nvSpPr>
         <p:spPr>
           <a:xfrm>
-            <a:off x="914400" y="3246120"/>
-            <a:ext cx="4572000" cy="411480"/>
+            <a:off x="914400" y="3429000"/>
+            <a:ext cx="2834640" cy="1371600"/>
           </a:xfrm>
           <a:prstGeom prst="rect">
             <a:avLst/>
@@ -6905,7 +7443,7 @@
               <a:buNone/>
             </a:pPr>
             <a:r>
-              <a:rPr lang="en-US" sz="1250" dirty="0">
+              <a:rPr lang="en-US" sz="1300" dirty="0">
                 <a:solidFill>
                   <a:srgbClr val="9AA7B4"/>
                 </a:solidFill>
@@ -6913,9 +7451,9 @@
                 <a:ea typeface="Calibri" pitchFamily="34" charset="-122"/>
                 <a:cs typeface="Calibri" pitchFamily="34" charset="-120"/>
               </a:rPr>
-              <a:t>One-table overview for managers, branch-level depth for developers, same doc.</a:t>
-            </a:r>
-            <a:endParaRPr lang="en-US" sz="1250" dirty="0"/>
+              <a:t>One codebase, two deployments: DeepSeek Flash for speed and cost, DeepSeek Pro for tougher roles. A single env var picks the model.</a:t>
+            </a:r>
+            <a:endParaRPr lang="en-US" sz="1300" dirty="0"/>
           </a:p>
         </p:txBody>
       </p:sp>
@@ -6927,16 +7465,16 @@
         </p:nvSpPr>
         <p:spPr>
           <a:xfrm>
-            <a:off x="640080" y="3840480"/>
-            <a:ext cx="5029200" cy="914400"/>
+            <a:off x="4279392" y="2468880"/>
+            <a:ext cx="3383280" cy="2468880"/>
           </a:xfrm>
           <a:prstGeom prst="roundRect">
             <a:avLst>
-              <a:gd name="adj" fmla="val 8000"/>
+              <a:gd name="adj" fmla="val 2963"/>
             </a:avLst>
           </a:prstGeom>
           <a:solidFill>
-            <a:srgbClr val="161B22"/>
+            <a:srgbClr val="1C2330"/>
           </a:solidFill>
           <a:ln w="12700">
             <a:solidFill>
@@ -6954,8 +7492,8 @@
         </p:nvSpPr>
         <p:spPr>
           <a:xfrm>
-            <a:off x="914400" y="3959352"/>
-            <a:ext cx="4572000" cy="320040"/>
+            <a:off x="4553712" y="2743200"/>
+            <a:ext cx="2834640" cy="640080"/>
           </a:xfrm>
           <a:prstGeom prst="rect">
             <a:avLst/>
@@ -6971,7 +7509,7 @@
               <a:buNone/>
             </a:pPr>
             <a:r>
-              <a:rPr lang="en-US" sz="1500" b="1" dirty="0">
+              <a:rPr lang="en-US" sz="1600" b="1" dirty="0">
                 <a:solidFill>
                   <a:srgbClr val="5EEAD4"/>
                 </a:solidFill>
@@ -6979,9 +7517,9 @@
                 <a:ea typeface="Georgia" pitchFamily="34" charset="-122"/>
                 <a:cs typeface="Georgia" pitchFamily="34" charset="-120"/>
               </a:rPr>
-              <a:t>Operational</a:t>
-            </a:r>
-            <a:endParaRPr lang="en-US" sz="1500" dirty="0"/>
+              <a:t>One reminder, deployed 3×</a:t>
+            </a:r>
+            <a:endParaRPr lang="en-US" sz="1600" dirty="0"/>
           </a:p>
         </p:txBody>
       </p:sp>
@@ -6993,8 +7531,8 @@
         </p:nvSpPr>
         <p:spPr>
           <a:xfrm>
-            <a:off x="914400" y="4297680"/>
-            <a:ext cx="4572000" cy="411480"/>
+            <a:off x="4553712" y="3429000"/>
+            <a:ext cx="2834640" cy="1371600"/>
           </a:xfrm>
           <a:prstGeom prst="rect">
             <a:avLst/>
@@ -7010,7 +7548,7 @@
               <a:buNone/>
             </a:pPr>
             <a:r>
-              <a:rPr lang="en-US" sz="1250" dirty="0">
+              <a:rPr lang="en-US" sz="1300" dirty="0">
                 <a:solidFill>
                   <a:srgbClr val="9AA7B4"/>
                 </a:solidFill>
@@ -7018,9 +7556,9 @@
                 <a:ea typeface="Calibri" pitchFamily="34" charset="-122"/>
                 <a:cs typeface="Calibri" pitchFamily="34" charset="-120"/>
               </a:rPr>
-              <a:t>Documents which log line proves which behavior: debug by grep, not by reading source.</a:t>
-            </a:r>
-            <a:endParaRPr lang="en-US" sz="1250" dirty="0"/>
+              <a:t>The WhatsApp reminder service runs three times, each with a different "hours since submission" threshold, for a staggered reminder sequence.</a:t>
+            </a:r>
+            <a:endParaRPr lang="en-US" sz="1300" dirty="0"/>
           </a:p>
         </p:txBody>
       </p:sp>
@@ -7032,16 +7570,16 @@
         </p:nvSpPr>
         <p:spPr>
           <a:xfrm>
-            <a:off x="640080" y="4892040"/>
-            <a:ext cx="5029200" cy="914400"/>
+            <a:off x="7918704" y="2468880"/>
+            <a:ext cx="3383280" cy="2468880"/>
           </a:xfrm>
           <a:prstGeom prst="roundRect">
             <a:avLst>
-              <a:gd name="adj" fmla="val 8000"/>
+              <a:gd name="adj" fmla="val 2963"/>
             </a:avLst>
           </a:prstGeom>
           <a:solidFill>
-            <a:srgbClr val="161B22"/>
+            <a:srgbClr val="1C2330"/>
           </a:solidFill>
           <a:ln w="12700">
             <a:solidFill>
@@ -7059,8 +7597,8 @@
         </p:nvSpPr>
         <p:spPr>
           <a:xfrm>
-            <a:off x="914400" y="5010912"/>
-            <a:ext cx="4572000" cy="320040"/>
+            <a:off x="8193024" y="2743200"/>
+            <a:ext cx="2834640" cy="640080"/>
           </a:xfrm>
           <a:prstGeom prst="rect">
             <a:avLst/>
@@ -7076,7 +7614,7 @@
               <a:buNone/>
             </a:pPr>
             <a:r>
-              <a:rPr lang="en-US" sz="1500" b="1" dirty="0">
+              <a:rPr lang="en-US" sz="1600" b="1" dirty="0">
                 <a:solidFill>
                   <a:srgbClr val="5EEAD4"/>
                 </a:solidFill>
@@ -7084,9 +7622,9 @@
                 <a:ea typeface="Georgia" pitchFamily="34" charset="-122"/>
                 <a:cs typeface="Georgia" pitchFamily="34" charset="-120"/>
               </a:rPr>
-              <a:t>Failure-first</a:t>
-            </a:r>
-            <a:endParaRPr lang="en-US" sz="1500" dirty="0"/>
+              <a:t>Same code, new database</a:t>
+            </a:r>
+            <a:endParaRPr lang="en-US" sz="1600" dirty="0"/>
           </a:p>
         </p:txBody>
       </p:sp>
@@ -7098,8 +7636,8 @@
         </p:nvSpPr>
         <p:spPr>
           <a:xfrm>
-            <a:off x="914400" y="5349240"/>
-            <a:ext cx="4572000" cy="411480"/>
+            <a:off x="8193024" y="3429000"/>
+            <a:ext cx="2834640" cy="1371600"/>
           </a:xfrm>
           <a:prstGeom prst="rect">
             <a:avLst/>
@@ -7115,7 +7653,7 @@
               <a:buNone/>
             </a:pPr>
             <a:r>
-              <a:rPr lang="en-US" sz="1250" dirty="0">
+              <a:rPr lang="en-US" sz="1300" dirty="0">
                 <a:solidFill>
                   <a:srgbClr val="9AA7B4"/>
                 </a:solidFill>
@@ -7123,309 +7661,48 @@
                 <a:ea typeface="Calibri" pitchFamily="34" charset="-122"/>
                 <a:cs typeface="Calibri" pitchFamily="34" charset="-120"/>
               </a:rPr>
-              <a:t>Maps real symptoms to the exact gate that caused them.</a:t>
-            </a:r>
-            <a:endParaRPr lang="en-US" sz="1250" dirty="0"/>
-          </a:p>
-        </p:txBody>
-      </p:sp>
-      <p:sp>
-        <p:nvSpPr>
-          <p:cNvPr id="14" name="Shape 12"/>
-          <p:cNvSpPr/>
-          <p:nvPr/>
-        </p:nvSpPr>
-        <p:spPr>
-          <a:xfrm>
-            <a:off x="6035040" y="1691640"/>
-            <a:ext cx="5532120" cy="4480560"/>
-          </a:xfrm>
-          <a:prstGeom prst="roundRect">
-            <a:avLst>
-              <a:gd name="adj" fmla="val 1633"/>
-            </a:avLst>
-          </a:prstGeom>
-          <a:solidFill>
-            <a:srgbClr val="0A0E14"/>
-          </a:solidFill>
-          <a:ln w="12700">
-            <a:solidFill>
-              <a:srgbClr val="2A3240"/>
-            </a:solidFill>
-            <a:prstDash val="solid"/>
-          </a:ln>
-        </p:spPr>
-      </p:sp>
-      <p:sp>
-        <p:nvSpPr>
-          <p:cNvPr id="15" name="Shape 13"/>
-          <p:cNvSpPr/>
-          <p:nvPr/>
-        </p:nvSpPr>
-        <p:spPr>
-          <a:xfrm>
-            <a:off x="6309360" y="1920240"/>
-            <a:ext cx="146304" cy="146304"/>
-          </a:xfrm>
-          <a:prstGeom prst="ellipse">
-            <a:avLst/>
-          </a:prstGeom>
-          <a:solidFill>
-            <a:srgbClr val="E06C75"/>
-          </a:solidFill>
-          <a:ln/>
-        </p:spPr>
-      </p:sp>
-      <p:sp>
-        <p:nvSpPr>
-          <p:cNvPr id="16" name="Shape 14"/>
-          <p:cNvSpPr/>
-          <p:nvPr/>
-        </p:nvSpPr>
-        <p:spPr>
-          <a:xfrm>
-            <a:off x="6601968" y="1920240"/>
-            <a:ext cx="146304" cy="146304"/>
-          </a:xfrm>
-          <a:prstGeom prst="ellipse">
-            <a:avLst/>
-          </a:prstGeom>
-          <a:solidFill>
-            <a:srgbClr val="E5C07B"/>
-          </a:solidFill>
-          <a:ln/>
-        </p:spPr>
-      </p:sp>
-      <p:sp>
-        <p:nvSpPr>
-          <p:cNvPr id="17" name="Shape 15"/>
-          <p:cNvSpPr/>
-          <p:nvPr/>
-        </p:nvSpPr>
-        <p:spPr>
-          <a:xfrm>
-            <a:off x="6894576" y="1920240"/>
-            <a:ext cx="146304" cy="146304"/>
-          </a:xfrm>
-          <a:prstGeom prst="ellipse">
-            <a:avLst/>
-          </a:prstGeom>
-          <a:solidFill>
-            <a:srgbClr val="98C379"/>
-          </a:solidFill>
-          <a:ln/>
-        </p:spPr>
-      </p:sp>
-      <p:sp>
-        <p:nvSpPr>
-          <p:cNvPr id="18" name="Text 16"/>
-          <p:cNvSpPr/>
-          <p:nvPr/>
-        </p:nvSpPr>
-        <p:spPr>
-          <a:xfrm>
-            <a:off x="7315200" y="1874520"/>
-            <a:ext cx="3657600" cy="274320"/>
-          </a:xfrm>
-          <a:prstGeom prst="rect">
-            <a:avLst/>
-          </a:prstGeom>
-          <a:noFill/>
-          <a:ln/>
-        </p:spPr>
-        <p:txBody>
-          <a:bodyPr wrap="square" rtlCol="0" anchor="ctr"/>
-          <a:lstStyle/>
-          <a:p>
-            <a:pPr indent="0" marL="0">
-              <a:buNone/>
-            </a:pPr>
-            <a:r>
-              <a:rPr lang="en-US" sz="1100" dirty="0">
+              <a:t>Each branch points at a different Notion database in the same workspace via env vars. New database, new deploy, no code change.</a:t>
+            </a:r>
+            <a:endParaRPr lang="en-US" sz="1300" dirty="0"/>
+          </a:p>
+        </p:txBody>
+      </p:sp>
+      <p:sp>
+        <p:nvSpPr>
+          <p:cNvPr id="14" name="Text 12"/>
+          <p:cNvSpPr/>
+          <p:nvPr/>
+        </p:nvSpPr>
+        <p:spPr>
+          <a:xfrm>
+            <a:off x="640080" y="5257800"/>
+            <a:ext cx="10881360" cy="365760"/>
+          </a:xfrm>
+          <a:prstGeom prst="rect">
+            <a:avLst/>
+          </a:prstGeom>
+          <a:noFill/>
+          <a:ln/>
+        </p:spPr>
+        <p:txBody>
+          <a:bodyPr wrap="square" rtlCol="0" anchor="ctr"/>
+          <a:lstStyle/>
+          <a:p>
+            <a:pPr algn="ctr" indent="0" marL="0">
+              <a:buNone/>
+            </a:pPr>
+            <a:r>
+              <a:rPr lang="en-US" sz="1300" i="1" dirty="0">
                 <a:solidFill>
                   <a:srgbClr val="7D8896"/>
                 </a:solidFill>
-                <a:latin typeface="Consolas" pitchFamily="34" charset="0"/>
-                <a:ea typeface="Consolas" pitchFamily="34" charset="-122"/>
-                <a:cs typeface="Consolas" pitchFamily="34" charset="-120"/>
-              </a:rPr>
-              <a:t>troubleshooting.md</a:t>
-            </a:r>
-            <a:endParaRPr lang="en-US" sz="1100" dirty="0"/>
-          </a:p>
-        </p:txBody>
-      </p:sp>
-      <p:sp>
-        <p:nvSpPr>
-          <p:cNvPr id="19" name="Text 17"/>
-          <p:cNvSpPr/>
-          <p:nvPr/>
-        </p:nvSpPr>
-        <p:spPr>
-          <a:xfrm>
-            <a:off x="6355080" y="2331720"/>
-            <a:ext cx="4892040" cy="3657600"/>
-          </a:xfrm>
-          <a:prstGeom prst="rect">
-            <a:avLst/>
-          </a:prstGeom>
-          <a:noFill/>
-          <a:ln/>
-        </p:spPr>
-        <p:txBody>
-          <a:bodyPr wrap="square" rtlCol="0" anchor="t"/>
-          <a:lstStyle/>
-          <a:p>
-            <a:pPr indent="0" marL="0">
-              <a:lnSpc>
-                <a:spcPct val="115000"/>
-              </a:lnSpc>
-              <a:buNone/>
-            </a:pPr>
-            <a:r>
-              <a:rPr lang="en-US" sz="1200" dirty="0">
-                <a:solidFill>
-                  <a:srgbClr val="7D8896"/>
-                </a:solidFill>
-                <a:latin typeface="Consolas" pitchFamily="34" charset="0"/>
-                <a:ea typeface="Consolas" pitchFamily="34" charset="-122"/>
-                <a:cs typeface="Consolas" pitchFamily="34" charset="-120"/>
-              </a:rPr>
-              <a:t>## Troubleshooting
-</a:t>
-            </a:r>
-            <a:pPr indent="0" marL="0">
-              <a:lnSpc>
-                <a:spcPct val="115000"/>
-              </a:lnSpc>
-              <a:buNone/>
-            </a:pPr>
-            <a:r>
-              <a:rPr lang="en-US" sz="1200" b="1" dirty="0">
-                <a:solidFill>
-                  <a:srgbClr val="5EEAD4"/>
-                </a:solidFill>
-                <a:latin typeface="Consolas" pitchFamily="34" charset="0"/>
-                <a:ea typeface="Consolas" pitchFamily="34" charset="-122"/>
-                <a:cs typeface="Consolas" pitchFamily="34" charset="-120"/>
-              </a:rPr>
-              <a:t>Candidate not considered for a role, check, in order:
-</a:t>
-            </a:r>
-            <a:pPr indent="0" marL="0">
-              <a:lnSpc>
-                <a:spcPct val="115000"/>
-              </a:lnSpc>
-              <a:buNone/>
-            </a:pPr>
-            <a:r>
-              <a:rPr lang="en-US" sz="1200" dirty="0">
-                <a:solidFill>
-                  <a:srgbClr val="E6EDF3"/>
-                </a:solidFill>
-                <a:latin typeface="Consolas" pitchFamily="34" charset="0"/>
-                <a:ea typeface="Consolas" pitchFamily="34" charset="-122"/>
-                <a:cs typeface="Consolas" pitchFamily="34" charset="-120"/>
-              </a:rPr>
-              <a:t>  1. Stage-2 keyword overlap
-  2. Stage-3 hard filters (language, location, score)
-  3. existing scored row (already processed)
-  4. duplicate-email de-duplication
-</a:t>
-            </a:r>
-            <a:pPr indent="0" marL="0">
-              <a:lnSpc>
-                <a:spcPct val="115000"/>
-              </a:lnSpc>
-              <a:buNone/>
-            </a:pPr>
-            <a:r>
-              <a:rPr lang="en-US" sz="1200" b="1" dirty="0">
-                <a:solidFill>
-                  <a:srgbClr val="5EEAD4"/>
-                </a:solidFill>
-                <a:latin typeface="Consolas" pitchFamily="34" charset="0"/>
-                <a:ea typeface="Consolas" pitchFamily="34" charset="-122"/>
-                <a:cs typeface="Consolas" pitchFamily="34" charset="-120"/>
-              </a:rPr>
-              <a:t>Fewer qualified matches than target, expected:
-</a:t>
-            </a:r>
-            <a:pPr indent="0" marL="0">
-              <a:lnSpc>
-                <a:spcPct val="115000"/>
-              </a:lnSpc>
-              <a:buNone/>
-            </a:pPr>
-            <a:r>
-              <a:rPr lang="en-US" sz="1200" dirty="0">
-                <a:solidFill>
-                  <a:srgbClr val="E6EDF3"/>
-                </a:solidFill>
-                <a:latin typeface="Consolas" pitchFamily="34" charset="0"/>
-                <a:ea typeface="Consolas" pitchFamily="34" charset="-122"/>
-                <a:cs typeface="Consolas" pitchFamily="34" charset="-120"/>
-              </a:rPr>
-              <a:t>  Stage 6 backfills below-threshold by descending</a:t>
-            </a:r>
-            <a:endParaRPr lang="en-US" sz="1200" dirty="0"/>
-          </a:p>
-          <a:p>
-            <a:pPr indent="0" marL="0">
-              <a:lnSpc>
-                <a:spcPct val="115000"/>
-              </a:lnSpc>
-              <a:buNone/>
-            </a:pPr>
-            <a:r>
-              <a:rPr lang="en-US" sz="1200" dirty="0">
-                <a:solidFill>
-                  <a:srgbClr val="E6EDF3"/>
-                </a:solidFill>
-                <a:latin typeface="Consolas" pitchFamily="34" charset="0"/>
-                <a:ea typeface="Consolas" pitchFamily="34" charset="-122"/>
-                <a:cs typeface="Consolas" pitchFamily="34" charset="-120"/>
-              </a:rPr>
-              <a:t>  score and logs </a:t>
-            </a:r>
-            <a:endParaRPr lang="en-US" sz="1200" dirty="0"/>
-          </a:p>
-          <a:p>
-            <a:pPr indent="0" marL="0">
-              <a:lnSpc>
-                <a:spcPct val="115000"/>
-              </a:lnSpc>
-              <a:buNone/>
-            </a:pPr>
-            <a:r>
-              <a:rPr lang="en-US" sz="1200" dirty="0">
-                <a:solidFill>
-                  <a:srgbClr val="F0B86E"/>
-                </a:solidFill>
-                <a:latin typeface="Consolas" pitchFamily="34" charset="0"/>
-                <a:ea typeface="Consolas" pitchFamily="34" charset="-122"/>
-                <a:cs typeface="Consolas" pitchFamily="34" charset="-120"/>
-              </a:rPr>
-              <a:t>fallback_selected=true</a:t>
-            </a:r>
-            <a:pPr indent="0" marL="0">
-              <a:lnSpc>
-                <a:spcPct val="115000"/>
-              </a:lnSpc>
-              <a:buNone/>
-            </a:pPr>
-            <a:r>
-              <a:rPr lang="en-US" sz="1200" dirty="0">
-                <a:solidFill>
-                  <a:srgbClr val="E6EDF3"/>
-                </a:solidFill>
-                <a:latin typeface="Consolas" pitchFamily="34" charset="0"/>
-                <a:ea typeface="Consolas" pitchFamily="34" charset="-122"/>
-                <a:cs typeface="Consolas" pitchFamily="34" charset="-120"/>
-              </a:rPr>
-              <a:t> per row.</a:t>
-            </a:r>
-            <a:endParaRPr lang="en-US" sz="1200" dirty="0"/>
+                <a:latin typeface="Calibri" pitchFamily="34" charset="0"/>
+                <a:ea typeface="Calibri" pitchFamily="34" charset="-122"/>
+                <a:cs typeface="Calibri" pitchFamily="34" charset="-120"/>
+              </a:rPr>
+              <a:t>Every client need met by configuration, not custom code, so all deployments stay consistent and safe to change.</a:t>
+            </a:r>
+            <a:endParaRPr lang="en-US" sz="1300" dirty="0"/>
           </a:p>
         </p:txBody>
       </p:sp>
@@ -7494,7 +7771,7 @@
                 <a:ea typeface="Consolas" pitchFamily="34" charset="-122"/>
                 <a:cs typeface="Consolas" pitchFamily="34" charset="-120"/>
               </a:rPr>
-              <a:t>IMPACT</a:t>
+              <a:t>TECHNICAL WRITING</a:t>
             </a:r>
             <a:endParaRPr lang="en-US" sz="1100" dirty="0"/>
           </a:p>
@@ -7533,7 +7810,7 @@
                 <a:ea typeface="Georgia" pitchFamily="34" charset="-122"/>
                 <a:cs typeface="Georgia" pitchFamily="34" charset="-120"/>
               </a:rPr>
-              <a:t>What the automation delivers</a:t>
+              <a:t>The documentation is part of the deliverable</a:t>
             </a:r>
             <a:endParaRPr lang="en-US" sz="3400" dirty="0"/>
           </a:p>
@@ -7541,22 +7818,61 @@
       </p:sp>
       <p:sp>
         <p:nvSpPr>
-          <p:cNvPr id="4" name="Shape 2"/>
-          <p:cNvSpPr/>
-          <p:nvPr/>
-        </p:nvSpPr>
-        <p:spPr>
-          <a:xfrm>
-            <a:off x="640080" y="1920240"/>
-            <a:ext cx="5120640" cy="1737360"/>
+          <p:cNvPr id="4" name="Text 2"/>
+          <p:cNvSpPr/>
+          <p:nvPr/>
+        </p:nvSpPr>
+        <p:spPr>
+          <a:xfrm>
+            <a:off x="640080" y="1691640"/>
+            <a:ext cx="4937760" cy="914400"/>
+          </a:xfrm>
+          <a:prstGeom prst="rect">
+            <a:avLst/>
+          </a:prstGeom>
+          <a:noFill/>
+          <a:ln/>
+        </p:spPr>
+        <p:txBody>
+          <a:bodyPr wrap="square" rtlCol="0" anchor="ctr"/>
+          <a:lstStyle/>
+          <a:p>
+            <a:pPr indent="0" marL="0">
+              <a:buNone/>
+            </a:pPr>
+            <a:r>
+              <a:rPr lang="en-US" sz="1600" dirty="0">
+                <a:solidFill>
+                  <a:srgbClr val="9AA7B4"/>
+                </a:solidFill>
+                <a:latin typeface="Calibri" pitchFamily="34" charset="0"/>
+                <a:ea typeface="Calibri" pitchFamily="34" charset="-122"/>
+                <a:cs typeface="Calibri" pitchFamily="34" charset="-120"/>
+              </a:rPr>
+              <a:t>Every service ships an operational handbook. For a system that runs unattended, the docs are the reliability layer.</a:t>
+            </a:r>
+            <a:endParaRPr lang="en-US" sz="1600" dirty="0"/>
+          </a:p>
+        </p:txBody>
+      </p:sp>
+      <p:sp>
+        <p:nvSpPr>
+          <p:cNvPr id="5" name="Shape 3"/>
+          <p:cNvSpPr/>
+          <p:nvPr/>
+        </p:nvSpPr>
+        <p:spPr>
+          <a:xfrm>
+            <a:off x="640080" y="2788920"/>
+            <a:ext cx="5029200" cy="914400"/>
           </a:xfrm>
           <a:prstGeom prst="roundRect">
             <a:avLst>
-              <a:gd name="adj" fmla="val 4211"/>
+              <a:gd name="adj" fmla="val 8000"/>
             </a:avLst>
           </a:prstGeom>
           <a:solidFill>
-            <a:srgbClr val="1C2330"/>
+            <a:srgbClr val="161B22"/>
           </a:solidFill>
           <a:ln w="12700">
             <a:solidFill>
@@ -7568,14 +7884,14 @@
       </p:sp>
       <p:sp>
         <p:nvSpPr>
-          <p:cNvPr id="5" name="Text 3"/>
-          <p:cNvSpPr/>
-          <p:nvPr/>
-        </p:nvSpPr>
-        <p:spPr>
-          <a:xfrm>
-            <a:off x="1005840" y="2212848"/>
-            <a:ext cx="4572000" cy="822960"/>
+          <p:cNvPr id="6" name="Text 4"/>
+          <p:cNvSpPr/>
+          <p:nvPr/>
+        </p:nvSpPr>
+        <p:spPr>
+          <a:xfrm>
+            <a:off x="914400" y="2907792"/>
+            <a:ext cx="4572000" cy="320040"/>
           </a:xfrm>
           <a:prstGeom prst="rect">
             <a:avLst/>
@@ -7591,7 +7907,7 @@
               <a:buNone/>
             </a:pPr>
             <a:r>
-              <a:rPr lang="en-US" sz="3800" b="1" dirty="0">
+              <a:rPr lang="en-US" sz="1500" b="1" dirty="0">
                 <a:solidFill>
                   <a:srgbClr val="5EEAD4"/>
                 </a:solidFill>
@@ -7599,22 +7915,22 @@
                 <a:ea typeface="Georgia" pitchFamily="34" charset="-122"/>
                 <a:cs typeface="Georgia" pitchFamily="34" charset="-120"/>
               </a:rPr>
-              <a:t>40,000</a:t>
-            </a:r>
-            <a:endParaRPr lang="en-US" sz="3800" dirty="0"/>
-          </a:p>
-        </p:txBody>
-      </p:sp>
-      <p:sp>
-        <p:nvSpPr>
-          <p:cNvPr id="6" name="Text 4"/>
-          <p:cNvSpPr/>
-          <p:nvPr/>
-        </p:nvSpPr>
-        <p:spPr>
-          <a:xfrm>
-            <a:off x="1024128" y="3063240"/>
-            <a:ext cx="4526280" cy="457200"/>
+              <a:t>Audience-layered</a:t>
+            </a:r>
+            <a:endParaRPr lang="en-US" sz="1500" dirty="0"/>
+          </a:p>
+        </p:txBody>
+      </p:sp>
+      <p:sp>
+        <p:nvSpPr>
+          <p:cNvPr id="7" name="Text 5"/>
+          <p:cNvSpPr/>
+          <p:nvPr/>
+        </p:nvSpPr>
+        <p:spPr>
+          <a:xfrm>
+            <a:off x="914400" y="3246120"/>
+            <a:ext cx="4572000" cy="411480"/>
           </a:xfrm>
           <a:prstGeom prst="rect">
             <a:avLst/>
@@ -7630,7 +7946,7 @@
               <a:buNone/>
             </a:pPr>
             <a:r>
-              <a:rPr lang="en-US" sz="1400" dirty="0">
+              <a:rPr lang="en-US" sz="1250" dirty="0">
                 <a:solidFill>
                   <a:srgbClr val="9AA7B4"/>
                 </a:solidFill>
@@ -7638,30 +7954,30 @@
                 <a:ea typeface="Calibri" pitchFamily="34" charset="-122"/>
                 <a:cs typeface="Calibri" pitchFamily="34" charset="-120"/>
               </a:rPr>
-              <a:t>candidate rows scanned per matching run</a:t>
-            </a:r>
-            <a:endParaRPr lang="en-US" sz="1400" dirty="0"/>
-          </a:p>
-        </p:txBody>
-      </p:sp>
-      <p:sp>
-        <p:nvSpPr>
-          <p:cNvPr id="7" name="Shape 5"/>
-          <p:cNvSpPr/>
-          <p:nvPr/>
-        </p:nvSpPr>
-        <p:spPr>
-          <a:xfrm>
-            <a:off x="6080760" y="1920240"/>
-            <a:ext cx="5120640" cy="1737360"/>
+              <a:t>One-table overview for managers, branch-level depth for developers, same doc.</a:t>
+            </a:r>
+            <a:endParaRPr lang="en-US" sz="1250" dirty="0"/>
+          </a:p>
+        </p:txBody>
+      </p:sp>
+      <p:sp>
+        <p:nvSpPr>
+          <p:cNvPr id="8" name="Shape 6"/>
+          <p:cNvSpPr/>
+          <p:nvPr/>
+        </p:nvSpPr>
+        <p:spPr>
+          <a:xfrm>
+            <a:off x="640080" y="3840480"/>
+            <a:ext cx="5029200" cy="914400"/>
           </a:xfrm>
           <a:prstGeom prst="roundRect">
             <a:avLst>
-              <a:gd name="adj" fmla="val 4211"/>
+              <a:gd name="adj" fmla="val 8000"/>
             </a:avLst>
           </a:prstGeom>
           <a:solidFill>
-            <a:srgbClr val="1C2330"/>
+            <a:srgbClr val="161B22"/>
           </a:solidFill>
           <a:ln w="12700">
             <a:solidFill>
@@ -7673,14 +7989,14 @@
       </p:sp>
       <p:sp>
         <p:nvSpPr>
-          <p:cNvPr id="8" name="Text 6"/>
-          <p:cNvSpPr/>
-          <p:nvPr/>
-        </p:nvSpPr>
-        <p:spPr>
-          <a:xfrm>
-            <a:off x="6446520" y="2212848"/>
-            <a:ext cx="4572000" cy="822960"/>
+          <p:cNvPr id="9" name="Text 7"/>
+          <p:cNvSpPr/>
+          <p:nvPr/>
+        </p:nvSpPr>
+        <p:spPr>
+          <a:xfrm>
+            <a:off x="914400" y="3959352"/>
+            <a:ext cx="4572000" cy="320040"/>
           </a:xfrm>
           <a:prstGeom prst="rect">
             <a:avLst/>
@@ -7696,7 +8012,7 @@
               <a:buNone/>
             </a:pPr>
             <a:r>
-              <a:rPr lang="en-US" sz="3800" b="1" dirty="0">
+              <a:rPr lang="en-US" sz="1500" b="1" dirty="0">
                 <a:solidFill>
                   <a:srgbClr val="5EEAD4"/>
                 </a:solidFill>
@@ -7704,22 +8020,22 @@
                 <a:ea typeface="Georgia" pitchFamily="34" charset="-122"/>
                 <a:cs typeface="Georgia" pitchFamily="34" charset="-120"/>
               </a:rPr>
-              <a:t>90-120 min</a:t>
-            </a:r>
-            <a:endParaRPr lang="en-US" sz="3800" dirty="0"/>
-          </a:p>
-        </p:txBody>
-      </p:sp>
-      <p:sp>
-        <p:nvSpPr>
-          <p:cNvPr id="9" name="Text 7"/>
-          <p:cNvSpPr/>
-          <p:nvPr/>
-        </p:nvSpPr>
-        <p:spPr>
-          <a:xfrm>
-            <a:off x="6464808" y="3063240"/>
-            <a:ext cx="4526280" cy="457200"/>
+              <a:t>Operational</a:t>
+            </a:r>
+            <a:endParaRPr lang="en-US" sz="1500" dirty="0"/>
+          </a:p>
+        </p:txBody>
+      </p:sp>
+      <p:sp>
+        <p:nvSpPr>
+          <p:cNvPr id="10" name="Text 8"/>
+          <p:cNvSpPr/>
+          <p:nvPr/>
+        </p:nvSpPr>
+        <p:spPr>
+          <a:xfrm>
+            <a:off x="914400" y="4297680"/>
+            <a:ext cx="4572000" cy="411480"/>
           </a:xfrm>
           <a:prstGeom prst="rect">
             <a:avLst/>
@@ -7735,7 +8051,7 @@
               <a:buNone/>
             </a:pPr>
             <a:r>
-              <a:rPr lang="en-US" sz="1400" dirty="0">
+              <a:rPr lang="en-US" sz="1250" dirty="0">
                 <a:solidFill>
                   <a:srgbClr val="9AA7B4"/>
                 </a:solidFill>
@@ -7743,30 +8059,30 @@
                 <a:ea typeface="Calibri" pitchFamily="34" charset="-122"/>
                 <a:cs typeface="Calibri" pitchFamily="34" charset="-120"/>
               </a:rPr>
-              <a:t>full run on Railway, with Slack status</a:t>
-            </a:r>
-            <a:endParaRPr lang="en-US" sz="1400" dirty="0"/>
-          </a:p>
-        </p:txBody>
-      </p:sp>
-      <p:sp>
-        <p:nvSpPr>
-          <p:cNvPr id="10" name="Shape 8"/>
-          <p:cNvSpPr/>
-          <p:nvPr/>
-        </p:nvSpPr>
-        <p:spPr>
-          <a:xfrm>
-            <a:off x="640080" y="3886200"/>
-            <a:ext cx="5120640" cy="1737360"/>
+              <a:t>Documents which log line proves which behavior: debug by grep, not by reading source.</a:t>
+            </a:r>
+            <a:endParaRPr lang="en-US" sz="1250" dirty="0"/>
+          </a:p>
+        </p:txBody>
+      </p:sp>
+      <p:sp>
+        <p:nvSpPr>
+          <p:cNvPr id="11" name="Shape 9"/>
+          <p:cNvSpPr/>
+          <p:nvPr/>
+        </p:nvSpPr>
+        <p:spPr>
+          <a:xfrm>
+            <a:off x="640080" y="4892040"/>
+            <a:ext cx="5029200" cy="914400"/>
           </a:xfrm>
           <a:prstGeom prst="roundRect">
             <a:avLst>
-              <a:gd name="adj" fmla="val 4211"/>
+              <a:gd name="adj" fmla="val 8000"/>
             </a:avLst>
           </a:prstGeom>
           <a:solidFill>
-            <a:srgbClr val="1C2330"/>
+            <a:srgbClr val="161B22"/>
           </a:solidFill>
           <a:ln w="12700">
             <a:solidFill>
@@ -7778,14 +8094,14 @@
       </p:sp>
       <p:sp>
         <p:nvSpPr>
-          <p:cNvPr id="11" name="Text 9"/>
-          <p:cNvSpPr/>
-          <p:nvPr/>
-        </p:nvSpPr>
-        <p:spPr>
-          <a:xfrm>
-            <a:off x="1005840" y="4178808"/>
-            <a:ext cx="4572000" cy="822960"/>
+          <p:cNvPr id="12" name="Text 10"/>
+          <p:cNvSpPr/>
+          <p:nvPr/>
+        </p:nvSpPr>
+        <p:spPr>
+          <a:xfrm>
+            <a:off x="914400" y="5010912"/>
+            <a:ext cx="4572000" cy="320040"/>
           </a:xfrm>
           <a:prstGeom prst="rect">
             <a:avLst/>
@@ -7801,7 +8117,7 @@
               <a:buNone/>
             </a:pPr>
             <a:r>
-              <a:rPr lang="en-US" sz="3800" b="1" dirty="0">
+              <a:rPr lang="en-US" sz="1500" b="1" dirty="0">
                 <a:solidFill>
                   <a:srgbClr val="5EEAD4"/>
                 </a:solidFill>
@@ -7809,22 +8125,22 @@
                 <a:ea typeface="Georgia" pitchFamily="34" charset="-122"/>
                 <a:cs typeface="Georgia" pitchFamily="34" charset="-120"/>
               </a:rPr>
-              <a:t>2,000+/day</a:t>
-            </a:r>
-            <a:endParaRPr lang="en-US" sz="3800" dirty="0"/>
-          </a:p>
-        </p:txBody>
-      </p:sp>
-      <p:sp>
-        <p:nvSpPr>
-          <p:cNvPr id="12" name="Text 10"/>
-          <p:cNvSpPr/>
-          <p:nvPr/>
-        </p:nvSpPr>
-        <p:spPr>
-          <a:xfrm>
-            <a:off x="1024128" y="5029200"/>
-            <a:ext cx="4526280" cy="457200"/>
+              <a:t>Failure-first</a:t>
+            </a:r>
+            <a:endParaRPr lang="en-US" sz="1500" dirty="0"/>
+          </a:p>
+        </p:txBody>
+      </p:sp>
+      <p:sp>
+        <p:nvSpPr>
+          <p:cNvPr id="13" name="Text 11"/>
+          <p:cNvSpPr/>
+          <p:nvPr/>
+        </p:nvSpPr>
+        <p:spPr>
+          <a:xfrm>
+            <a:off x="914400" y="5349240"/>
+            <a:ext cx="4572000" cy="411480"/>
           </a:xfrm>
           <a:prstGeom prst="rect">
             <a:avLst/>
@@ -7840,7 +8156,7 @@
               <a:buNone/>
             </a:pPr>
             <a:r>
-              <a:rPr lang="en-US" sz="1400" dirty="0">
+              <a:rPr lang="en-US" sz="1250" dirty="0">
                 <a:solidFill>
                   <a:srgbClr val="9AA7B4"/>
                 </a:solidFill>
@@ -7848,30 +8164,30 @@
                 <a:ea typeface="Calibri" pitchFamily="34" charset="-122"/>
                 <a:cs typeface="Calibri" pitchFamily="34" charset="-120"/>
               </a:rPr>
-              <a:t>WhatsApp + emails (Twilio + Postmark)</a:t>
-            </a:r>
-            <a:endParaRPr lang="en-US" sz="1400" dirty="0"/>
-          </a:p>
-        </p:txBody>
-      </p:sp>
-      <p:sp>
-        <p:nvSpPr>
-          <p:cNvPr id="13" name="Shape 11"/>
-          <p:cNvSpPr/>
-          <p:nvPr/>
-        </p:nvSpPr>
-        <p:spPr>
-          <a:xfrm>
-            <a:off x="6080760" y="3886200"/>
-            <a:ext cx="5120640" cy="1737360"/>
+              <a:t>Maps real symptoms to the exact gate that caused them.</a:t>
+            </a:r>
+            <a:endParaRPr lang="en-US" sz="1250" dirty="0"/>
+          </a:p>
+        </p:txBody>
+      </p:sp>
+      <p:sp>
+        <p:nvSpPr>
+          <p:cNvPr id="14" name="Shape 12"/>
+          <p:cNvSpPr/>
+          <p:nvPr/>
+        </p:nvSpPr>
+        <p:spPr>
+          <a:xfrm>
+            <a:off x="6035040" y="1691640"/>
+            <a:ext cx="5532120" cy="4480560"/>
           </a:xfrm>
           <a:prstGeom prst="roundRect">
             <a:avLst>
-              <a:gd name="adj" fmla="val 4211"/>
+              <a:gd name="adj" fmla="val 1633"/>
             </a:avLst>
           </a:prstGeom>
           <a:solidFill>
-            <a:srgbClr val="1C2330"/>
+            <a:srgbClr val="0A0E14"/>
           </a:solidFill>
           <a:ln w="12700">
             <a:solidFill>
@@ -7883,14 +8199,74 @@
       </p:sp>
       <p:sp>
         <p:nvSpPr>
-          <p:cNvPr id="14" name="Text 12"/>
-          <p:cNvSpPr/>
-          <p:nvPr/>
-        </p:nvSpPr>
-        <p:spPr>
-          <a:xfrm>
-            <a:off x="6446520" y="4178808"/>
-            <a:ext cx="4572000" cy="822960"/>
+          <p:cNvPr id="15" name="Shape 13"/>
+          <p:cNvSpPr/>
+          <p:nvPr/>
+        </p:nvSpPr>
+        <p:spPr>
+          <a:xfrm>
+            <a:off x="6309360" y="1920240"/>
+            <a:ext cx="146304" cy="146304"/>
+          </a:xfrm>
+          <a:prstGeom prst="ellipse">
+            <a:avLst/>
+          </a:prstGeom>
+          <a:solidFill>
+            <a:srgbClr val="E06C75"/>
+          </a:solidFill>
+          <a:ln/>
+        </p:spPr>
+      </p:sp>
+      <p:sp>
+        <p:nvSpPr>
+          <p:cNvPr id="16" name="Shape 14"/>
+          <p:cNvSpPr/>
+          <p:nvPr/>
+        </p:nvSpPr>
+        <p:spPr>
+          <a:xfrm>
+            <a:off x="6601968" y="1920240"/>
+            <a:ext cx="146304" cy="146304"/>
+          </a:xfrm>
+          <a:prstGeom prst="ellipse">
+            <a:avLst/>
+          </a:prstGeom>
+          <a:solidFill>
+            <a:srgbClr val="E5C07B"/>
+          </a:solidFill>
+          <a:ln/>
+        </p:spPr>
+      </p:sp>
+      <p:sp>
+        <p:nvSpPr>
+          <p:cNvPr id="17" name="Shape 15"/>
+          <p:cNvSpPr/>
+          <p:nvPr/>
+        </p:nvSpPr>
+        <p:spPr>
+          <a:xfrm>
+            <a:off x="6894576" y="1920240"/>
+            <a:ext cx="146304" cy="146304"/>
+          </a:xfrm>
+          <a:prstGeom prst="ellipse">
+            <a:avLst/>
+          </a:prstGeom>
+          <a:solidFill>
+            <a:srgbClr val="98C379"/>
+          </a:solidFill>
+          <a:ln/>
+        </p:spPr>
+      </p:sp>
+      <p:sp>
+        <p:nvSpPr>
+          <p:cNvPr id="18" name="Text 16"/>
+          <p:cNvSpPr/>
+          <p:nvPr/>
+        </p:nvSpPr>
+        <p:spPr>
+          <a:xfrm>
+            <a:off x="7315200" y="1874520"/>
+            <a:ext cx="3657600" cy="274320"/>
           </a:xfrm>
           <a:prstGeom prst="rect">
             <a:avLst/>
@@ -7906,95 +8282,191 @@
               <a:buNone/>
             </a:pPr>
             <a:r>
-              <a:rPr lang="en-US" sz="3800" b="1" dirty="0">
+              <a:rPr lang="en-US" sz="1100" dirty="0">
+                <a:solidFill>
+                  <a:srgbClr val="7D8896"/>
+                </a:solidFill>
+                <a:latin typeface="Consolas" pitchFamily="34" charset="0"/>
+                <a:ea typeface="Consolas" pitchFamily="34" charset="-122"/>
+                <a:cs typeface="Consolas" pitchFamily="34" charset="-120"/>
+              </a:rPr>
+              <a:t>troubleshooting.md</a:t>
+            </a:r>
+            <a:endParaRPr lang="en-US" sz="1100" dirty="0"/>
+          </a:p>
+        </p:txBody>
+      </p:sp>
+      <p:sp>
+        <p:nvSpPr>
+          <p:cNvPr id="19" name="Text 17"/>
+          <p:cNvSpPr/>
+          <p:nvPr/>
+        </p:nvSpPr>
+        <p:spPr>
+          <a:xfrm>
+            <a:off x="6355080" y="2331720"/>
+            <a:ext cx="4892040" cy="3657600"/>
+          </a:xfrm>
+          <a:prstGeom prst="rect">
+            <a:avLst/>
+          </a:prstGeom>
+          <a:noFill/>
+          <a:ln/>
+        </p:spPr>
+        <p:txBody>
+          <a:bodyPr wrap="square" rtlCol="0" anchor="t"/>
+          <a:lstStyle/>
+          <a:p>
+            <a:pPr indent="0" marL="0">
+              <a:lnSpc>
+                <a:spcPct val="115000"/>
+              </a:lnSpc>
+              <a:buNone/>
+            </a:pPr>
+            <a:r>
+              <a:rPr lang="en-US" sz="1200" dirty="0">
+                <a:solidFill>
+                  <a:srgbClr val="7D8896"/>
+                </a:solidFill>
+                <a:latin typeface="Consolas" pitchFamily="34" charset="0"/>
+                <a:ea typeface="Consolas" pitchFamily="34" charset="-122"/>
+                <a:cs typeface="Consolas" pitchFamily="34" charset="-120"/>
+              </a:rPr>
+              <a:t>## Troubleshooting
+</a:t>
+            </a:r>
+            <a:pPr indent="0" marL="0">
+              <a:lnSpc>
+                <a:spcPct val="115000"/>
+              </a:lnSpc>
+              <a:buNone/>
+            </a:pPr>
+            <a:r>
+              <a:rPr lang="en-US" sz="1200" b="1" dirty="0">
                 <a:solidFill>
                   <a:srgbClr val="5EEAD4"/>
                 </a:solidFill>
-                <a:latin typeface="Georgia" pitchFamily="34" charset="0"/>
-                <a:ea typeface="Georgia" pitchFamily="34" charset="-122"/>
-                <a:cs typeface="Georgia" pitchFamily="34" charset="-120"/>
-              </a:rPr>
-              <a:t>&lt;1 min</a:t>
-            </a:r>
-            <a:endParaRPr lang="en-US" sz="3800" dirty="0"/>
-          </a:p>
-        </p:txBody>
-      </p:sp>
-      <p:sp>
-        <p:nvSpPr>
-          <p:cNvPr id="15" name="Text 13"/>
-          <p:cNvSpPr/>
-          <p:nvPr/>
-        </p:nvSpPr>
-        <p:spPr>
-          <a:xfrm>
-            <a:off x="6464808" y="5029200"/>
-            <a:ext cx="4526280" cy="457200"/>
-          </a:xfrm>
-          <a:prstGeom prst="rect">
-            <a:avLst/>
-          </a:prstGeom>
-          <a:noFill/>
-          <a:ln/>
-        </p:spPr>
-        <p:txBody>
-          <a:bodyPr wrap="square" rtlCol="0" anchor="ctr"/>
-          <a:lstStyle/>
-          <a:p>
+                <a:latin typeface="Consolas" pitchFamily="34" charset="0"/>
+                <a:ea typeface="Consolas" pitchFamily="34" charset="-122"/>
+                <a:cs typeface="Consolas" pitchFamily="34" charset="-120"/>
+              </a:rPr>
+              <a:t>Candidate not considered for a role, check, in order:
+</a:t>
+            </a:r>
             <a:pPr indent="0" marL="0">
-              <a:buNone/>
-            </a:pPr>
-            <a:r>
-              <a:rPr lang="en-US" sz="1400" dirty="0">
-                <a:solidFill>
-                  <a:srgbClr val="9AA7B4"/>
-                </a:solidFill>
-                <a:latin typeface="Calibri" pitchFamily="34" charset="0"/>
-                <a:ea typeface="Calibri" pitchFamily="34" charset="-122"/>
-                <a:cs typeface="Calibri" pitchFamily="34" charset="-120"/>
-              </a:rPr>
-              <a:t>to parse a CV, regex-first, AI only when needed</a:t>
-            </a:r>
-            <a:endParaRPr lang="en-US" sz="1400" dirty="0"/>
-          </a:p>
-        </p:txBody>
-      </p:sp>
-      <p:sp>
-        <p:nvSpPr>
-          <p:cNvPr id="16" name="Text 14"/>
-          <p:cNvSpPr/>
-          <p:nvPr/>
-        </p:nvSpPr>
-        <p:spPr>
-          <a:xfrm>
-            <a:off x="640080" y="5943600"/>
-            <a:ext cx="10881360" cy="365760"/>
-          </a:xfrm>
-          <a:prstGeom prst="rect">
-            <a:avLst/>
-          </a:prstGeom>
-          <a:noFill/>
-          <a:ln/>
-        </p:spPr>
-        <p:txBody>
-          <a:bodyPr wrap="square" rtlCol="0" anchor="ctr"/>
-          <a:lstStyle/>
-          <a:p>
-            <a:pPr algn="ctr" indent="0" marL="0">
-              <a:buNone/>
-            </a:pPr>
-            <a:r>
-              <a:rPr lang="en-US" sz="1300" i="1" dirty="0">
-                <a:solidFill>
-                  <a:srgbClr val="7D8896"/>
-                </a:solidFill>
-                <a:latin typeface="Calibri" pitchFamily="34" charset="0"/>
-                <a:ea typeface="Calibri" pitchFamily="34" charset="-122"/>
-                <a:cs typeface="Calibri" pitchFamily="34" charset="-120"/>
-              </a:rPr>
-              <a:t>Manual work that took weeks, now seconds to a couple of hours. Workflow on the previous slides.</a:t>
-            </a:r>
-            <a:endParaRPr lang="en-US" sz="1300" dirty="0"/>
+              <a:lnSpc>
+                <a:spcPct val="115000"/>
+              </a:lnSpc>
+              <a:buNone/>
+            </a:pPr>
+            <a:r>
+              <a:rPr lang="en-US" sz="1200" dirty="0">
+                <a:solidFill>
+                  <a:srgbClr val="E6EDF3"/>
+                </a:solidFill>
+                <a:latin typeface="Consolas" pitchFamily="34" charset="0"/>
+                <a:ea typeface="Consolas" pitchFamily="34" charset="-122"/>
+                <a:cs typeface="Consolas" pitchFamily="34" charset="-120"/>
+              </a:rPr>
+              <a:t>  1. Stage-2 keyword overlap
+  2. Stage-3 hard filters (language, location, score)
+  3. existing scored row (already processed)
+  4. duplicate-email de-duplication
+</a:t>
+            </a:r>
+            <a:pPr indent="0" marL="0">
+              <a:lnSpc>
+                <a:spcPct val="115000"/>
+              </a:lnSpc>
+              <a:buNone/>
+            </a:pPr>
+            <a:r>
+              <a:rPr lang="en-US" sz="1200" b="1" dirty="0">
+                <a:solidFill>
+                  <a:srgbClr val="5EEAD4"/>
+                </a:solidFill>
+                <a:latin typeface="Consolas" pitchFamily="34" charset="0"/>
+                <a:ea typeface="Consolas" pitchFamily="34" charset="-122"/>
+                <a:cs typeface="Consolas" pitchFamily="34" charset="-120"/>
+              </a:rPr>
+              <a:t>Fewer qualified matches than target, expected:
+</a:t>
+            </a:r>
+            <a:pPr indent="0" marL="0">
+              <a:lnSpc>
+                <a:spcPct val="115000"/>
+              </a:lnSpc>
+              <a:buNone/>
+            </a:pPr>
+            <a:r>
+              <a:rPr lang="en-US" sz="1200" dirty="0">
+                <a:solidFill>
+                  <a:srgbClr val="E6EDF3"/>
+                </a:solidFill>
+                <a:latin typeface="Consolas" pitchFamily="34" charset="0"/>
+                <a:ea typeface="Consolas" pitchFamily="34" charset="-122"/>
+                <a:cs typeface="Consolas" pitchFamily="34" charset="-120"/>
+              </a:rPr>
+              <a:t>  Stage 6 backfills below-threshold by descending</a:t>
+            </a:r>
+            <a:endParaRPr lang="en-US" sz="1200" dirty="0"/>
+          </a:p>
+          <a:p>
+            <a:pPr indent="0" marL="0">
+              <a:lnSpc>
+                <a:spcPct val="115000"/>
+              </a:lnSpc>
+              <a:buNone/>
+            </a:pPr>
+            <a:r>
+              <a:rPr lang="en-US" sz="1200" dirty="0">
+                <a:solidFill>
+                  <a:srgbClr val="E6EDF3"/>
+                </a:solidFill>
+                <a:latin typeface="Consolas" pitchFamily="34" charset="0"/>
+                <a:ea typeface="Consolas" pitchFamily="34" charset="-122"/>
+                <a:cs typeface="Consolas" pitchFamily="34" charset="-120"/>
+              </a:rPr>
+              <a:t>  score and logs </a:t>
+            </a:r>
+            <a:endParaRPr lang="en-US" sz="1200" dirty="0"/>
+          </a:p>
+          <a:p>
+            <a:pPr indent="0" marL="0">
+              <a:lnSpc>
+                <a:spcPct val="115000"/>
+              </a:lnSpc>
+              <a:buNone/>
+            </a:pPr>
+            <a:r>
+              <a:rPr lang="en-US" sz="1200" dirty="0">
+                <a:solidFill>
+                  <a:srgbClr val="F0B86E"/>
+                </a:solidFill>
+                <a:latin typeface="Consolas" pitchFamily="34" charset="0"/>
+                <a:ea typeface="Consolas" pitchFamily="34" charset="-122"/>
+                <a:cs typeface="Consolas" pitchFamily="34" charset="-120"/>
+              </a:rPr>
+              <a:t>fallback_selected=true</a:t>
+            </a:r>
+            <a:pPr indent="0" marL="0">
+              <a:lnSpc>
+                <a:spcPct val="115000"/>
+              </a:lnSpc>
+              <a:buNone/>
+            </a:pPr>
+            <a:r>
+              <a:rPr lang="en-US" sz="1200" dirty="0">
+                <a:solidFill>
+                  <a:srgbClr val="E6EDF3"/>
+                </a:solidFill>
+                <a:latin typeface="Consolas" pitchFamily="34" charset="0"/>
+                <a:ea typeface="Consolas" pitchFamily="34" charset="-122"/>
+                <a:cs typeface="Consolas" pitchFamily="34" charset="-120"/>
+              </a:rPr>
+              <a:t> per row.</a:t>
+            </a:r>
+            <a:endParaRPr lang="en-US" sz="1200" dirty="0"/>
           </a:p>
         </p:txBody>
       </p:sp>
@@ -8038,24 +8510,24 @@
         </p:nvSpPr>
         <p:spPr>
           <a:xfrm>
-            <a:off x="640080" y="1097280"/>
-            <a:ext cx="10058400" cy="274320"/>
-          </a:xfrm>
-          <a:prstGeom prst="rect">
-            <a:avLst/>
-          </a:prstGeom>
-          <a:noFill/>
-          <a:ln/>
-        </p:spPr>
-        <p:txBody>
-          <a:bodyPr wrap="square" rtlCol="0" anchor="ctr"/>
-          <a:lstStyle/>
-          <a:p>
-            <a:pPr indent="0" marL="0">
-              <a:buNone/>
-            </a:pPr>
-            <a:r>
-              <a:rPr lang="en-US" sz="1200" spc="200" kern="0" dirty="0">
+            <a:off x="640080" y="502920"/>
+            <a:ext cx="7315200" cy="274320"/>
+          </a:xfrm>
+          <a:prstGeom prst="rect">
+            <a:avLst/>
+          </a:prstGeom>
+          <a:noFill/>
+          <a:ln/>
+        </p:spPr>
+        <p:txBody>
+          <a:bodyPr wrap="square" rtlCol="0" anchor="ctr"/>
+          <a:lstStyle/>
+          <a:p>
+            <a:pPr algn="l" indent="0" marL="0">
+              <a:buNone/>
+            </a:pPr>
+            <a:r>
+              <a:rPr lang="en-US" sz="1100" spc="200" kern="0" dirty="0">
                 <a:solidFill>
                   <a:srgbClr val="5EEAD4"/>
                 </a:solidFill>
@@ -8063,60 +8535,38 @@
                 <a:ea typeface="Consolas" pitchFamily="34" charset="-122"/>
                 <a:cs typeface="Consolas" pitchFamily="34" charset="-120"/>
               </a:rPr>
-              <a:t>WHAT THIS DEMONSTRATES</a:t>
-            </a:r>
-            <a:endParaRPr lang="en-US" sz="1200" dirty="0"/>
-          </a:p>
-        </p:txBody>
-      </p:sp>
-      <p:sp>
-        <p:nvSpPr>
-          <p:cNvPr id="3" name="Shape 1"/>
-          <p:cNvSpPr/>
-          <p:nvPr/>
-        </p:nvSpPr>
-        <p:spPr>
-          <a:xfrm>
-            <a:off x="640080" y="1691640"/>
-            <a:ext cx="109728" cy="914400"/>
-          </a:xfrm>
-          <a:prstGeom prst="roundRect">
-            <a:avLst>
-              <a:gd name="adj" fmla="val 50000"/>
-            </a:avLst>
-          </a:prstGeom>
-          <a:solidFill>
-            <a:srgbClr val="5EEAD4"/>
-          </a:solidFill>
-          <a:ln/>
-        </p:spPr>
-      </p:sp>
-      <p:sp>
-        <p:nvSpPr>
-          <p:cNvPr id="4" name="Text 2"/>
-          <p:cNvSpPr/>
-          <p:nvPr/>
-        </p:nvSpPr>
-        <p:spPr>
-          <a:xfrm>
-            <a:off x="1005840" y="1709928"/>
-            <a:ext cx="3657600" cy="411480"/>
-          </a:xfrm>
-          <a:prstGeom prst="rect">
-            <a:avLst/>
-          </a:prstGeom>
-          <a:noFill/>
-          <a:ln/>
-        </p:spPr>
-        <p:txBody>
-          <a:bodyPr wrap="square" rtlCol="0" anchor="ctr"/>
-          <a:lstStyle/>
-          <a:p>
-            <a:pPr indent="0" marL="0">
-              <a:buNone/>
-            </a:pPr>
-            <a:r>
-              <a:rPr lang="en-US" sz="2100" b="1" dirty="0">
+              <a:t>IMPACT</a:t>
+            </a:r>
+            <a:endParaRPr lang="en-US" sz="1100" dirty="0"/>
+          </a:p>
+        </p:txBody>
+      </p:sp>
+      <p:sp>
+        <p:nvSpPr>
+          <p:cNvPr id="3" name="Text 1"/>
+          <p:cNvSpPr/>
+          <p:nvPr/>
+        </p:nvSpPr>
+        <p:spPr>
+          <a:xfrm>
+            <a:off x="640080" y="822960"/>
+            <a:ext cx="10881360" cy="822960"/>
+          </a:xfrm>
+          <a:prstGeom prst="rect">
+            <a:avLst/>
+          </a:prstGeom>
+          <a:noFill/>
+          <a:ln/>
+        </p:spPr>
+        <p:txBody>
+          <a:bodyPr wrap="square" rtlCol="0" anchor="ctr"/>
+          <a:lstStyle/>
+          <a:p>
+            <a:pPr algn="l" indent="0" marL="0">
+              <a:buNone/>
+            </a:pPr>
+            <a:r>
+              <a:rPr lang="en-US" sz="3400" b="1" dirty="0">
                 <a:solidFill>
                   <a:srgbClr val="E6EDF3"/>
                 </a:solidFill>
@@ -8124,11 +8574,38 @@
                 <a:ea typeface="Georgia" pitchFamily="34" charset="-122"/>
                 <a:cs typeface="Georgia" pitchFamily="34" charset="-120"/>
               </a:rPr>
-              <a:t>AI automation</a:t>
-            </a:r>
-            <a:endParaRPr lang="en-US" sz="2100" dirty="0"/>
-          </a:p>
-        </p:txBody>
+              <a:t>What the automation delivers</a:t>
+            </a:r>
+            <a:endParaRPr lang="en-US" sz="3400" dirty="0"/>
+          </a:p>
+        </p:txBody>
+      </p:sp>
+      <p:sp>
+        <p:nvSpPr>
+          <p:cNvPr id="4" name="Shape 2"/>
+          <p:cNvSpPr/>
+          <p:nvPr/>
+        </p:nvSpPr>
+        <p:spPr>
+          <a:xfrm>
+            <a:off x="640080" y="1920240"/>
+            <a:ext cx="5120640" cy="1737360"/>
+          </a:xfrm>
+          <a:prstGeom prst="roundRect">
+            <a:avLst>
+              <a:gd name="adj" fmla="val 4211"/>
+            </a:avLst>
+          </a:prstGeom>
+          <a:solidFill>
+            <a:srgbClr val="1C2330"/>
+          </a:solidFill>
+          <a:ln w="12700">
+            <a:solidFill>
+              <a:srgbClr val="2A3240"/>
+            </a:solidFill>
+            <a:prstDash val="solid"/>
+          </a:ln>
+        </p:spPr>
       </p:sp>
       <p:sp>
         <p:nvSpPr>
@@ -8138,8 +8615,8 @@
         </p:nvSpPr>
         <p:spPr>
           <a:xfrm>
-            <a:off x="1005840" y="2148840"/>
-            <a:ext cx="9601200" cy="548640"/>
+            <a:off x="1005840" y="2212848"/>
+            <a:ext cx="4572000" cy="822960"/>
           </a:xfrm>
           <a:prstGeom prst="rect">
             <a:avLst/>
@@ -8155,7 +8632,46 @@
               <a:buNone/>
             </a:pPr>
             <a:r>
-              <a:rPr lang="en-US" sz="1500" dirty="0">
+              <a:rPr lang="en-US" sz="3800" b="1" dirty="0">
+                <a:solidFill>
+                  <a:srgbClr val="5EEAD4"/>
+                </a:solidFill>
+                <a:latin typeface="Georgia" pitchFamily="34" charset="0"/>
+                <a:ea typeface="Georgia" pitchFamily="34" charset="-122"/>
+                <a:cs typeface="Georgia" pitchFamily="34" charset="-120"/>
+              </a:rPr>
+              <a:t>40,000</a:t>
+            </a:r>
+            <a:endParaRPr lang="en-US" sz="3800" dirty="0"/>
+          </a:p>
+        </p:txBody>
+      </p:sp>
+      <p:sp>
+        <p:nvSpPr>
+          <p:cNvPr id="6" name="Text 4"/>
+          <p:cNvSpPr/>
+          <p:nvPr/>
+        </p:nvSpPr>
+        <p:spPr>
+          <a:xfrm>
+            <a:off x="1024128" y="3063240"/>
+            <a:ext cx="4526280" cy="457200"/>
+          </a:xfrm>
+          <a:prstGeom prst="rect">
+            <a:avLst/>
+          </a:prstGeom>
+          <a:noFill/>
+          <a:ln/>
+        </p:spPr>
+        <p:txBody>
+          <a:bodyPr wrap="square" rtlCol="0" anchor="ctr"/>
+          <a:lstStyle/>
+          <a:p>
+            <a:pPr indent="0" marL="0">
+              <a:buNone/>
+            </a:pPr>
+            <a:r>
+              <a:rPr lang="en-US" sz="1400" dirty="0">
                 <a:solidFill>
                   <a:srgbClr val="9AA7B4"/>
                 </a:solidFill>
@@ -8163,44 +8679,49 @@
                 <a:ea typeface="Calibri" pitchFamily="34" charset="-122"/>
                 <a:cs typeface="Calibri" pitchFamily="34" charset="-120"/>
               </a:rPr>
-              <a:t>14 event-driven services, idempotent, rate-limited, running unattended in production.</a:t>
-            </a:r>
-            <a:endParaRPr lang="en-US" sz="1500" dirty="0"/>
-          </a:p>
-        </p:txBody>
-      </p:sp>
-      <p:sp>
-        <p:nvSpPr>
-          <p:cNvPr id="6" name="Shape 4"/>
-          <p:cNvSpPr/>
-          <p:nvPr/>
-        </p:nvSpPr>
-        <p:spPr>
-          <a:xfrm>
-            <a:off x="640080" y="2834640"/>
-            <a:ext cx="109728" cy="914400"/>
+              <a:t>candidate rows scanned per matching run</a:t>
+            </a:r>
+            <a:endParaRPr lang="en-US" sz="1400" dirty="0"/>
+          </a:p>
+        </p:txBody>
+      </p:sp>
+      <p:sp>
+        <p:nvSpPr>
+          <p:cNvPr id="7" name="Shape 5"/>
+          <p:cNvSpPr/>
+          <p:nvPr/>
+        </p:nvSpPr>
+        <p:spPr>
+          <a:xfrm>
+            <a:off x="6080760" y="1920240"/>
+            <a:ext cx="5120640" cy="1737360"/>
           </a:xfrm>
           <a:prstGeom prst="roundRect">
             <a:avLst>
-              <a:gd name="adj" fmla="val 50000"/>
+              <a:gd name="adj" fmla="val 4211"/>
             </a:avLst>
           </a:prstGeom>
           <a:solidFill>
-            <a:srgbClr val="5EEAD4"/>
+            <a:srgbClr val="1C2330"/>
           </a:solidFill>
-          <a:ln/>
-        </p:spPr>
-      </p:sp>
-      <p:sp>
-        <p:nvSpPr>
-          <p:cNvPr id="7" name="Text 5"/>
-          <p:cNvSpPr/>
-          <p:nvPr/>
-        </p:nvSpPr>
-        <p:spPr>
-          <a:xfrm>
-            <a:off x="1005840" y="2852928"/>
-            <a:ext cx="3657600" cy="411480"/>
+          <a:ln w="12700">
+            <a:solidFill>
+              <a:srgbClr val="2A3240"/>
+            </a:solidFill>
+            <a:prstDash val="solid"/>
+          </a:ln>
+        </p:spPr>
+      </p:sp>
+      <p:sp>
+        <p:nvSpPr>
+          <p:cNvPr id="8" name="Text 6"/>
+          <p:cNvSpPr/>
+          <p:nvPr/>
+        </p:nvSpPr>
+        <p:spPr>
+          <a:xfrm>
+            <a:off x="6446520" y="2212848"/>
+            <a:ext cx="4572000" cy="822960"/>
           </a:xfrm>
           <a:prstGeom prst="rect">
             <a:avLst/>
@@ -8216,30 +8737,30 @@
               <a:buNone/>
             </a:pPr>
             <a:r>
-              <a:rPr lang="en-US" sz="2100" b="1" dirty="0">
-                <a:solidFill>
-                  <a:srgbClr val="E6EDF3"/>
+              <a:rPr lang="en-US" sz="3800" b="1" dirty="0">
+                <a:solidFill>
+                  <a:srgbClr val="5EEAD4"/>
                 </a:solidFill>
                 <a:latin typeface="Georgia" pitchFamily="34" charset="0"/>
                 <a:ea typeface="Georgia" pitchFamily="34" charset="-122"/>
                 <a:cs typeface="Georgia" pitchFamily="34" charset="-120"/>
               </a:rPr>
-              <a:t>Technical writing</a:t>
-            </a:r>
-            <a:endParaRPr lang="en-US" sz="2100" dirty="0"/>
-          </a:p>
-        </p:txBody>
-      </p:sp>
-      <p:sp>
-        <p:nvSpPr>
-          <p:cNvPr id="8" name="Text 6"/>
-          <p:cNvSpPr/>
-          <p:nvPr/>
-        </p:nvSpPr>
-        <p:spPr>
-          <a:xfrm>
-            <a:off x="1005840" y="3291840"/>
-            <a:ext cx="9601200" cy="548640"/>
+              <a:t>90-120 min</a:t>
+            </a:r>
+            <a:endParaRPr lang="en-US" sz="3800" dirty="0"/>
+          </a:p>
+        </p:txBody>
+      </p:sp>
+      <p:sp>
+        <p:nvSpPr>
+          <p:cNvPr id="9" name="Text 7"/>
+          <p:cNvSpPr/>
+          <p:nvPr/>
+        </p:nvSpPr>
+        <p:spPr>
+          <a:xfrm>
+            <a:off x="6464808" y="3063240"/>
+            <a:ext cx="4526280" cy="457200"/>
           </a:xfrm>
           <a:prstGeom prst="rect">
             <a:avLst/>
@@ -8255,7 +8776,7 @@
               <a:buNone/>
             </a:pPr>
             <a:r>
-              <a:rPr lang="en-US" sz="1500" dirty="0">
+              <a:rPr lang="en-US" sz="1400" dirty="0">
                 <a:solidFill>
                   <a:srgbClr val="9AA7B4"/>
                 </a:solidFill>
@@ -8263,44 +8784,49 @@
                 <a:ea typeface="Calibri" pitchFamily="34" charset="-122"/>
                 <a:cs typeface="Calibri" pitchFamily="34" charset="-120"/>
               </a:rPr>
-              <a:t>Audience-layered operational handbooks, failure-first troubleshooting, this case study.</a:t>
-            </a:r>
-            <a:endParaRPr lang="en-US" sz="1500" dirty="0"/>
-          </a:p>
-        </p:txBody>
-      </p:sp>
-      <p:sp>
-        <p:nvSpPr>
-          <p:cNvPr id="9" name="Shape 7"/>
-          <p:cNvSpPr/>
-          <p:nvPr/>
-        </p:nvSpPr>
-        <p:spPr>
-          <a:xfrm>
-            <a:off x="640080" y="3977640"/>
-            <a:ext cx="109728" cy="914400"/>
+              <a:t>full run on Railway, with Slack status</a:t>
+            </a:r>
+            <a:endParaRPr lang="en-US" sz="1400" dirty="0"/>
+          </a:p>
+        </p:txBody>
+      </p:sp>
+      <p:sp>
+        <p:nvSpPr>
+          <p:cNvPr id="10" name="Shape 8"/>
+          <p:cNvSpPr/>
+          <p:nvPr/>
+        </p:nvSpPr>
+        <p:spPr>
+          <a:xfrm>
+            <a:off x="640080" y="3886200"/>
+            <a:ext cx="5120640" cy="1737360"/>
           </a:xfrm>
           <a:prstGeom prst="roundRect">
             <a:avLst>
-              <a:gd name="adj" fmla="val 50000"/>
+              <a:gd name="adj" fmla="val 4211"/>
             </a:avLst>
           </a:prstGeom>
           <a:solidFill>
-            <a:srgbClr val="5EEAD4"/>
+            <a:srgbClr val="1C2330"/>
           </a:solidFill>
-          <a:ln/>
-        </p:spPr>
-      </p:sp>
-      <p:sp>
-        <p:nvSpPr>
-          <p:cNvPr id="10" name="Text 8"/>
-          <p:cNvSpPr/>
-          <p:nvPr/>
-        </p:nvSpPr>
-        <p:spPr>
-          <a:xfrm>
-            <a:off x="1005840" y="3995928"/>
-            <a:ext cx="3657600" cy="411480"/>
+          <a:ln w="12700">
+            <a:solidFill>
+              <a:srgbClr val="2A3240"/>
+            </a:solidFill>
+            <a:prstDash val="solid"/>
+          </a:ln>
+        </p:spPr>
+      </p:sp>
+      <p:sp>
+        <p:nvSpPr>
+          <p:cNvPr id="11" name="Text 9"/>
+          <p:cNvSpPr/>
+          <p:nvPr/>
+        </p:nvSpPr>
+        <p:spPr>
+          <a:xfrm>
+            <a:off x="1005840" y="4178808"/>
+            <a:ext cx="4572000" cy="822960"/>
           </a:xfrm>
           <a:prstGeom prst="rect">
             <a:avLst/>
@@ -8316,30 +8842,30 @@
               <a:buNone/>
             </a:pPr>
             <a:r>
-              <a:rPr lang="en-US" sz="2100" b="1" dirty="0">
-                <a:solidFill>
-                  <a:srgbClr val="E6EDF3"/>
+              <a:rPr lang="en-US" sz="3800" b="1" dirty="0">
+                <a:solidFill>
+                  <a:srgbClr val="5EEAD4"/>
                 </a:solidFill>
                 <a:latin typeface="Georgia" pitchFamily="34" charset="0"/>
                 <a:ea typeface="Georgia" pitchFamily="34" charset="-122"/>
                 <a:cs typeface="Georgia" pitchFamily="34" charset="-120"/>
               </a:rPr>
-              <a:t>Cost-aware AI</a:t>
-            </a:r>
-            <a:endParaRPr lang="en-US" sz="2100" dirty="0"/>
-          </a:p>
-        </p:txBody>
-      </p:sp>
-      <p:sp>
-        <p:nvSpPr>
-          <p:cNvPr id="11" name="Text 9"/>
-          <p:cNvSpPr/>
-          <p:nvPr/>
-        </p:nvSpPr>
-        <p:spPr>
-          <a:xfrm>
-            <a:off x="1005840" y="4434840"/>
-            <a:ext cx="9601200" cy="548640"/>
+              <a:t>2,000+/day</a:t>
+            </a:r>
+            <a:endParaRPr lang="en-US" sz="3800" dirty="0"/>
+          </a:p>
+        </p:txBody>
+      </p:sp>
+      <p:sp>
+        <p:nvSpPr>
+          <p:cNvPr id="12" name="Text 10"/>
+          <p:cNvSpPr/>
+          <p:nvPr/>
+        </p:nvSpPr>
+        <p:spPr>
+          <a:xfrm>
+            <a:off x="1024128" y="5029200"/>
+            <a:ext cx="4526280" cy="457200"/>
           </a:xfrm>
           <a:prstGeom prst="rect">
             <a:avLst/>
@@ -8355,7 +8881,7 @@
               <a:buNone/>
             </a:pPr>
             <a:r>
-              <a:rPr lang="en-US" sz="1500" dirty="0">
+              <a:rPr lang="en-US" sz="1400" dirty="0">
                 <a:solidFill>
                   <a:srgbClr val="9AA7B4"/>
                 </a:solidFill>
@@ -8363,22 +8889,49 @@
                 <a:ea typeface="Calibri" pitchFamily="34" charset="-122"/>
                 <a:cs typeface="Calibri" pitchFamily="34" charset="-120"/>
               </a:rPr>
-              <a:t>DeepSeek on judgment-heavy steps, regex everywhere else. No wasted tokens.</a:t>
-            </a:r>
-            <a:endParaRPr lang="en-US" sz="1500" dirty="0"/>
-          </a:p>
-        </p:txBody>
-      </p:sp>
-      <p:sp>
-        <p:nvSpPr>
-          <p:cNvPr id="12" name="Text 10"/>
-          <p:cNvSpPr/>
-          <p:nvPr/>
-        </p:nvSpPr>
-        <p:spPr>
-          <a:xfrm>
-            <a:off x="640080" y="5486400"/>
-            <a:ext cx="6400800" cy="457200"/>
+              <a:t>WhatsApp + emails (Twilio + Postmark)</a:t>
+            </a:r>
+            <a:endParaRPr lang="en-US" sz="1400" dirty="0"/>
+          </a:p>
+        </p:txBody>
+      </p:sp>
+      <p:sp>
+        <p:nvSpPr>
+          <p:cNvPr id="13" name="Shape 11"/>
+          <p:cNvSpPr/>
+          <p:nvPr/>
+        </p:nvSpPr>
+        <p:spPr>
+          <a:xfrm>
+            <a:off x="6080760" y="3886200"/>
+            <a:ext cx="5120640" cy="1737360"/>
+          </a:xfrm>
+          <a:prstGeom prst="roundRect">
+            <a:avLst>
+              <a:gd name="adj" fmla="val 4211"/>
+            </a:avLst>
+          </a:prstGeom>
+          <a:solidFill>
+            <a:srgbClr val="1C2330"/>
+          </a:solidFill>
+          <a:ln w="12700">
+            <a:solidFill>
+              <a:srgbClr val="2A3240"/>
+            </a:solidFill>
+            <a:prstDash val="solid"/>
+          </a:ln>
+        </p:spPr>
+      </p:sp>
+      <p:sp>
+        <p:nvSpPr>
+          <p:cNvPr id="14" name="Text 12"/>
+          <p:cNvSpPr/>
+          <p:nvPr/>
+        </p:nvSpPr>
+        <p:spPr>
+          <a:xfrm>
+            <a:off x="6446520" y="4178808"/>
+            <a:ext cx="4572000" cy="822960"/>
           </a:xfrm>
           <a:prstGeom prst="rect">
             <a:avLst/>
@@ -8394,30 +8947,30 @@
               <a:buNone/>
             </a:pPr>
             <a:r>
-              <a:rPr lang="en-US" sz="2200" b="1" dirty="0">
-                <a:solidFill>
-                  <a:srgbClr val="E6EDF3"/>
+              <a:rPr lang="en-US" sz="3800" b="1" dirty="0">
+                <a:solidFill>
+                  <a:srgbClr val="5EEAD4"/>
                 </a:solidFill>
                 <a:latin typeface="Georgia" pitchFamily="34" charset="0"/>
                 <a:ea typeface="Georgia" pitchFamily="34" charset="-122"/>
                 <a:cs typeface="Georgia" pitchFamily="34" charset="-120"/>
               </a:rPr>
-              <a:t>Wessam Mandour</a:t>
-            </a:r>
-            <a:endParaRPr lang="en-US" sz="2200" dirty="0"/>
-          </a:p>
-        </p:txBody>
-      </p:sp>
-      <p:sp>
-        <p:nvSpPr>
-          <p:cNvPr id="13" name="Text 11"/>
-          <p:cNvSpPr/>
-          <p:nvPr/>
-        </p:nvSpPr>
-        <p:spPr>
-          <a:xfrm>
-            <a:off x="640080" y="5989320"/>
-            <a:ext cx="10972800" cy="365760"/>
+              <a:t>&lt;1 min</a:t>
+            </a:r>
+            <a:endParaRPr lang="en-US" sz="3800" dirty="0"/>
+          </a:p>
+        </p:txBody>
+      </p:sp>
+      <p:sp>
+        <p:nvSpPr>
+          <p:cNvPr id="15" name="Text 13"/>
+          <p:cNvSpPr/>
+          <p:nvPr/>
+        </p:nvSpPr>
+        <p:spPr>
+          <a:xfrm>
+            <a:off x="6464808" y="5029200"/>
+            <a:ext cx="4526280" cy="457200"/>
           </a:xfrm>
           <a:prstGeom prst="rect">
             <a:avLst/>
@@ -8433,15 +8986,54 @@
               <a:buNone/>
             </a:pPr>
             <a:r>
-              <a:rPr lang="en-US" sz="1300" dirty="0">
+              <a:rPr lang="en-US" sz="1400" dirty="0">
                 <a:solidFill>
                   <a:srgbClr val="9AA7B4"/>
                 </a:solidFill>
-                <a:latin typeface="Consolas" pitchFamily="34" charset="0"/>
-                <a:ea typeface="Consolas" pitchFamily="34" charset="-122"/>
-                <a:cs typeface="Consolas" pitchFamily="34" charset="-120"/>
-              </a:rPr>
-              <a:t>wessam.mandour94@gmail.com   ·   linkedin.com/in/wessam-mandour   ·   github.com/Wessam-Mandour</a:t>
+                <a:latin typeface="Calibri" pitchFamily="34" charset="0"/>
+                <a:ea typeface="Calibri" pitchFamily="34" charset="-122"/>
+                <a:cs typeface="Calibri" pitchFamily="34" charset="-120"/>
+              </a:rPr>
+              <a:t>to parse a CV, regex-first, AI only when needed</a:t>
+            </a:r>
+            <a:endParaRPr lang="en-US" sz="1400" dirty="0"/>
+          </a:p>
+        </p:txBody>
+      </p:sp>
+      <p:sp>
+        <p:nvSpPr>
+          <p:cNvPr id="16" name="Text 14"/>
+          <p:cNvSpPr/>
+          <p:nvPr/>
+        </p:nvSpPr>
+        <p:spPr>
+          <a:xfrm>
+            <a:off x="640080" y="5943600"/>
+            <a:ext cx="10881360" cy="365760"/>
+          </a:xfrm>
+          <a:prstGeom prst="rect">
+            <a:avLst/>
+          </a:prstGeom>
+          <a:noFill/>
+          <a:ln/>
+        </p:spPr>
+        <p:txBody>
+          <a:bodyPr wrap="square" rtlCol="0" anchor="ctr"/>
+          <a:lstStyle/>
+          <a:p>
+            <a:pPr algn="ctr" indent="0" marL="0">
+              <a:buNone/>
+            </a:pPr>
+            <a:r>
+              <a:rPr lang="en-US" sz="1300" i="1" dirty="0">
+                <a:solidFill>
+                  <a:srgbClr val="7D8896"/>
+                </a:solidFill>
+                <a:latin typeface="Calibri" pitchFamily="34" charset="0"/>
+                <a:ea typeface="Calibri" pitchFamily="34" charset="-122"/>
+                <a:cs typeface="Calibri" pitchFamily="34" charset="-120"/>
+              </a:rPr>
+              <a:t>Manual work that took weeks, now seconds to a couple of hours. Workflow on the previous slides.</a:t>
             </a:r>
             <a:endParaRPr lang="en-US" sz="1300" dirty="0"/>
           </a:p>

</xml_diff>

<commit_message>
Add detailed Q&A section; 20,000+ scored/run (DeepSeek API calls), 10-min transcript retry, 60s interview->Notion; deepen candidate-flow detail across site, case study, deck
</commit_message>
<xml_diff>
--- a/deck/AI-Recruiting-Automation-Portfolio.pptx
+++ b/deck/AI-Recruiting-Automation-Portfolio.pptx
@@ -3319,7 +3319,7 @@
                 <a:ea typeface="Calibri" pitchFamily="34" charset="-122"/>
                 <a:cs typeface="Calibri" pitchFamily="34" charset="-120"/>
               </a:rPr>
-              <a:t>Ranks candidates with a written rationale each, through a six-stage funnel. A full run takes 90 to 120 min on Railway and posts Slack status to the team.</a:t>
+              <a:t>Ranks candidates through a six-stage funnel, scoring upward of 20,000 per run via DeepSeek (20,000+ API calls). 90 to 120 min on Railway, with Slack status to the team.</a:t>
             </a:r>
             <a:endParaRPr lang="en-US" sz="1400" dirty="0"/>
           </a:p>
@@ -3463,7 +3463,7 @@
                 <a:ea typeface="Calibri" pitchFamily="34" charset="-122"/>
                 <a:cs typeface="Calibri" pitchFamily="34" charset="-120"/>
               </a:rPr>
-              <a:t>Webhook-triggered automations (CV parse, transcript scoring) plus cron-scheduled reminder sweeps. 2,000+ WhatsApp and email a day; CV parsed in under a minute.</a:t>
+              <a:t>Webhook automations plus cron reminder sweeps. 2,000+ WhatsApp and email a day; CV parsed in under a minute; a completed interview updates Notion in about 60 seconds.</a:t>
             </a:r>
             <a:endParaRPr lang="en-US" sz="1400" dirty="0"/>
           </a:p>
@@ -3634,7 +3634,7 @@
                 <a:ea typeface="Georgia" pitchFamily="34" charset="-122"/>
                 <a:cs typeface="Georgia" pitchFamily="34" charset="-120"/>
               </a:rPr>
-              <a:t>90-120 min</a:t>
+              <a:t>20,000+</a:t>
             </a:r>
             <a:endParaRPr lang="en-US" sz="2600" dirty="0"/>
           </a:p>
@@ -3673,7 +3673,7 @@
                 <a:ea typeface="Calibri" pitchFamily="34" charset="-122"/>
                 <a:cs typeface="Calibri" pitchFamily="34" charset="-120"/>
               </a:rPr>
-              <a:t>matching run on Railway</a:t>
+              <a:t>scored / run (DeepSeek)</a:t>
             </a:r>
             <a:endParaRPr lang="en-US" sz="1200" dirty="0"/>
           </a:p>
@@ -3739,7 +3739,7 @@
                 <a:ea typeface="Georgia" pitchFamily="34" charset="-122"/>
                 <a:cs typeface="Georgia" pitchFamily="34" charset="-120"/>
               </a:rPr>
-              <a:t>2,000+/day</a:t>
+              <a:t>90-120 min</a:t>
             </a:r>
             <a:endParaRPr lang="en-US" sz="2600" dirty="0"/>
           </a:p>
@@ -3778,7 +3778,7 @@
                 <a:ea typeface="Calibri" pitchFamily="34" charset="-122"/>
                 <a:cs typeface="Calibri" pitchFamily="34" charset="-120"/>
               </a:rPr>
-              <a:t>WhatsApp + email</a:t>
+              <a:t>matching run on Railway</a:t>
             </a:r>
             <a:endParaRPr lang="en-US" sz="1200" dirty="0"/>
           </a:p>
@@ -3844,7 +3844,7 @@
                 <a:ea typeface="Georgia" pitchFamily="34" charset="-122"/>
                 <a:cs typeface="Georgia" pitchFamily="34" charset="-120"/>
               </a:rPr>
-              <a:t>&lt;1 min</a:t>
+              <a:t>2,000+/day</a:t>
             </a:r>
             <a:endParaRPr lang="en-US" sz="2600" dirty="0"/>
           </a:p>
@@ -3883,7 +3883,7 @@
                 <a:ea typeface="Calibri" pitchFamily="34" charset="-122"/>
                 <a:cs typeface="Calibri" pitchFamily="34" charset="-120"/>
               </a:rPr>
-              <a:t>CV parsed, regex-first</a:t>
+              <a:t>WhatsApp + email</a:t>
             </a:r>
             <a:endParaRPr lang="en-US" sz="1200" dirty="0"/>
           </a:p>
@@ -8745,7 +8745,7 @@
                 <a:ea typeface="Georgia" pitchFamily="34" charset="-122"/>
                 <a:cs typeface="Georgia" pitchFamily="34" charset="-120"/>
               </a:rPr>
-              <a:t>90-120 min</a:t>
+              <a:t>20,000+</a:t>
             </a:r>
             <a:endParaRPr lang="en-US" sz="3800" dirty="0"/>
           </a:p>
@@ -8784,7 +8784,7 @@
                 <a:ea typeface="Calibri" pitchFamily="34" charset="-122"/>
                 <a:cs typeface="Calibri" pitchFamily="34" charset="-120"/>
               </a:rPr>
-              <a:t>full run on Railway, with Slack status</a:t>
+              <a:t>scored per run, 20k+ DeepSeek API calls</a:t>
             </a:r>
             <a:endParaRPr lang="en-US" sz="1400" dirty="0"/>
           </a:p>
@@ -8850,7 +8850,7 @@
                 <a:ea typeface="Georgia" pitchFamily="34" charset="-122"/>
                 <a:cs typeface="Georgia" pitchFamily="34" charset="-120"/>
               </a:rPr>
-              <a:t>2,000+/day</a:t>
+              <a:t>90-120 min</a:t>
             </a:r>
             <a:endParaRPr lang="en-US" sz="3800" dirty="0"/>
           </a:p>
@@ -8889,7 +8889,7 @@
                 <a:ea typeface="Calibri" pitchFamily="34" charset="-122"/>
                 <a:cs typeface="Calibri" pitchFamily="34" charset="-120"/>
               </a:rPr>
-              <a:t>WhatsApp + emails (Twilio + Postmark)</a:t>
+              <a:t>full run on Railway, with Slack status</a:t>
             </a:r>
             <a:endParaRPr lang="en-US" sz="1400" dirty="0"/>
           </a:p>
@@ -8955,7 +8955,7 @@
                 <a:ea typeface="Georgia" pitchFamily="34" charset="-122"/>
                 <a:cs typeface="Georgia" pitchFamily="34" charset="-120"/>
               </a:rPr>
-              <a:t>&lt;1 min</a:t>
+              <a:t>2,000+/day</a:t>
             </a:r>
             <a:endParaRPr lang="en-US" sz="3800" dirty="0"/>
           </a:p>
@@ -8994,7 +8994,7 @@
                 <a:ea typeface="Calibri" pitchFamily="34" charset="-122"/>
                 <a:cs typeface="Calibri" pitchFamily="34" charset="-120"/>
               </a:rPr>
-              <a:t>to parse a CV, regex-first, AI only when needed</a:t>
+              <a:t>WhatsApp + emails (Twilio + Postmark)</a:t>
             </a:r>
             <a:endParaRPr lang="en-US" sz="1400" dirty="0"/>
           </a:p>

</xml_diff>

<commit_message>
Generic LLM pill; mobile hamburger menu + lower back-to-top threshold; two clearly-distinct independent projects (Role Matching / Candidate Flow); add favicon + social link-preview (OG image)
</commit_message>
<xml_diff>
--- a/deck/AI-Recruiting-Automation-Portfolio.pptx
+++ b/deck/AI-Recruiting-Automation-Portfolio.pptx
@@ -2008,7 +2008,7 @@
                 <a:ea typeface="Consolas" pitchFamily="34" charset="-122"/>
                 <a:cs typeface="Consolas" pitchFamily="34" charset="-120"/>
               </a:rPr>
-              <a:t>DeepSeek · LLM Workflows</a:t>
+              <a:t>LLM Workflows &amp; APIs</a:t>
             </a:r>
             <a:endParaRPr lang="en-US" sz="1100" dirty="0"/>
           </a:p>
@@ -3136,7 +3136,7 @@
                 <a:ea typeface="Consolas" pitchFamily="34" charset="-122"/>
                 <a:cs typeface="Consolas" pitchFamily="34" charset="-120"/>
               </a:rPr>
-              <a:t>THE SYSTEM</a:t>
+              <a:t>THE SYSTEM · TWO INDEPENDENT PROJECTS</a:t>
             </a:r>
             <a:endParaRPr lang="en-US" sz="1100" dirty="0"/>
           </a:p>
@@ -3175,7 +3175,7 @@
                 <a:ea typeface="Georgia" pitchFamily="34" charset="-122"/>
                 <a:cs typeface="Georgia" pitchFamily="34" charset="-120"/>
               </a:rPr>
-              <a:t>Two systems, one automated funnel</a:t>
+              <a:t>Two separate projects, one funnel</a:t>
             </a:r>
             <a:endParaRPr lang="en-US" sz="3400" dirty="0"/>
           </a:p>
@@ -3241,7 +3241,7 @@
                 <a:ea typeface="Georgia" pitchFamily="34" charset="-122"/>
                 <a:cs typeface="Georgia" pitchFamily="34" charset="-120"/>
               </a:rPr>
-              <a:t>◆  Matching Engine</a:t>
+              <a:t>◆  Role Matching</a:t>
             </a:r>
             <a:endParaRPr lang="en-US" sz="2100" dirty="0"/>
           </a:p>
@@ -3280,7 +3280,7 @@
                 <a:ea typeface="Consolas" pitchFamily="34" charset="-122"/>
                 <a:cs typeface="Consolas" pitchFamily="34" charset="-120"/>
               </a:rPr>
-              <a:t>Python · FastAPI · DeepSeek</a:t>
+              <a:t>Project 01 · Python · FastAPI</a:t>
             </a:r>
             <a:endParaRPr lang="en-US" sz="1250" dirty="0"/>
           </a:p>
@@ -3319,7 +3319,7 @@
                 <a:ea typeface="Calibri" pitchFamily="34" charset="-122"/>
                 <a:cs typeface="Calibri" pitchFamily="34" charset="-120"/>
               </a:rPr>
-              <a:t>Ranks candidates through a six-stage funnel, scoring upward of 20,000 per run via DeepSeek (20,000+ API calls). 90 to 120 min on Railway, with Slack status to the team.</a:t>
+              <a:t>Independent project. Ranks candidates through a six-stage funnel, scoring upward of 20,000 per run (20,000+ LLM API calls). 90 to 120 min on Railway, with Slack status to the team.</a:t>
             </a:r>
             <a:endParaRPr lang="en-US" sz="1400" dirty="0"/>
           </a:p>
@@ -3424,7 +3424,7 @@
                 <a:ea typeface="Consolas" pitchFamily="34" charset="-122"/>
                 <a:cs typeface="Consolas" pitchFamily="34" charset="-120"/>
               </a:rPr>
-              <a:t>Node · Express · 14 services</a:t>
+              <a:t>Project 02 · Node · Express · 14 svc</a:t>
             </a:r>
             <a:endParaRPr lang="en-US" sz="1250" dirty="0"/>
           </a:p>
@@ -3463,7 +3463,7 @@
                 <a:ea typeface="Calibri" pitchFamily="34" charset="-122"/>
                 <a:cs typeface="Calibri" pitchFamily="34" charset="-120"/>
               </a:rPr>
-              <a:t>Webhook automations plus cron reminder sweeps. 2,000+ WhatsApp and email a day; CV parsed in under a minute; a completed interview updates Notion in about 60 seconds.</a:t>
+              <a:t>Independent project. Webhook automations plus cron reminder sweeps. 2,000+ WhatsApp and email a day; CV parsed in under a minute; a completed interview updates Notion in about 60 seconds.</a:t>
             </a:r>
             <a:endParaRPr lang="en-US" sz="1400" dirty="0"/>
           </a:p>
@@ -3673,7 +3673,7 @@
                 <a:ea typeface="Calibri" pitchFamily="34" charset="-122"/>
                 <a:cs typeface="Calibri" pitchFamily="34" charset="-120"/>
               </a:rPr>
-              <a:t>scored / run (DeepSeek)</a:t>
+              <a:t>scored / run (LLM API)</a:t>
             </a:r>
             <a:endParaRPr lang="en-US" sz="1200" dirty="0"/>
           </a:p>
@@ -8784,7 +8784,7 @@
                 <a:ea typeface="Calibri" pitchFamily="34" charset="-122"/>
                 <a:cs typeface="Calibri" pitchFamily="34" charset="-120"/>
               </a:rPr>
-              <a:t>scored per run, 20k+ DeepSeek API calls</a:t>
+              <a:t>scored per run, 20k+ LLM API calls</a:t>
             </a:r>
             <a:endParaRPr lang="en-US" sz="1400" dirty="0"/>
           </a:p>

</xml_diff>

<commit_message>
Add produced guided-walkthrough video (scenes, transitions, live-DOM captions + number highlights, Puppeteer recorder); regenerate CV PDF; add reliability slide to deck
</commit_message>
<xml_diff>
--- a/deck/AI-Recruiting-Automation-Portfolio.pptx
+++ b/deck/AI-Recruiting-Automation-Portfolio.pptx
@@ -15,9 +15,10 @@
     <p:sldId id="263" r:id="rId9"/>
     <p:sldId id="264" r:id="rId10"/>
     <p:sldId id="265" r:id="rId11"/>
+    <p:sldId id="266" r:id="rId12"/>
   </p:sldIdLst>
   <p:notesMasterIdLst>
-    <p:notesMasterId r:id="rId12"/>
+    <p:notesMasterId r:id="rId13"/>
   </p:notesMasterIdLst>
   <p:sldSz cx="12191695" cy="6858000"/>
   <p:notesSz cx="6858000" cy="12191695"/>
@@ -623,6 +624,94 @@
             <a:fld id="{F7021451-1387-4CA6-816F-3879F97B5CBC}" type="slidenum">
               <a:rPr lang="en-US"/>
               <a:t>10</a:t>
+            </a:fld>
+            <a:endParaRPr lang="en-US"/>
+          </a:p>
+        </p:txBody>
+      </p:sp>
+    </p:spTree>
+    <p:extLst>
+      <p:ext uri="{BB962C8B-B14F-4D97-AF65-F5344CB8AC3E}">
+        <p14:creationId xmlns:p14="http://schemas.microsoft.com/office/powerpoint/2010/main" val="1024086991"/>
+      </p:ext>
+    </p:extLst>
+  </p:cSld>
+  <p:clrMapOvr>
+    <a:masterClrMapping/>
+  </p:clrMapOvr>
+</p:notes>
+</file>
+
+<file path=ppt/notesSlides/notesSlide11.xml><?xml version="1.0" encoding="utf-8"?>
+<p:notes xmlns:a="http://schemas.openxmlformats.org/drawingml/2006/main" xmlns:r="http://schemas.openxmlformats.org/officeDocument/2006/relationships" xmlns:p="http://schemas.openxmlformats.org/presentationml/2006/main">
+  <p:cSld>
+    <p:spTree>
+      <p:nvGrpSpPr>
+        <p:cNvPr id="1" name=""/>
+        <p:cNvGrpSpPr/>
+        <p:nvPr/>
+      </p:nvGrpSpPr>
+      <p:grpSpPr>
+        <a:xfrm>
+          <a:off x="0" y="0"/>
+          <a:ext cx="0" cy="0"/>
+          <a:chOff x="0" y="0"/>
+          <a:chExt cx="0" cy="0"/>
+        </a:xfrm>
+      </p:grpSpPr>
+      <p:sp>
+        <p:nvSpPr>
+          <p:cNvPr id="2" name="Slide Image Placeholder 1"/>
+          <p:cNvSpPr>
+            <a:spLocks noGrp="1" noRot="1" noChangeAspect="1"/>
+          </p:cNvSpPr>
+          <p:nvPr>
+            <p:ph type="sldImg"/>
+          </p:nvPr>
+        </p:nvSpPr>
+        <p:spPr/>
+      </p:sp>
+      <p:sp>
+        <p:nvSpPr>
+          <p:cNvPr id="3" name="Notes Placeholder 2"/>
+          <p:cNvSpPr>
+            <a:spLocks noGrp="1"/>
+          </p:cNvSpPr>
+          <p:nvPr>
+            <p:ph type="body" idx="1"/>
+          </p:nvPr>
+        </p:nvSpPr>
+        <p:spPr/>
+        <p:txBody>
+          <a:bodyPr/>
+          <a:lstStyle/>
+          <a:p>
+            <a:r>
+              <a:rPr lang="en-US" dirty="0"/>
+              <a:t/>
+            </a:r>
+            <a:endParaRPr lang="en-US" dirty="0"/>
+          </a:p>
+        </p:txBody>
+      </p:sp>
+      <p:sp>
+        <p:nvSpPr>
+          <p:cNvPr id="4" name="Slide Number Placeholder 3"/>
+          <p:cNvSpPr>
+            <a:spLocks noGrp="1"/>
+          </p:cNvSpPr>
+          <p:nvPr>
+            <p:ph type="sldNum" sz="quarter" idx="10"/>
+          </p:nvPr>
+        </p:nvSpPr>
+        <p:spPr/>
+        <p:txBody>
+          <a:bodyPr/>
+          <a:lstStyle/>
+          <a:p>
+            <a:fld id="{F7021451-1387-4CA6-816F-3879F97B5CBC}" type="slidenum">
+              <a:rPr lang="en-US"/>
+              <a:t>11</a:t>
             </a:fld>
             <a:endParaRPr lang="en-US"/>
           </a:p>
@@ -2093,6 +2182,575 @@
         </p:nvSpPr>
         <p:spPr>
           <a:xfrm>
+            <a:off x="640080" y="502920"/>
+            <a:ext cx="7315200" cy="274320"/>
+          </a:xfrm>
+          <a:prstGeom prst="rect">
+            <a:avLst/>
+          </a:prstGeom>
+          <a:noFill/>
+          <a:ln/>
+        </p:spPr>
+        <p:txBody>
+          <a:bodyPr wrap="square" rtlCol="0" anchor="ctr"/>
+          <a:lstStyle/>
+          <a:p>
+            <a:pPr algn="l" indent="0" marL="0">
+              <a:buNone/>
+            </a:pPr>
+            <a:r>
+              <a:rPr lang="en-US" sz="1100" spc="200" kern="0" dirty="0">
+                <a:solidFill>
+                  <a:srgbClr val="5EEAD4"/>
+                </a:solidFill>
+                <a:latin typeface="Consolas" pitchFamily="34" charset="0"/>
+                <a:ea typeface="Consolas" pitchFamily="34" charset="-122"/>
+                <a:cs typeface="Consolas" pitchFamily="34" charset="-120"/>
+              </a:rPr>
+              <a:t>IMPACT</a:t>
+            </a:r>
+            <a:endParaRPr lang="en-US" sz="1100" dirty="0"/>
+          </a:p>
+        </p:txBody>
+      </p:sp>
+      <p:sp>
+        <p:nvSpPr>
+          <p:cNvPr id="3" name="Text 1"/>
+          <p:cNvSpPr/>
+          <p:nvPr/>
+        </p:nvSpPr>
+        <p:spPr>
+          <a:xfrm>
+            <a:off x="640080" y="822960"/>
+            <a:ext cx="10881360" cy="822960"/>
+          </a:xfrm>
+          <a:prstGeom prst="rect">
+            <a:avLst/>
+          </a:prstGeom>
+          <a:noFill/>
+          <a:ln/>
+        </p:spPr>
+        <p:txBody>
+          <a:bodyPr wrap="square" rtlCol="0" anchor="ctr"/>
+          <a:lstStyle/>
+          <a:p>
+            <a:pPr algn="l" indent="0" marL="0">
+              <a:buNone/>
+            </a:pPr>
+            <a:r>
+              <a:rPr lang="en-US" sz="3400" b="1" dirty="0">
+                <a:solidFill>
+                  <a:srgbClr val="E6EDF3"/>
+                </a:solidFill>
+                <a:latin typeface="Georgia" pitchFamily="34" charset="0"/>
+                <a:ea typeface="Georgia" pitchFamily="34" charset="-122"/>
+                <a:cs typeface="Georgia" pitchFamily="34" charset="-120"/>
+              </a:rPr>
+              <a:t>What the automation delivers</a:t>
+            </a:r>
+            <a:endParaRPr lang="en-US" sz="3400" dirty="0"/>
+          </a:p>
+        </p:txBody>
+      </p:sp>
+      <p:sp>
+        <p:nvSpPr>
+          <p:cNvPr id="4" name="Shape 2"/>
+          <p:cNvSpPr/>
+          <p:nvPr/>
+        </p:nvSpPr>
+        <p:spPr>
+          <a:xfrm>
+            <a:off x="640080" y="1920240"/>
+            <a:ext cx="5120640" cy="1737360"/>
+          </a:xfrm>
+          <a:prstGeom prst="roundRect">
+            <a:avLst>
+              <a:gd name="adj" fmla="val 4211"/>
+            </a:avLst>
+          </a:prstGeom>
+          <a:solidFill>
+            <a:srgbClr val="1C2330"/>
+          </a:solidFill>
+          <a:ln w="12700">
+            <a:solidFill>
+              <a:srgbClr val="2A3240"/>
+            </a:solidFill>
+            <a:prstDash val="solid"/>
+          </a:ln>
+        </p:spPr>
+      </p:sp>
+      <p:sp>
+        <p:nvSpPr>
+          <p:cNvPr id="5" name="Text 3"/>
+          <p:cNvSpPr/>
+          <p:nvPr/>
+        </p:nvSpPr>
+        <p:spPr>
+          <a:xfrm>
+            <a:off x="1005840" y="2212848"/>
+            <a:ext cx="4572000" cy="822960"/>
+          </a:xfrm>
+          <a:prstGeom prst="rect">
+            <a:avLst/>
+          </a:prstGeom>
+          <a:noFill/>
+          <a:ln/>
+        </p:spPr>
+        <p:txBody>
+          <a:bodyPr wrap="square" rtlCol="0" anchor="ctr"/>
+          <a:lstStyle/>
+          <a:p>
+            <a:pPr indent="0" marL="0">
+              <a:buNone/>
+            </a:pPr>
+            <a:r>
+              <a:rPr lang="en-US" sz="3800" b="1" dirty="0">
+                <a:solidFill>
+                  <a:srgbClr val="5EEAD4"/>
+                </a:solidFill>
+                <a:latin typeface="Georgia" pitchFamily="34" charset="0"/>
+                <a:ea typeface="Georgia" pitchFamily="34" charset="-122"/>
+                <a:cs typeface="Georgia" pitchFamily="34" charset="-120"/>
+              </a:rPr>
+              <a:t>40,000</a:t>
+            </a:r>
+            <a:endParaRPr lang="en-US" sz="3800" dirty="0"/>
+          </a:p>
+        </p:txBody>
+      </p:sp>
+      <p:sp>
+        <p:nvSpPr>
+          <p:cNvPr id="6" name="Text 4"/>
+          <p:cNvSpPr/>
+          <p:nvPr/>
+        </p:nvSpPr>
+        <p:spPr>
+          <a:xfrm>
+            <a:off x="1024128" y="3063240"/>
+            <a:ext cx="4526280" cy="457200"/>
+          </a:xfrm>
+          <a:prstGeom prst="rect">
+            <a:avLst/>
+          </a:prstGeom>
+          <a:noFill/>
+          <a:ln/>
+        </p:spPr>
+        <p:txBody>
+          <a:bodyPr wrap="square" rtlCol="0" anchor="ctr"/>
+          <a:lstStyle/>
+          <a:p>
+            <a:pPr indent="0" marL="0">
+              <a:buNone/>
+            </a:pPr>
+            <a:r>
+              <a:rPr lang="en-US" sz="1400" dirty="0">
+                <a:solidFill>
+                  <a:srgbClr val="9AA7B4"/>
+                </a:solidFill>
+                <a:latin typeface="Calibri" pitchFamily="34" charset="0"/>
+                <a:ea typeface="Calibri" pitchFamily="34" charset="-122"/>
+                <a:cs typeface="Calibri" pitchFamily="34" charset="-120"/>
+              </a:rPr>
+              <a:t>candidate rows scanned per matching run</a:t>
+            </a:r>
+            <a:endParaRPr lang="en-US" sz="1400" dirty="0"/>
+          </a:p>
+        </p:txBody>
+      </p:sp>
+      <p:sp>
+        <p:nvSpPr>
+          <p:cNvPr id="7" name="Shape 5"/>
+          <p:cNvSpPr/>
+          <p:nvPr/>
+        </p:nvSpPr>
+        <p:spPr>
+          <a:xfrm>
+            <a:off x="6080760" y="1920240"/>
+            <a:ext cx="5120640" cy="1737360"/>
+          </a:xfrm>
+          <a:prstGeom prst="roundRect">
+            <a:avLst>
+              <a:gd name="adj" fmla="val 4211"/>
+            </a:avLst>
+          </a:prstGeom>
+          <a:solidFill>
+            <a:srgbClr val="1C2330"/>
+          </a:solidFill>
+          <a:ln w="12700">
+            <a:solidFill>
+              <a:srgbClr val="2A3240"/>
+            </a:solidFill>
+            <a:prstDash val="solid"/>
+          </a:ln>
+        </p:spPr>
+      </p:sp>
+      <p:sp>
+        <p:nvSpPr>
+          <p:cNvPr id="8" name="Text 6"/>
+          <p:cNvSpPr/>
+          <p:nvPr/>
+        </p:nvSpPr>
+        <p:spPr>
+          <a:xfrm>
+            <a:off x="6446520" y="2212848"/>
+            <a:ext cx="4572000" cy="822960"/>
+          </a:xfrm>
+          <a:prstGeom prst="rect">
+            <a:avLst/>
+          </a:prstGeom>
+          <a:noFill/>
+          <a:ln/>
+        </p:spPr>
+        <p:txBody>
+          <a:bodyPr wrap="square" rtlCol="0" anchor="ctr"/>
+          <a:lstStyle/>
+          <a:p>
+            <a:pPr indent="0" marL="0">
+              <a:buNone/>
+            </a:pPr>
+            <a:r>
+              <a:rPr lang="en-US" sz="3800" b="1" dirty="0">
+                <a:solidFill>
+                  <a:srgbClr val="5EEAD4"/>
+                </a:solidFill>
+                <a:latin typeface="Georgia" pitchFamily="34" charset="0"/>
+                <a:ea typeface="Georgia" pitchFamily="34" charset="-122"/>
+                <a:cs typeface="Georgia" pitchFamily="34" charset="-120"/>
+              </a:rPr>
+              <a:t>20,000+</a:t>
+            </a:r>
+            <a:endParaRPr lang="en-US" sz="3800" dirty="0"/>
+          </a:p>
+        </p:txBody>
+      </p:sp>
+      <p:sp>
+        <p:nvSpPr>
+          <p:cNvPr id="9" name="Text 7"/>
+          <p:cNvSpPr/>
+          <p:nvPr/>
+        </p:nvSpPr>
+        <p:spPr>
+          <a:xfrm>
+            <a:off x="6464808" y="3063240"/>
+            <a:ext cx="4526280" cy="457200"/>
+          </a:xfrm>
+          <a:prstGeom prst="rect">
+            <a:avLst/>
+          </a:prstGeom>
+          <a:noFill/>
+          <a:ln/>
+        </p:spPr>
+        <p:txBody>
+          <a:bodyPr wrap="square" rtlCol="0" anchor="ctr"/>
+          <a:lstStyle/>
+          <a:p>
+            <a:pPr indent="0" marL="0">
+              <a:buNone/>
+            </a:pPr>
+            <a:r>
+              <a:rPr lang="en-US" sz="1400" dirty="0">
+                <a:solidFill>
+                  <a:srgbClr val="9AA7B4"/>
+                </a:solidFill>
+                <a:latin typeface="Calibri" pitchFamily="34" charset="0"/>
+                <a:ea typeface="Calibri" pitchFamily="34" charset="-122"/>
+                <a:cs typeface="Calibri" pitchFamily="34" charset="-120"/>
+              </a:rPr>
+              <a:t>scored per run, 20k+ LLM API calls</a:t>
+            </a:r>
+            <a:endParaRPr lang="en-US" sz="1400" dirty="0"/>
+          </a:p>
+        </p:txBody>
+      </p:sp>
+      <p:sp>
+        <p:nvSpPr>
+          <p:cNvPr id="10" name="Shape 8"/>
+          <p:cNvSpPr/>
+          <p:nvPr/>
+        </p:nvSpPr>
+        <p:spPr>
+          <a:xfrm>
+            <a:off x="640080" y="3886200"/>
+            <a:ext cx="5120640" cy="1737360"/>
+          </a:xfrm>
+          <a:prstGeom prst="roundRect">
+            <a:avLst>
+              <a:gd name="adj" fmla="val 4211"/>
+            </a:avLst>
+          </a:prstGeom>
+          <a:solidFill>
+            <a:srgbClr val="1C2330"/>
+          </a:solidFill>
+          <a:ln w="12700">
+            <a:solidFill>
+              <a:srgbClr val="2A3240"/>
+            </a:solidFill>
+            <a:prstDash val="solid"/>
+          </a:ln>
+        </p:spPr>
+      </p:sp>
+      <p:sp>
+        <p:nvSpPr>
+          <p:cNvPr id="11" name="Text 9"/>
+          <p:cNvSpPr/>
+          <p:nvPr/>
+        </p:nvSpPr>
+        <p:spPr>
+          <a:xfrm>
+            <a:off x="1005840" y="4178808"/>
+            <a:ext cx="4572000" cy="822960"/>
+          </a:xfrm>
+          <a:prstGeom prst="rect">
+            <a:avLst/>
+          </a:prstGeom>
+          <a:noFill/>
+          <a:ln/>
+        </p:spPr>
+        <p:txBody>
+          <a:bodyPr wrap="square" rtlCol="0" anchor="ctr"/>
+          <a:lstStyle/>
+          <a:p>
+            <a:pPr indent="0" marL="0">
+              <a:buNone/>
+            </a:pPr>
+            <a:r>
+              <a:rPr lang="en-US" sz="3800" b="1" dirty="0">
+                <a:solidFill>
+                  <a:srgbClr val="5EEAD4"/>
+                </a:solidFill>
+                <a:latin typeface="Georgia" pitchFamily="34" charset="0"/>
+                <a:ea typeface="Georgia" pitchFamily="34" charset="-122"/>
+                <a:cs typeface="Georgia" pitchFamily="34" charset="-120"/>
+              </a:rPr>
+              <a:t>90-120 min</a:t>
+            </a:r>
+            <a:endParaRPr lang="en-US" sz="3800" dirty="0"/>
+          </a:p>
+        </p:txBody>
+      </p:sp>
+      <p:sp>
+        <p:nvSpPr>
+          <p:cNvPr id="12" name="Text 10"/>
+          <p:cNvSpPr/>
+          <p:nvPr/>
+        </p:nvSpPr>
+        <p:spPr>
+          <a:xfrm>
+            <a:off x="1024128" y="5029200"/>
+            <a:ext cx="4526280" cy="457200"/>
+          </a:xfrm>
+          <a:prstGeom prst="rect">
+            <a:avLst/>
+          </a:prstGeom>
+          <a:noFill/>
+          <a:ln/>
+        </p:spPr>
+        <p:txBody>
+          <a:bodyPr wrap="square" rtlCol="0" anchor="ctr"/>
+          <a:lstStyle/>
+          <a:p>
+            <a:pPr indent="0" marL="0">
+              <a:buNone/>
+            </a:pPr>
+            <a:r>
+              <a:rPr lang="en-US" sz="1400" dirty="0">
+                <a:solidFill>
+                  <a:srgbClr val="9AA7B4"/>
+                </a:solidFill>
+                <a:latin typeface="Calibri" pitchFamily="34" charset="0"/>
+                <a:ea typeface="Calibri" pitchFamily="34" charset="-122"/>
+                <a:cs typeface="Calibri" pitchFamily="34" charset="-120"/>
+              </a:rPr>
+              <a:t>full run on Railway, with Slack status</a:t>
+            </a:r>
+            <a:endParaRPr lang="en-US" sz="1400" dirty="0"/>
+          </a:p>
+        </p:txBody>
+      </p:sp>
+      <p:sp>
+        <p:nvSpPr>
+          <p:cNvPr id="13" name="Shape 11"/>
+          <p:cNvSpPr/>
+          <p:nvPr/>
+        </p:nvSpPr>
+        <p:spPr>
+          <a:xfrm>
+            <a:off x="6080760" y="3886200"/>
+            <a:ext cx="5120640" cy="1737360"/>
+          </a:xfrm>
+          <a:prstGeom prst="roundRect">
+            <a:avLst>
+              <a:gd name="adj" fmla="val 4211"/>
+            </a:avLst>
+          </a:prstGeom>
+          <a:solidFill>
+            <a:srgbClr val="1C2330"/>
+          </a:solidFill>
+          <a:ln w="12700">
+            <a:solidFill>
+              <a:srgbClr val="2A3240"/>
+            </a:solidFill>
+            <a:prstDash val="solid"/>
+          </a:ln>
+        </p:spPr>
+      </p:sp>
+      <p:sp>
+        <p:nvSpPr>
+          <p:cNvPr id="14" name="Text 12"/>
+          <p:cNvSpPr/>
+          <p:nvPr/>
+        </p:nvSpPr>
+        <p:spPr>
+          <a:xfrm>
+            <a:off x="6446520" y="4178808"/>
+            <a:ext cx="4572000" cy="822960"/>
+          </a:xfrm>
+          <a:prstGeom prst="rect">
+            <a:avLst/>
+          </a:prstGeom>
+          <a:noFill/>
+          <a:ln/>
+        </p:spPr>
+        <p:txBody>
+          <a:bodyPr wrap="square" rtlCol="0" anchor="ctr"/>
+          <a:lstStyle/>
+          <a:p>
+            <a:pPr indent="0" marL="0">
+              <a:buNone/>
+            </a:pPr>
+            <a:r>
+              <a:rPr lang="en-US" sz="3800" b="1" dirty="0">
+                <a:solidFill>
+                  <a:srgbClr val="5EEAD4"/>
+                </a:solidFill>
+                <a:latin typeface="Georgia" pitchFamily="34" charset="0"/>
+                <a:ea typeface="Georgia" pitchFamily="34" charset="-122"/>
+                <a:cs typeface="Georgia" pitchFamily="34" charset="-120"/>
+              </a:rPr>
+              <a:t>2,000+/day</a:t>
+            </a:r>
+            <a:endParaRPr lang="en-US" sz="3800" dirty="0"/>
+          </a:p>
+        </p:txBody>
+      </p:sp>
+      <p:sp>
+        <p:nvSpPr>
+          <p:cNvPr id="15" name="Text 13"/>
+          <p:cNvSpPr/>
+          <p:nvPr/>
+        </p:nvSpPr>
+        <p:spPr>
+          <a:xfrm>
+            <a:off x="6464808" y="5029200"/>
+            <a:ext cx="4526280" cy="457200"/>
+          </a:xfrm>
+          <a:prstGeom prst="rect">
+            <a:avLst/>
+          </a:prstGeom>
+          <a:noFill/>
+          <a:ln/>
+        </p:spPr>
+        <p:txBody>
+          <a:bodyPr wrap="square" rtlCol="0" anchor="ctr"/>
+          <a:lstStyle/>
+          <a:p>
+            <a:pPr indent="0" marL="0">
+              <a:buNone/>
+            </a:pPr>
+            <a:r>
+              <a:rPr lang="en-US" sz="1400" dirty="0">
+                <a:solidFill>
+                  <a:srgbClr val="9AA7B4"/>
+                </a:solidFill>
+                <a:latin typeface="Calibri" pitchFamily="34" charset="0"/>
+                <a:ea typeface="Calibri" pitchFamily="34" charset="-122"/>
+                <a:cs typeface="Calibri" pitchFamily="34" charset="-120"/>
+              </a:rPr>
+              <a:t>WhatsApp + emails (Twilio + Postmark)</a:t>
+            </a:r>
+            <a:endParaRPr lang="en-US" sz="1400" dirty="0"/>
+          </a:p>
+        </p:txBody>
+      </p:sp>
+      <p:sp>
+        <p:nvSpPr>
+          <p:cNvPr id="16" name="Text 14"/>
+          <p:cNvSpPr/>
+          <p:nvPr/>
+        </p:nvSpPr>
+        <p:spPr>
+          <a:xfrm>
+            <a:off x="640080" y="5943600"/>
+            <a:ext cx="10881360" cy="365760"/>
+          </a:xfrm>
+          <a:prstGeom prst="rect">
+            <a:avLst/>
+          </a:prstGeom>
+          <a:noFill/>
+          <a:ln/>
+        </p:spPr>
+        <p:txBody>
+          <a:bodyPr wrap="square" rtlCol="0" anchor="ctr"/>
+          <a:lstStyle/>
+          <a:p>
+            <a:pPr algn="ctr" indent="0" marL="0">
+              <a:buNone/>
+            </a:pPr>
+            <a:r>
+              <a:rPr lang="en-US" sz="1300" i="1" dirty="0">
+                <a:solidFill>
+                  <a:srgbClr val="7D8896"/>
+                </a:solidFill>
+                <a:latin typeface="Calibri" pitchFamily="34" charset="0"/>
+                <a:ea typeface="Calibri" pitchFamily="34" charset="-122"/>
+                <a:cs typeface="Calibri" pitchFamily="34" charset="-120"/>
+              </a:rPr>
+              <a:t>Manual work that took weeks, now seconds to a couple of hours. Workflow on the previous slides.</a:t>
+            </a:r>
+            <a:endParaRPr lang="en-US" sz="1300" dirty="0"/>
+          </a:p>
+        </p:txBody>
+      </p:sp>
+    </p:spTree>
+  </p:cSld>
+  <p:clrMapOvr>
+    <a:masterClrMapping/>
+  </p:clrMapOvr>
+</p:sld>
+</file>
+
+<file path=ppt/slides/slide11.xml><?xml version="1.0" encoding="utf-8"?>
+<p:sld xmlns:a="http://schemas.openxmlformats.org/drawingml/2006/main" xmlns:r="http://schemas.openxmlformats.org/officeDocument/2006/relationships" xmlns:p="http://schemas.openxmlformats.org/presentationml/2006/main">
+  <p:cSld name="Slide 11">
+    <p:bg>
+      <p:bgPr>
+        <a:solidFill>
+          <a:srgbClr val="0D1117"/>
+        </a:solidFill>
+      </p:bgPr>
+    </p:bg>
+    <p:spTree>
+      <p:nvGrpSpPr>
+        <p:cNvPr id="1" name=""/>
+        <p:cNvGrpSpPr/>
+        <p:nvPr/>
+      </p:nvGrpSpPr>
+      <p:grpSpPr>
+        <a:xfrm>
+          <a:off x="0" y="0"/>
+          <a:ext cx="0" cy="0"/>
+          <a:chOff x="0" y="0"/>
+          <a:chExt cx="0" cy="0"/>
+        </a:xfrm>
+      </p:grpSpPr>
+      <p:sp>
+        <p:nvSpPr>
+          <p:cNvPr id="2" name="Text 0"/>
+          <p:cNvSpPr/>
+          <p:nvPr/>
+        </p:nvSpPr>
+        <p:spPr>
+          <a:xfrm>
             <a:off x="640080" y="1097280"/>
             <a:ext cx="10058400" cy="274320"/>
           </a:xfrm>
@@ -7268,7 +7926,7 @@
                 <a:ea typeface="Consolas" pitchFamily="34" charset="-122"/>
                 <a:cs typeface="Consolas" pitchFamily="34" charset="-120"/>
               </a:rPr>
-              <a:t>CONFIGURABLE BY DESIGN</a:t>
+              <a:t>RELIABILITY &amp; ERROR HANDLING</a:t>
             </a:r>
             <a:endParaRPr lang="en-US" sz="1100" dirty="0"/>
           </a:p>
@@ -7307,7 +7965,7 @@
                 <a:ea typeface="Georgia" pitchFamily="34" charset="-122"/>
                 <a:cs typeface="Georgia" pitchFamily="34" charset="-120"/>
               </a:rPr>
-              <a:t>One codebase, many deployments, zero forks</a:t>
+              <a:t>What survives when a third party misbehaves</a:t>
             </a:r>
             <a:endParaRPr lang="en-US" sz="3400" dirty="0"/>
           </a:p>
@@ -7315,61 +7973,22 @@
       </p:sp>
       <p:sp>
         <p:nvSpPr>
-          <p:cNvPr id="4" name="Text 2"/>
-          <p:cNvSpPr/>
-          <p:nvPr/>
-        </p:nvSpPr>
-        <p:spPr>
-          <a:xfrm>
-            <a:off x="640080" y="1645920"/>
-            <a:ext cx="10881360" cy="640080"/>
-          </a:xfrm>
-          <a:prstGeom prst="rect">
-            <a:avLst/>
-          </a:prstGeom>
-          <a:noFill/>
-          <a:ln/>
-        </p:spPr>
-        <p:txBody>
-          <a:bodyPr wrap="square" rtlCol="0" anchor="ctr"/>
-          <a:lstStyle/>
-          <a:p>
-            <a:pPr indent="0" marL="0">
-              <a:buNone/>
-            </a:pPr>
-            <a:r>
-              <a:rPr lang="en-US" sz="1500" i="1" dirty="0">
-                <a:solidFill>
-                  <a:srgbClr val="9AA7B4"/>
-                </a:solidFill>
-                <a:latin typeface="Calibri" pitchFamily="34" charset="0"/>
-                <a:ea typeface="Calibri" pitchFamily="34" charset="-122"/>
-                <a:cs typeface="Calibri" pitchFamily="34" charset="-120"/>
-              </a:rPr>
-              <a:t>Nothing is hard-coded per client. Behavior is driven entirely by environment variables, so the same service is deployed many times, each tuned to a different goal, by changing config and redeploying.</a:t>
-            </a:r>
-            <a:endParaRPr lang="en-US" sz="1500" dirty="0"/>
-          </a:p>
-        </p:txBody>
-      </p:sp>
-      <p:sp>
-        <p:nvSpPr>
-          <p:cNvPr id="5" name="Shape 3"/>
-          <p:cNvSpPr/>
-          <p:nvPr/>
-        </p:nvSpPr>
-        <p:spPr>
-          <a:xfrm>
-            <a:off x="640080" y="2468880"/>
-            <a:ext cx="3383280" cy="2468880"/>
+          <p:cNvPr id="4" name="Shape 2"/>
+          <p:cNvSpPr/>
+          <p:nvPr/>
+        </p:nvSpPr>
+        <p:spPr>
+          <a:xfrm>
+            <a:off x="640080" y="1691640"/>
+            <a:ext cx="5257800" cy="4526280"/>
           </a:xfrm>
           <a:prstGeom prst="roundRect">
             <a:avLst>
-              <a:gd name="adj" fmla="val 2963"/>
+              <a:gd name="adj" fmla="val 1616"/>
             </a:avLst>
           </a:prstGeom>
           <a:solidFill>
-            <a:srgbClr val="1C2330"/>
+            <a:srgbClr val="161B22"/>
           </a:solidFill>
           <a:ln w="12700">
             <a:solidFill>
@@ -7381,14 +8000,34 @@
       </p:sp>
       <p:sp>
         <p:nvSpPr>
+          <p:cNvPr id="5" name="Shape 3"/>
+          <p:cNvSpPr/>
+          <p:nvPr/>
+        </p:nvSpPr>
+        <p:spPr>
+          <a:xfrm>
+            <a:off x="640080" y="1691640"/>
+            <a:ext cx="5257800" cy="64008"/>
+          </a:xfrm>
+          <a:prstGeom prst="rect">
+            <a:avLst/>
+          </a:prstGeom>
+          <a:solidFill>
+            <a:srgbClr val="5EEAD4"/>
+          </a:solidFill>
+          <a:ln/>
+        </p:spPr>
+      </p:sp>
+      <p:sp>
+        <p:nvSpPr>
           <p:cNvPr id="6" name="Text 4"/>
           <p:cNvSpPr/>
           <p:nvPr/>
         </p:nvSpPr>
         <p:spPr>
           <a:xfrm>
-            <a:off x="914400" y="2743200"/>
-            <a:ext cx="2834640" cy="640080"/>
+            <a:off x="960120" y="1938528"/>
+            <a:ext cx="4617720" cy="365760"/>
           </a:xfrm>
           <a:prstGeom prst="rect">
             <a:avLst/>
@@ -7404,17 +8043,17 @@
               <a:buNone/>
             </a:pPr>
             <a:r>
-              <a:rPr lang="en-US" sz="1600" b="1" dirty="0">
+              <a:rPr lang="en-US" sz="1300" b="1" dirty="0">
                 <a:solidFill>
                   <a:srgbClr val="5EEAD4"/>
                 </a:solidFill>
-                <a:latin typeface="Georgia" pitchFamily="34" charset="0"/>
-                <a:ea typeface="Georgia" pitchFamily="34" charset="-122"/>
-                <a:cs typeface="Georgia" pitchFamily="34" charset="-120"/>
-              </a:rPr>
-              <a:t>Same engine, Flash or Pro</a:t>
-            </a:r>
-            <a:endParaRPr lang="en-US" sz="1600" dirty="0"/>
+                <a:latin typeface="Consolas" pitchFamily="34" charset="0"/>
+                <a:ea typeface="Consolas" pitchFamily="34" charset="-122"/>
+                <a:cs typeface="Consolas" pitchFamily="34" charset="-120"/>
+              </a:rPr>
+              <a:t>Project 01 · Role Matching</a:t>
+            </a:r>
+            <a:endParaRPr lang="en-US" sz="1300" dirty="0"/>
           </a:p>
         </p:txBody>
       </p:sp>
@@ -7426,24 +8065,31 @@
         </p:nvSpPr>
         <p:spPr>
           <a:xfrm>
-            <a:off x="914400" y="3429000"/>
-            <a:ext cx="2834640" cy="1371600"/>
-          </a:xfrm>
-          <a:prstGeom prst="rect">
-            <a:avLst/>
-          </a:prstGeom>
-          <a:noFill/>
-          <a:ln/>
-        </p:spPr>
-        <p:txBody>
-          <a:bodyPr wrap="square" rtlCol="0" anchor="ctr"/>
-          <a:lstStyle/>
-          <a:p>
-            <a:pPr indent="0" marL="0">
-              <a:buNone/>
-            </a:pPr>
-            <a:r>
-              <a:rPr lang="en-US" sz="1300" dirty="0">
+            <a:off x="960120" y="2432304"/>
+            <a:ext cx="4617720" cy="3611880"/>
+          </a:xfrm>
+          <a:prstGeom prst="rect">
+            <a:avLst/>
+          </a:prstGeom>
+          <a:noFill/>
+          <a:ln/>
+        </p:spPr>
+        <p:txBody>
+          <a:bodyPr wrap="square" rtlCol="0" anchor="t"/>
+          <a:lstStyle/>
+          <a:p>
+            <a:pPr marL="203200" indent="-203200">
+              <a:lnSpc>
+                <a:spcPct val="104000"/>
+              </a:lnSpc>
+              <a:spcAft>
+                <a:spcPts val="1100"/>
+              </a:spcAft>
+              <a:buSzPct val="100000"/>
+              <a:buChar char="•"/>
+            </a:pPr>
+            <a:r>
+              <a:rPr lang="en-US" sz="1350" dirty="0">
                 <a:solidFill>
                   <a:srgbClr val="9AA7B4"/>
                 </a:solidFill>
@@ -7451,9 +8097,81 @@
                 <a:ea typeface="Calibri" pitchFamily="34" charset="-122"/>
                 <a:cs typeface="Calibri" pitchFamily="34" charset="-120"/>
               </a:rPr>
-              <a:t>One codebase, two deployments: DeepSeek Flash for speed and cost, DeepSeek Pro for tougher roles. A single env var picks the model.</a:t>
-            </a:r>
-            <a:endParaRPr lang="en-US" sz="1300" dirty="0"/>
+              <a:t>DeepSeek over HTTPX: 7 retries, Retry-After aware, 5xx retried, other 4xx fail-fast, 90s timeout</a:t>
+            </a:r>
+            <a:endParaRPr lang="en-US" sz="1350" dirty="0"/>
+          </a:p>
+          <a:p>
+            <a:pPr marL="203200" indent="-203200">
+              <a:lnSpc>
+                <a:spcPct val="104000"/>
+              </a:lnSpc>
+              <a:spcAft>
+                <a:spcPts val="1100"/>
+              </a:spcAft>
+              <a:buSzPct val="100000"/>
+              <a:buChar char="•"/>
+            </a:pPr>
+            <a:r>
+              <a:rPr lang="en-US" sz="1350" dirty="0">
+                <a:solidFill>
+                  <a:srgbClr val="9AA7B4"/>
+                </a:solidFill>
+                <a:latin typeface="Calibri" pitchFamily="34" charset="0"/>
+                <a:ea typeface="Calibri" pitchFamily="34" charset="-122"/>
+                <a:cs typeface="Calibri" pitchFamily="34" charset="-120"/>
+              </a:rPr>
+              <a:t>Notion: 10 attempts in a 180s window, longer backoff on 503, invalid cursor = 5-min cooldown + restart</a:t>
+            </a:r>
+            <a:endParaRPr lang="en-US" sz="1350" dirty="0"/>
+          </a:p>
+          <a:p>
+            <a:pPr marL="203200" indent="-203200">
+              <a:lnSpc>
+                <a:spcPct val="104000"/>
+              </a:lnSpc>
+              <a:spcAft>
+                <a:spcPts val="1100"/>
+              </a:spcAft>
+              <a:buSzPct val="100000"/>
+              <a:buChar char="•"/>
+            </a:pPr>
+            <a:r>
+              <a:rPr lang="en-US" sz="1350" dirty="0">
+                <a:solidFill>
+                  <a:srgbClr val="9AA7B4"/>
+                </a:solidFill>
+                <a:latin typeface="Calibri" pitchFamily="34" charset="0"/>
+                <a:ea typeface="Calibri" pitchFamily="34" charset="-122"/>
+                <a:cs typeface="Calibri" pitchFamily="34" charset="-120"/>
+              </a:rPr>
+              <a:t>Global async semaphore (100) + prefetch window; sequential job queue with a 5-min cooldown between jobs</a:t>
+            </a:r>
+            <a:endParaRPr lang="en-US" sz="1350" dirty="0"/>
+          </a:p>
+          <a:p>
+            <a:pPr marL="203200" indent="-203200">
+              <a:lnSpc>
+                <a:spcPct val="104000"/>
+              </a:lnSpc>
+              <a:spcAft>
+                <a:spcPts val="1100"/>
+              </a:spcAft>
+              <a:buSzPct val="100000"/>
+              <a:buChar char="•"/>
+            </a:pPr>
+            <a:r>
+              <a:rPr lang="en-US" sz="1350" dirty="0">
+                <a:solidFill>
+                  <a:srgbClr val="9AA7B4"/>
+                </a:solidFill>
+                <a:latin typeface="Calibri" pitchFamily="34" charset="0"/>
+                <a:ea typeface="Calibri" pitchFamily="34" charset="-122"/>
+                <a:cs typeface="Calibri" pitchFamily="34" charset="-120"/>
+              </a:rPr>
+              <a:t>Per-candidate isolation; the run fails only if zero usable scores come back; idempotent re-runs</a:t>
+            </a:r>
+            <a:endParaRPr lang="en-US" sz="1350" dirty="0"/>
           </a:p>
         </p:txBody>
       </p:sp>
@@ -7465,16 +8183,16 @@
         </p:nvSpPr>
         <p:spPr>
           <a:xfrm>
-            <a:off x="4279392" y="2468880"/>
-            <a:ext cx="3383280" cy="2468880"/>
+            <a:off x="6126480" y="1691640"/>
+            <a:ext cx="5257800" cy="4526280"/>
           </a:xfrm>
           <a:prstGeom prst="roundRect">
             <a:avLst>
-              <a:gd name="adj" fmla="val 2963"/>
+              <a:gd name="adj" fmla="val 1616"/>
             </a:avLst>
           </a:prstGeom>
           <a:solidFill>
-            <a:srgbClr val="1C2330"/>
+            <a:srgbClr val="161B22"/>
           </a:solidFill>
           <a:ln w="12700">
             <a:solidFill>
@@ -7486,14 +8204,34 @@
       </p:sp>
       <p:sp>
         <p:nvSpPr>
-          <p:cNvPr id="9" name="Text 7"/>
-          <p:cNvSpPr/>
-          <p:nvPr/>
-        </p:nvSpPr>
-        <p:spPr>
-          <a:xfrm>
-            <a:off x="4553712" y="2743200"/>
-            <a:ext cx="2834640" cy="640080"/>
+          <p:cNvPr id="9" name="Shape 7"/>
+          <p:cNvSpPr/>
+          <p:nvPr/>
+        </p:nvSpPr>
+        <p:spPr>
+          <a:xfrm>
+            <a:off x="6126480" y="1691640"/>
+            <a:ext cx="5257800" cy="64008"/>
+          </a:xfrm>
+          <a:prstGeom prst="rect">
+            <a:avLst/>
+          </a:prstGeom>
+          <a:solidFill>
+            <a:srgbClr val="7C9EFF"/>
+          </a:solidFill>
+          <a:ln/>
+        </p:spPr>
+      </p:sp>
+      <p:sp>
+        <p:nvSpPr>
+          <p:cNvPr id="10" name="Text 8"/>
+          <p:cNvSpPr/>
+          <p:nvPr/>
+        </p:nvSpPr>
+        <p:spPr>
+          <a:xfrm>
+            <a:off x="6446520" y="1938528"/>
+            <a:ext cx="4617720" cy="365760"/>
           </a:xfrm>
           <a:prstGeom prst="rect">
             <a:avLst/>
@@ -7509,46 +8247,53 @@
               <a:buNone/>
             </a:pPr>
             <a:r>
-              <a:rPr lang="en-US" sz="1600" b="1" dirty="0">
-                <a:solidFill>
-                  <a:srgbClr val="5EEAD4"/>
-                </a:solidFill>
-                <a:latin typeface="Georgia" pitchFamily="34" charset="0"/>
-                <a:ea typeface="Georgia" pitchFamily="34" charset="-122"/>
-                <a:cs typeface="Georgia" pitchFamily="34" charset="-120"/>
-              </a:rPr>
-              <a:t>One reminder, deployed 3×</a:t>
-            </a:r>
-            <a:endParaRPr lang="en-US" sz="1600" dirty="0"/>
-          </a:p>
-        </p:txBody>
-      </p:sp>
-      <p:sp>
-        <p:nvSpPr>
-          <p:cNvPr id="10" name="Text 8"/>
-          <p:cNvSpPr/>
-          <p:nvPr/>
-        </p:nvSpPr>
-        <p:spPr>
-          <a:xfrm>
-            <a:off x="4553712" y="3429000"/>
-            <a:ext cx="2834640" cy="1371600"/>
-          </a:xfrm>
-          <a:prstGeom prst="rect">
-            <a:avLst/>
-          </a:prstGeom>
-          <a:noFill/>
-          <a:ln/>
-        </p:spPr>
-        <p:txBody>
-          <a:bodyPr wrap="square" rtlCol="0" anchor="ctr"/>
-          <a:lstStyle/>
-          <a:p>
-            <a:pPr indent="0" marL="0">
-              <a:buNone/>
-            </a:pPr>
-            <a:r>
-              <a:rPr lang="en-US" sz="1300" dirty="0">
+              <a:rPr lang="en-US" sz="1300" b="1" dirty="0">
+                <a:solidFill>
+                  <a:srgbClr val="7C9EFF"/>
+                </a:solidFill>
+                <a:latin typeface="Consolas" pitchFamily="34" charset="0"/>
+                <a:ea typeface="Consolas" pitchFamily="34" charset="-122"/>
+                <a:cs typeface="Consolas" pitchFamily="34" charset="-120"/>
+              </a:rPr>
+              <a:t>Project 02 · Candidate Flow</a:t>
+            </a:r>
+            <a:endParaRPr lang="en-US" sz="1300" dirty="0"/>
+          </a:p>
+        </p:txBody>
+      </p:sp>
+      <p:sp>
+        <p:nvSpPr>
+          <p:cNvPr id="11" name="Text 9"/>
+          <p:cNvSpPr/>
+          <p:nvPr/>
+        </p:nvSpPr>
+        <p:spPr>
+          <a:xfrm>
+            <a:off x="6446520" y="2432304"/>
+            <a:ext cx="4617720" cy="3611880"/>
+          </a:xfrm>
+          <a:prstGeom prst="rect">
+            <a:avLst/>
+          </a:prstGeom>
+          <a:noFill/>
+          <a:ln/>
+        </p:spPr>
+        <p:txBody>
+          <a:bodyPr wrap="square" rtlCol="0" anchor="t"/>
+          <a:lstStyle/>
+          <a:p>
+            <a:pPr marL="203200" indent="-203200">
+              <a:lnSpc>
+                <a:spcPct val="104000"/>
+              </a:lnSpc>
+              <a:spcAft>
+                <a:spcPts val="1100"/>
+              </a:spcAft>
+              <a:buSzPct val="100000"/>
+              <a:buChar char="•"/>
+            </a:pPr>
+            <a:r>
+              <a:rPr lang="en-US" sz="1350" dirty="0">
                 <a:solidFill>
                   <a:srgbClr val="9AA7B4"/>
                 </a:solidFill>
@@ -7556,104 +8301,23 @@
                 <a:ea typeface="Calibri" pitchFamily="34" charset="-122"/>
                 <a:cs typeface="Calibri" pitchFamily="34" charset="-120"/>
               </a:rPr>
-              <a:t>The WhatsApp reminder service runs three times, each with a different "hours since submission" threshold, for a staggered reminder sequence.</a:t>
-            </a:r>
-            <a:endParaRPr lang="en-US" sz="1300" dirty="0"/>
-          </a:p>
-        </p:txBody>
-      </p:sp>
-      <p:sp>
-        <p:nvSpPr>
-          <p:cNvPr id="11" name="Shape 9"/>
-          <p:cNvSpPr/>
-          <p:nvPr/>
-        </p:nvSpPr>
-        <p:spPr>
-          <a:xfrm>
-            <a:off x="7918704" y="2468880"/>
-            <a:ext cx="3383280" cy="2468880"/>
-          </a:xfrm>
-          <a:prstGeom prst="roundRect">
-            <a:avLst>
-              <a:gd name="adj" fmla="val 2963"/>
-            </a:avLst>
-          </a:prstGeom>
-          <a:solidFill>
-            <a:srgbClr val="1C2330"/>
-          </a:solidFill>
-          <a:ln w="12700">
-            <a:solidFill>
-              <a:srgbClr val="2A3240"/>
-            </a:solidFill>
-            <a:prstDash val="solid"/>
-          </a:ln>
-        </p:spPr>
-      </p:sp>
-      <p:sp>
-        <p:nvSpPr>
-          <p:cNvPr id="12" name="Text 10"/>
-          <p:cNvSpPr/>
-          <p:nvPr/>
-        </p:nvSpPr>
-        <p:spPr>
-          <a:xfrm>
-            <a:off x="8193024" y="2743200"/>
-            <a:ext cx="2834640" cy="640080"/>
-          </a:xfrm>
-          <a:prstGeom prst="rect">
-            <a:avLst/>
-          </a:prstGeom>
-          <a:noFill/>
-          <a:ln/>
-        </p:spPr>
-        <p:txBody>
-          <a:bodyPr wrap="square" rtlCol="0" anchor="ctr"/>
-          <a:lstStyle/>
-          <a:p>
-            <a:pPr indent="0" marL="0">
-              <a:buNone/>
-            </a:pPr>
-            <a:r>
-              <a:rPr lang="en-US" sz="1600" b="1" dirty="0">
-                <a:solidFill>
-                  <a:srgbClr val="5EEAD4"/>
-                </a:solidFill>
-                <a:latin typeface="Georgia" pitchFamily="34" charset="0"/>
-                <a:ea typeface="Georgia" pitchFamily="34" charset="-122"/>
-                <a:cs typeface="Georgia" pitchFamily="34" charset="-120"/>
-              </a:rPr>
-              <a:t>Same code, new database</a:t>
-            </a:r>
-            <a:endParaRPr lang="en-US" sz="1600" dirty="0"/>
-          </a:p>
-        </p:txBody>
-      </p:sp>
-      <p:sp>
-        <p:nvSpPr>
-          <p:cNvPr id="13" name="Text 11"/>
-          <p:cNvSpPr/>
-          <p:nvPr/>
-        </p:nvSpPr>
-        <p:spPr>
-          <a:xfrm>
-            <a:off x="8193024" y="3429000"/>
-            <a:ext cx="2834640" cy="1371600"/>
-          </a:xfrm>
-          <a:prstGeom prst="rect">
-            <a:avLst/>
-          </a:prstGeom>
-          <a:noFill/>
-          <a:ln/>
-        </p:spPr>
-        <p:txBody>
-          <a:bodyPr wrap="square" rtlCol="0" anchor="ctr"/>
-          <a:lstStyle/>
-          <a:p>
-            <a:pPr indent="0" marL="0">
-              <a:buNone/>
-            </a:pPr>
-            <a:r>
-              <a:rPr lang="en-US" sz="1300" dirty="0">
+              <a:t>Postmark: hourly + daily send caps (sliding window), 408/429/5xx backoff, 5-min queue cooldown</a:t>
+            </a:r>
+            <a:endParaRPr lang="en-US" sz="1350" dirty="0"/>
+          </a:p>
+          <a:p>
+            <a:pPr marL="203200" indent="-203200">
+              <a:lnSpc>
+                <a:spcPct val="104000"/>
+              </a:lnSpc>
+              <a:spcAft>
+                <a:spcPts val="1100"/>
+              </a:spcAft>
+              <a:buSzPct val="100000"/>
+              <a:buChar char="•"/>
+            </a:pPr>
+            <a:r>
+              <a:rPr lang="en-US" sz="1350" dirty="0">
                 <a:solidFill>
                   <a:srgbClr val="9AA7B4"/>
                 </a:solidFill>
@@ -7661,48 +8325,96 @@
                 <a:ea typeface="Calibri" pitchFamily="34" charset="-122"/>
                 <a:cs typeface="Calibri" pitchFamily="34" charset="-120"/>
               </a:rPr>
-              <a:t>Each branch points at a different Notion database in the same workspace via env vars. New database, new deploy, no code change.</a:t>
-            </a:r>
-            <a:endParaRPr lang="en-US" sz="1300" dirty="0"/>
-          </a:p>
-        </p:txBody>
-      </p:sp>
-      <p:sp>
-        <p:nvSpPr>
-          <p:cNvPr id="14" name="Text 12"/>
-          <p:cNvSpPr/>
-          <p:nvPr/>
-        </p:nvSpPr>
-        <p:spPr>
-          <a:xfrm>
-            <a:off x="640080" y="5257800"/>
-            <a:ext cx="10881360" cy="365760"/>
-          </a:xfrm>
-          <a:prstGeom prst="rect">
-            <a:avLst/>
-          </a:prstGeom>
-          <a:noFill/>
-          <a:ln/>
-        </p:spPr>
-        <p:txBody>
-          <a:bodyPr wrap="square" rtlCol="0" anchor="ctr"/>
-          <a:lstStyle/>
-          <a:p>
-            <a:pPr algn="ctr" indent="0" marL="0">
-              <a:buNone/>
-            </a:pPr>
-            <a:r>
-              <a:rPr lang="en-US" sz="1300" i="1" dirty="0">
-                <a:solidFill>
-                  <a:srgbClr val="7D8896"/>
+              <a:t>Hireflix transcript: polls up to 10 min at 60s, writes only when every answer is transcribed</a:t>
+            </a:r>
+            <a:endParaRPr lang="en-US" sz="1350" dirty="0"/>
+          </a:p>
+          <a:p>
+            <a:pPr marL="203200" indent="-203200">
+              <a:lnSpc>
+                <a:spcPct val="104000"/>
+              </a:lnSpc>
+              <a:spcAft>
+                <a:spcPts val="1100"/>
+              </a:spcAft>
+              <a:buSzPct val="100000"/>
+              <a:buChar char="•"/>
+            </a:pPr>
+            <a:r>
+              <a:rPr lang="en-US" sz="1350" dirty="0">
+                <a:solidFill>
+                  <a:srgbClr val="9AA7B4"/>
                 </a:solidFill>
                 <a:latin typeface="Calibri" pitchFamily="34" charset="0"/>
                 <a:ea typeface="Calibri" pitchFamily="34" charset="-122"/>
                 <a:cs typeface="Calibri" pitchFamily="34" charset="-120"/>
               </a:rPr>
-              <a:t>Same automation, different database, setting, or timeframe? Redeployed to a new space in about 5 minutes.</a:t>
-            </a:r>
-            <a:endParaRPr lang="en-US" sz="1300" dirty="0"/>
+              <a:t>Twilio: cron-driven, five templates, a configurable hours-since threshold, never double-nudges</a:t>
+            </a:r>
+            <a:endParaRPr lang="en-US" sz="1350" dirty="0"/>
+          </a:p>
+          <a:p>
+            <a:pPr marL="203200" indent="-203200">
+              <a:lnSpc>
+                <a:spcPct val="104000"/>
+              </a:lnSpc>
+              <a:spcAft>
+                <a:spcPts val="1100"/>
+              </a:spcAft>
+              <a:buSzPct val="100000"/>
+              <a:buChar char="•"/>
+            </a:pPr>
+            <a:r>
+              <a:rPr lang="en-US" sz="1350" dirty="0">
+                <a:solidFill>
+                  <a:srgbClr val="9AA7B4"/>
+                </a:solidFill>
+                <a:latin typeface="Calibri" pitchFamily="34" charset="0"/>
+                <a:ea typeface="Calibri" pitchFamily="34" charset="-122"/>
+                <a:cs typeface="Calibri" pitchFamily="34" charset="-120"/>
+              </a:rPr>
+              <a:t>CV: pdf-parse + regex extraction, DeepSeek only to structure &amp; score; SIGTERM + crash handlers</a:t>
+            </a:r>
+            <a:endParaRPr lang="en-US" sz="1350" dirty="0"/>
+          </a:p>
+        </p:txBody>
+      </p:sp>
+      <p:sp>
+        <p:nvSpPr>
+          <p:cNvPr id="12" name="Text 10"/>
+          <p:cNvSpPr/>
+          <p:nvPr/>
+        </p:nvSpPr>
+        <p:spPr>
+          <a:xfrm>
+            <a:off x="640080" y="6327648"/>
+            <a:ext cx="10881360" cy="274320"/>
+          </a:xfrm>
+          <a:prstGeom prst="rect">
+            <a:avLst/>
+          </a:prstGeom>
+          <a:noFill/>
+          <a:ln/>
+        </p:spPr>
+        <p:txBody>
+          <a:bodyPr wrap="square" rtlCol="0" anchor="ctr"/>
+          <a:lstStyle/>
+          <a:p>
+            <a:pPr algn="ctr" indent="0" marL="0">
+              <a:buNone/>
+            </a:pPr>
+            <a:r>
+              <a:rPr lang="en-US" sz="1200" i="1" dirty="0">
+                <a:solidFill>
+                  <a:srgbClr val="7D8896"/>
+                </a:solidFill>
+                <a:latin typeface="Calibri" pitchFamily="34" charset="0"/>
+                <a:ea typeface="Calibri" pitchFamily="34" charset="-122"/>
+                <a:cs typeface="Calibri" pitchFamily="34" charset="-120"/>
+              </a:rPr>
+              <a:t>Drawn from the actual codebases, not aspirational.</a:t>
+            </a:r>
+            <a:endParaRPr lang="en-US" sz="1200" dirty="0"/>
           </a:p>
         </p:txBody>
       </p:sp>
@@ -7771,7 +8483,7 @@
                 <a:ea typeface="Consolas" pitchFamily="34" charset="-122"/>
                 <a:cs typeface="Consolas" pitchFamily="34" charset="-120"/>
               </a:rPr>
-              <a:t>TECHNICAL WRITING</a:t>
+              <a:t>CONFIGURABLE BY DESIGN</a:t>
             </a:r>
             <a:endParaRPr lang="en-US" sz="1100" dirty="0"/>
           </a:p>
@@ -7810,7 +8522,7 @@
                 <a:ea typeface="Georgia" pitchFamily="34" charset="-122"/>
                 <a:cs typeface="Georgia" pitchFamily="34" charset="-120"/>
               </a:rPr>
-              <a:t>The documentation is part of the deliverable</a:t>
+              <a:t>One codebase, many deployments, zero forks</a:t>
             </a:r>
             <a:endParaRPr lang="en-US" sz="3400" dirty="0"/>
           </a:p>
@@ -7824,8 +8536,8 @@
         </p:nvSpPr>
         <p:spPr>
           <a:xfrm>
-            <a:off x="640080" y="1691640"/>
-            <a:ext cx="4937760" cy="914400"/>
+            <a:off x="640080" y="1645920"/>
+            <a:ext cx="10881360" cy="640080"/>
           </a:xfrm>
           <a:prstGeom prst="rect">
             <a:avLst/>
@@ -7841,7 +8553,7 @@
               <a:buNone/>
             </a:pPr>
             <a:r>
-              <a:rPr lang="en-US" sz="1600" dirty="0">
+              <a:rPr lang="en-US" sz="1500" i="1" dirty="0">
                 <a:solidFill>
                   <a:srgbClr val="9AA7B4"/>
                 </a:solidFill>
@@ -7849,9 +8561,9 @@
                 <a:ea typeface="Calibri" pitchFamily="34" charset="-122"/>
                 <a:cs typeface="Calibri" pitchFamily="34" charset="-120"/>
               </a:rPr>
-              <a:t>Every service ships an operational handbook. For a system that runs unattended, the docs are the reliability layer.</a:t>
-            </a:r>
-            <a:endParaRPr lang="en-US" sz="1600" dirty="0"/>
+              <a:t>Nothing is hard-coded per client. Behavior is driven entirely by environment variables, so the same service is deployed many times, each tuned to a different goal, by changing config and redeploying.</a:t>
+            </a:r>
+            <a:endParaRPr lang="en-US" sz="1500" dirty="0"/>
           </a:p>
         </p:txBody>
       </p:sp>
@@ -7863,16 +8575,16 @@
         </p:nvSpPr>
         <p:spPr>
           <a:xfrm>
-            <a:off x="640080" y="2788920"/>
-            <a:ext cx="5029200" cy="914400"/>
+            <a:off x="640080" y="2468880"/>
+            <a:ext cx="3383280" cy="2468880"/>
           </a:xfrm>
           <a:prstGeom prst="roundRect">
             <a:avLst>
-              <a:gd name="adj" fmla="val 8000"/>
+              <a:gd name="adj" fmla="val 2963"/>
             </a:avLst>
           </a:prstGeom>
           <a:solidFill>
-            <a:srgbClr val="161B22"/>
+            <a:srgbClr val="1C2330"/>
           </a:solidFill>
           <a:ln w="12700">
             <a:solidFill>
@@ -7890,8 +8602,8 @@
         </p:nvSpPr>
         <p:spPr>
           <a:xfrm>
-            <a:off x="914400" y="2907792"/>
-            <a:ext cx="4572000" cy="320040"/>
+            <a:off x="914400" y="2743200"/>
+            <a:ext cx="2834640" cy="640080"/>
           </a:xfrm>
           <a:prstGeom prst="rect">
             <a:avLst/>
@@ -7907,7 +8619,7 @@
               <a:buNone/>
             </a:pPr>
             <a:r>
-              <a:rPr lang="en-US" sz="1500" b="1" dirty="0">
+              <a:rPr lang="en-US" sz="1600" b="1" dirty="0">
                 <a:solidFill>
                   <a:srgbClr val="5EEAD4"/>
                 </a:solidFill>
@@ -7915,9 +8627,9 @@
                 <a:ea typeface="Georgia" pitchFamily="34" charset="-122"/>
                 <a:cs typeface="Georgia" pitchFamily="34" charset="-120"/>
               </a:rPr>
-              <a:t>Audience-layered</a:t>
-            </a:r>
-            <a:endParaRPr lang="en-US" sz="1500" dirty="0"/>
+              <a:t>Same engine, Flash or Pro</a:t>
+            </a:r>
+            <a:endParaRPr lang="en-US" sz="1600" dirty="0"/>
           </a:p>
         </p:txBody>
       </p:sp>
@@ -7929,8 +8641,8 @@
         </p:nvSpPr>
         <p:spPr>
           <a:xfrm>
-            <a:off x="914400" y="3246120"/>
-            <a:ext cx="4572000" cy="411480"/>
+            <a:off x="914400" y="3429000"/>
+            <a:ext cx="2834640" cy="1371600"/>
           </a:xfrm>
           <a:prstGeom prst="rect">
             <a:avLst/>
@@ -7946,7 +8658,7 @@
               <a:buNone/>
             </a:pPr>
             <a:r>
-              <a:rPr lang="en-US" sz="1250" dirty="0">
+              <a:rPr lang="en-US" sz="1300" dirty="0">
                 <a:solidFill>
                   <a:srgbClr val="9AA7B4"/>
                 </a:solidFill>
@@ -7954,9 +8666,9 @@
                 <a:ea typeface="Calibri" pitchFamily="34" charset="-122"/>
                 <a:cs typeface="Calibri" pitchFamily="34" charset="-120"/>
               </a:rPr>
-              <a:t>One-table overview for managers, branch-level depth for developers, same doc.</a:t>
-            </a:r>
-            <a:endParaRPr lang="en-US" sz="1250" dirty="0"/>
+              <a:t>One codebase, two deployments: DeepSeek Flash for speed and cost, DeepSeek Pro for tougher roles. A single env var picks the model.</a:t>
+            </a:r>
+            <a:endParaRPr lang="en-US" sz="1300" dirty="0"/>
           </a:p>
         </p:txBody>
       </p:sp>
@@ -7968,16 +8680,16 @@
         </p:nvSpPr>
         <p:spPr>
           <a:xfrm>
-            <a:off x="640080" y="3840480"/>
-            <a:ext cx="5029200" cy="914400"/>
+            <a:off x="4279392" y="2468880"/>
+            <a:ext cx="3383280" cy="2468880"/>
           </a:xfrm>
           <a:prstGeom prst="roundRect">
             <a:avLst>
-              <a:gd name="adj" fmla="val 8000"/>
+              <a:gd name="adj" fmla="val 2963"/>
             </a:avLst>
           </a:prstGeom>
           <a:solidFill>
-            <a:srgbClr val="161B22"/>
+            <a:srgbClr val="1C2330"/>
           </a:solidFill>
           <a:ln w="12700">
             <a:solidFill>
@@ -7995,8 +8707,8 @@
         </p:nvSpPr>
         <p:spPr>
           <a:xfrm>
-            <a:off x="914400" y="3959352"/>
-            <a:ext cx="4572000" cy="320040"/>
+            <a:off x="4553712" y="2743200"/>
+            <a:ext cx="2834640" cy="640080"/>
           </a:xfrm>
           <a:prstGeom prst="rect">
             <a:avLst/>
@@ -8012,7 +8724,7 @@
               <a:buNone/>
             </a:pPr>
             <a:r>
-              <a:rPr lang="en-US" sz="1500" b="1" dirty="0">
+              <a:rPr lang="en-US" sz="1600" b="1" dirty="0">
                 <a:solidFill>
                   <a:srgbClr val="5EEAD4"/>
                 </a:solidFill>
@@ -8020,9 +8732,9 @@
                 <a:ea typeface="Georgia" pitchFamily="34" charset="-122"/>
                 <a:cs typeface="Georgia" pitchFamily="34" charset="-120"/>
               </a:rPr>
-              <a:t>Operational</a:t>
-            </a:r>
-            <a:endParaRPr lang="en-US" sz="1500" dirty="0"/>
+              <a:t>One reminder, deployed 3×</a:t>
+            </a:r>
+            <a:endParaRPr lang="en-US" sz="1600" dirty="0"/>
           </a:p>
         </p:txBody>
       </p:sp>
@@ -8034,8 +8746,8 @@
         </p:nvSpPr>
         <p:spPr>
           <a:xfrm>
-            <a:off x="914400" y="4297680"/>
-            <a:ext cx="4572000" cy="411480"/>
+            <a:off x="4553712" y="3429000"/>
+            <a:ext cx="2834640" cy="1371600"/>
           </a:xfrm>
           <a:prstGeom prst="rect">
             <a:avLst/>
@@ -8051,7 +8763,7 @@
               <a:buNone/>
             </a:pPr>
             <a:r>
-              <a:rPr lang="en-US" sz="1250" dirty="0">
+              <a:rPr lang="en-US" sz="1300" dirty="0">
                 <a:solidFill>
                   <a:srgbClr val="9AA7B4"/>
                 </a:solidFill>
@@ -8059,9 +8771,9 @@
                 <a:ea typeface="Calibri" pitchFamily="34" charset="-122"/>
                 <a:cs typeface="Calibri" pitchFamily="34" charset="-120"/>
               </a:rPr>
-              <a:t>Documents which log line proves which behavior: debug by grep, not by reading source.</a:t>
-            </a:r>
-            <a:endParaRPr lang="en-US" sz="1250" dirty="0"/>
+              <a:t>The WhatsApp reminder service runs three times, each with a different "hours since submission" threshold, for a staggered reminder sequence.</a:t>
+            </a:r>
+            <a:endParaRPr lang="en-US" sz="1300" dirty="0"/>
           </a:p>
         </p:txBody>
       </p:sp>
@@ -8073,16 +8785,16 @@
         </p:nvSpPr>
         <p:spPr>
           <a:xfrm>
-            <a:off x="640080" y="4892040"/>
-            <a:ext cx="5029200" cy="914400"/>
+            <a:off x="7918704" y="2468880"/>
+            <a:ext cx="3383280" cy="2468880"/>
           </a:xfrm>
           <a:prstGeom prst="roundRect">
             <a:avLst>
-              <a:gd name="adj" fmla="val 8000"/>
+              <a:gd name="adj" fmla="val 2963"/>
             </a:avLst>
           </a:prstGeom>
           <a:solidFill>
-            <a:srgbClr val="161B22"/>
+            <a:srgbClr val="1C2330"/>
           </a:solidFill>
           <a:ln w="12700">
             <a:solidFill>
@@ -8100,8 +8812,8 @@
         </p:nvSpPr>
         <p:spPr>
           <a:xfrm>
-            <a:off x="914400" y="5010912"/>
-            <a:ext cx="4572000" cy="320040"/>
+            <a:off x="8193024" y="2743200"/>
+            <a:ext cx="2834640" cy="640080"/>
           </a:xfrm>
           <a:prstGeom prst="rect">
             <a:avLst/>
@@ -8117,7 +8829,7 @@
               <a:buNone/>
             </a:pPr>
             <a:r>
-              <a:rPr lang="en-US" sz="1500" b="1" dirty="0">
+              <a:rPr lang="en-US" sz="1600" b="1" dirty="0">
                 <a:solidFill>
                   <a:srgbClr val="5EEAD4"/>
                 </a:solidFill>
@@ -8125,9 +8837,9 @@
                 <a:ea typeface="Georgia" pitchFamily="34" charset="-122"/>
                 <a:cs typeface="Georgia" pitchFamily="34" charset="-120"/>
               </a:rPr>
-              <a:t>Failure-first</a:t>
-            </a:r>
-            <a:endParaRPr lang="en-US" sz="1500" dirty="0"/>
+              <a:t>Same code, new database</a:t>
+            </a:r>
+            <a:endParaRPr lang="en-US" sz="1600" dirty="0"/>
           </a:p>
         </p:txBody>
       </p:sp>
@@ -8139,8 +8851,8 @@
         </p:nvSpPr>
         <p:spPr>
           <a:xfrm>
-            <a:off x="914400" y="5349240"/>
-            <a:ext cx="4572000" cy="411480"/>
+            <a:off x="8193024" y="3429000"/>
+            <a:ext cx="2834640" cy="1371600"/>
           </a:xfrm>
           <a:prstGeom prst="rect">
             <a:avLst/>
@@ -8156,7 +8868,7 @@
               <a:buNone/>
             </a:pPr>
             <a:r>
-              <a:rPr lang="en-US" sz="1250" dirty="0">
+              <a:rPr lang="en-US" sz="1300" dirty="0">
                 <a:solidFill>
                   <a:srgbClr val="9AA7B4"/>
                 </a:solidFill>
@@ -8164,309 +8876,48 @@
                 <a:ea typeface="Calibri" pitchFamily="34" charset="-122"/>
                 <a:cs typeface="Calibri" pitchFamily="34" charset="-120"/>
               </a:rPr>
-              <a:t>Maps real symptoms to the exact gate that caused them.</a:t>
-            </a:r>
-            <a:endParaRPr lang="en-US" sz="1250" dirty="0"/>
-          </a:p>
-        </p:txBody>
-      </p:sp>
-      <p:sp>
-        <p:nvSpPr>
-          <p:cNvPr id="14" name="Shape 12"/>
-          <p:cNvSpPr/>
-          <p:nvPr/>
-        </p:nvSpPr>
-        <p:spPr>
-          <a:xfrm>
-            <a:off x="6035040" y="1691640"/>
-            <a:ext cx="5532120" cy="4480560"/>
-          </a:xfrm>
-          <a:prstGeom prst="roundRect">
-            <a:avLst>
-              <a:gd name="adj" fmla="val 1633"/>
-            </a:avLst>
-          </a:prstGeom>
-          <a:solidFill>
-            <a:srgbClr val="0A0E14"/>
-          </a:solidFill>
-          <a:ln w="12700">
-            <a:solidFill>
-              <a:srgbClr val="2A3240"/>
-            </a:solidFill>
-            <a:prstDash val="solid"/>
-          </a:ln>
-        </p:spPr>
-      </p:sp>
-      <p:sp>
-        <p:nvSpPr>
-          <p:cNvPr id="15" name="Shape 13"/>
-          <p:cNvSpPr/>
-          <p:nvPr/>
-        </p:nvSpPr>
-        <p:spPr>
-          <a:xfrm>
-            <a:off x="6309360" y="1920240"/>
-            <a:ext cx="146304" cy="146304"/>
-          </a:xfrm>
-          <a:prstGeom prst="ellipse">
-            <a:avLst/>
-          </a:prstGeom>
-          <a:solidFill>
-            <a:srgbClr val="E06C75"/>
-          </a:solidFill>
-          <a:ln/>
-        </p:spPr>
-      </p:sp>
-      <p:sp>
-        <p:nvSpPr>
-          <p:cNvPr id="16" name="Shape 14"/>
-          <p:cNvSpPr/>
-          <p:nvPr/>
-        </p:nvSpPr>
-        <p:spPr>
-          <a:xfrm>
-            <a:off x="6601968" y="1920240"/>
-            <a:ext cx="146304" cy="146304"/>
-          </a:xfrm>
-          <a:prstGeom prst="ellipse">
-            <a:avLst/>
-          </a:prstGeom>
-          <a:solidFill>
-            <a:srgbClr val="E5C07B"/>
-          </a:solidFill>
-          <a:ln/>
-        </p:spPr>
-      </p:sp>
-      <p:sp>
-        <p:nvSpPr>
-          <p:cNvPr id="17" name="Shape 15"/>
-          <p:cNvSpPr/>
-          <p:nvPr/>
-        </p:nvSpPr>
-        <p:spPr>
-          <a:xfrm>
-            <a:off x="6894576" y="1920240"/>
-            <a:ext cx="146304" cy="146304"/>
-          </a:xfrm>
-          <a:prstGeom prst="ellipse">
-            <a:avLst/>
-          </a:prstGeom>
-          <a:solidFill>
-            <a:srgbClr val="98C379"/>
-          </a:solidFill>
-          <a:ln/>
-        </p:spPr>
-      </p:sp>
-      <p:sp>
-        <p:nvSpPr>
-          <p:cNvPr id="18" name="Text 16"/>
-          <p:cNvSpPr/>
-          <p:nvPr/>
-        </p:nvSpPr>
-        <p:spPr>
-          <a:xfrm>
-            <a:off x="7315200" y="1874520"/>
-            <a:ext cx="3657600" cy="274320"/>
-          </a:xfrm>
-          <a:prstGeom prst="rect">
-            <a:avLst/>
-          </a:prstGeom>
-          <a:noFill/>
-          <a:ln/>
-        </p:spPr>
-        <p:txBody>
-          <a:bodyPr wrap="square" rtlCol="0" anchor="ctr"/>
-          <a:lstStyle/>
-          <a:p>
-            <a:pPr indent="0" marL="0">
-              <a:buNone/>
-            </a:pPr>
-            <a:r>
-              <a:rPr lang="en-US" sz="1100" dirty="0">
+              <a:t>Each branch points at a different Notion database in the same workspace via env vars. New database, new deploy, no code change.</a:t>
+            </a:r>
+            <a:endParaRPr lang="en-US" sz="1300" dirty="0"/>
+          </a:p>
+        </p:txBody>
+      </p:sp>
+      <p:sp>
+        <p:nvSpPr>
+          <p:cNvPr id="14" name="Text 12"/>
+          <p:cNvSpPr/>
+          <p:nvPr/>
+        </p:nvSpPr>
+        <p:spPr>
+          <a:xfrm>
+            <a:off x="640080" y="5257800"/>
+            <a:ext cx="10881360" cy="365760"/>
+          </a:xfrm>
+          <a:prstGeom prst="rect">
+            <a:avLst/>
+          </a:prstGeom>
+          <a:noFill/>
+          <a:ln/>
+        </p:spPr>
+        <p:txBody>
+          <a:bodyPr wrap="square" rtlCol="0" anchor="ctr"/>
+          <a:lstStyle/>
+          <a:p>
+            <a:pPr algn="ctr" indent="0" marL="0">
+              <a:buNone/>
+            </a:pPr>
+            <a:r>
+              <a:rPr lang="en-US" sz="1300" i="1" dirty="0">
                 <a:solidFill>
                   <a:srgbClr val="7D8896"/>
                 </a:solidFill>
-                <a:latin typeface="Consolas" pitchFamily="34" charset="0"/>
-                <a:ea typeface="Consolas" pitchFamily="34" charset="-122"/>
-                <a:cs typeface="Consolas" pitchFamily="34" charset="-120"/>
-              </a:rPr>
-              <a:t>troubleshooting.md</a:t>
-            </a:r>
-            <a:endParaRPr lang="en-US" sz="1100" dirty="0"/>
-          </a:p>
-        </p:txBody>
-      </p:sp>
-      <p:sp>
-        <p:nvSpPr>
-          <p:cNvPr id="19" name="Text 17"/>
-          <p:cNvSpPr/>
-          <p:nvPr/>
-        </p:nvSpPr>
-        <p:spPr>
-          <a:xfrm>
-            <a:off x="6355080" y="2331720"/>
-            <a:ext cx="4892040" cy="3657600"/>
-          </a:xfrm>
-          <a:prstGeom prst="rect">
-            <a:avLst/>
-          </a:prstGeom>
-          <a:noFill/>
-          <a:ln/>
-        </p:spPr>
-        <p:txBody>
-          <a:bodyPr wrap="square" rtlCol="0" anchor="t"/>
-          <a:lstStyle/>
-          <a:p>
-            <a:pPr indent="0" marL="0">
-              <a:lnSpc>
-                <a:spcPct val="115000"/>
-              </a:lnSpc>
-              <a:buNone/>
-            </a:pPr>
-            <a:r>
-              <a:rPr lang="en-US" sz="1200" dirty="0">
-                <a:solidFill>
-                  <a:srgbClr val="7D8896"/>
-                </a:solidFill>
-                <a:latin typeface="Consolas" pitchFamily="34" charset="0"/>
-                <a:ea typeface="Consolas" pitchFamily="34" charset="-122"/>
-                <a:cs typeface="Consolas" pitchFamily="34" charset="-120"/>
-              </a:rPr>
-              <a:t>## Troubleshooting
-</a:t>
-            </a:r>
-            <a:pPr indent="0" marL="0">
-              <a:lnSpc>
-                <a:spcPct val="115000"/>
-              </a:lnSpc>
-              <a:buNone/>
-            </a:pPr>
-            <a:r>
-              <a:rPr lang="en-US" sz="1200" b="1" dirty="0">
-                <a:solidFill>
-                  <a:srgbClr val="5EEAD4"/>
-                </a:solidFill>
-                <a:latin typeface="Consolas" pitchFamily="34" charset="0"/>
-                <a:ea typeface="Consolas" pitchFamily="34" charset="-122"/>
-                <a:cs typeface="Consolas" pitchFamily="34" charset="-120"/>
-              </a:rPr>
-              <a:t>Candidate not considered for a role, check, in order:
-</a:t>
-            </a:r>
-            <a:pPr indent="0" marL="0">
-              <a:lnSpc>
-                <a:spcPct val="115000"/>
-              </a:lnSpc>
-              <a:buNone/>
-            </a:pPr>
-            <a:r>
-              <a:rPr lang="en-US" sz="1200" dirty="0">
-                <a:solidFill>
-                  <a:srgbClr val="E6EDF3"/>
-                </a:solidFill>
-                <a:latin typeface="Consolas" pitchFamily="34" charset="0"/>
-                <a:ea typeface="Consolas" pitchFamily="34" charset="-122"/>
-                <a:cs typeface="Consolas" pitchFamily="34" charset="-120"/>
-              </a:rPr>
-              <a:t>  1. Stage-2 keyword overlap
-  2. Stage-3 hard filters (language, location, score)
-  3. existing scored row (already processed)
-  4. duplicate-email de-duplication
-</a:t>
-            </a:r>
-            <a:pPr indent="0" marL="0">
-              <a:lnSpc>
-                <a:spcPct val="115000"/>
-              </a:lnSpc>
-              <a:buNone/>
-            </a:pPr>
-            <a:r>
-              <a:rPr lang="en-US" sz="1200" b="1" dirty="0">
-                <a:solidFill>
-                  <a:srgbClr val="5EEAD4"/>
-                </a:solidFill>
-                <a:latin typeface="Consolas" pitchFamily="34" charset="0"/>
-                <a:ea typeface="Consolas" pitchFamily="34" charset="-122"/>
-                <a:cs typeface="Consolas" pitchFamily="34" charset="-120"/>
-              </a:rPr>
-              <a:t>Fewer qualified matches than target, expected:
-</a:t>
-            </a:r>
-            <a:pPr indent="0" marL="0">
-              <a:lnSpc>
-                <a:spcPct val="115000"/>
-              </a:lnSpc>
-              <a:buNone/>
-            </a:pPr>
-            <a:r>
-              <a:rPr lang="en-US" sz="1200" dirty="0">
-                <a:solidFill>
-                  <a:srgbClr val="E6EDF3"/>
-                </a:solidFill>
-                <a:latin typeface="Consolas" pitchFamily="34" charset="0"/>
-                <a:ea typeface="Consolas" pitchFamily="34" charset="-122"/>
-                <a:cs typeface="Consolas" pitchFamily="34" charset="-120"/>
-              </a:rPr>
-              <a:t>  Stage 6 backfills below-threshold by descending</a:t>
-            </a:r>
-            <a:endParaRPr lang="en-US" sz="1200" dirty="0"/>
-          </a:p>
-          <a:p>
-            <a:pPr indent="0" marL="0">
-              <a:lnSpc>
-                <a:spcPct val="115000"/>
-              </a:lnSpc>
-              <a:buNone/>
-            </a:pPr>
-            <a:r>
-              <a:rPr lang="en-US" sz="1200" dirty="0">
-                <a:solidFill>
-                  <a:srgbClr val="E6EDF3"/>
-                </a:solidFill>
-                <a:latin typeface="Consolas" pitchFamily="34" charset="0"/>
-                <a:ea typeface="Consolas" pitchFamily="34" charset="-122"/>
-                <a:cs typeface="Consolas" pitchFamily="34" charset="-120"/>
-              </a:rPr>
-              <a:t>  score and logs </a:t>
-            </a:r>
-            <a:endParaRPr lang="en-US" sz="1200" dirty="0"/>
-          </a:p>
-          <a:p>
-            <a:pPr indent="0" marL="0">
-              <a:lnSpc>
-                <a:spcPct val="115000"/>
-              </a:lnSpc>
-              <a:buNone/>
-            </a:pPr>
-            <a:r>
-              <a:rPr lang="en-US" sz="1200" dirty="0">
-                <a:solidFill>
-                  <a:srgbClr val="F0B86E"/>
-                </a:solidFill>
-                <a:latin typeface="Consolas" pitchFamily="34" charset="0"/>
-                <a:ea typeface="Consolas" pitchFamily="34" charset="-122"/>
-                <a:cs typeface="Consolas" pitchFamily="34" charset="-120"/>
-              </a:rPr>
-              <a:t>fallback_selected=true</a:t>
-            </a:r>
-            <a:pPr indent="0" marL="0">
-              <a:lnSpc>
-                <a:spcPct val="115000"/>
-              </a:lnSpc>
-              <a:buNone/>
-            </a:pPr>
-            <a:r>
-              <a:rPr lang="en-US" sz="1200" dirty="0">
-                <a:solidFill>
-                  <a:srgbClr val="E6EDF3"/>
-                </a:solidFill>
-                <a:latin typeface="Consolas" pitchFamily="34" charset="0"/>
-                <a:ea typeface="Consolas" pitchFamily="34" charset="-122"/>
-                <a:cs typeface="Consolas" pitchFamily="34" charset="-120"/>
-              </a:rPr>
-              <a:t> per row.</a:t>
-            </a:r>
-            <a:endParaRPr lang="en-US" sz="1200" dirty="0"/>
+                <a:latin typeface="Calibri" pitchFamily="34" charset="0"/>
+                <a:ea typeface="Calibri" pitchFamily="34" charset="-122"/>
+                <a:cs typeface="Calibri" pitchFamily="34" charset="-120"/>
+              </a:rPr>
+              <a:t>Same automation, different database, setting, or timeframe? Redeployed to a new space in about 5 minutes.</a:t>
+            </a:r>
+            <a:endParaRPr lang="en-US" sz="1300" dirty="0"/>
           </a:p>
         </p:txBody>
       </p:sp>
@@ -8535,7 +8986,7 @@
                 <a:ea typeface="Consolas" pitchFamily="34" charset="-122"/>
                 <a:cs typeface="Consolas" pitchFamily="34" charset="-120"/>
               </a:rPr>
-              <a:t>IMPACT</a:t>
+              <a:t>TECHNICAL WRITING</a:t>
             </a:r>
             <a:endParaRPr lang="en-US" sz="1100" dirty="0"/>
           </a:p>
@@ -8574,7 +9025,7 @@
                 <a:ea typeface="Georgia" pitchFamily="34" charset="-122"/>
                 <a:cs typeface="Georgia" pitchFamily="34" charset="-120"/>
               </a:rPr>
-              <a:t>What the automation delivers</a:t>
+              <a:t>The documentation is part of the deliverable</a:t>
             </a:r>
             <a:endParaRPr lang="en-US" sz="3400" dirty="0"/>
           </a:p>
@@ -8582,22 +9033,61 @@
       </p:sp>
       <p:sp>
         <p:nvSpPr>
-          <p:cNvPr id="4" name="Shape 2"/>
-          <p:cNvSpPr/>
-          <p:nvPr/>
-        </p:nvSpPr>
-        <p:spPr>
-          <a:xfrm>
-            <a:off x="640080" y="1920240"/>
-            <a:ext cx="5120640" cy="1737360"/>
+          <p:cNvPr id="4" name="Text 2"/>
+          <p:cNvSpPr/>
+          <p:nvPr/>
+        </p:nvSpPr>
+        <p:spPr>
+          <a:xfrm>
+            <a:off x="640080" y="1691640"/>
+            <a:ext cx="4937760" cy="914400"/>
+          </a:xfrm>
+          <a:prstGeom prst="rect">
+            <a:avLst/>
+          </a:prstGeom>
+          <a:noFill/>
+          <a:ln/>
+        </p:spPr>
+        <p:txBody>
+          <a:bodyPr wrap="square" rtlCol="0" anchor="ctr"/>
+          <a:lstStyle/>
+          <a:p>
+            <a:pPr indent="0" marL="0">
+              <a:buNone/>
+            </a:pPr>
+            <a:r>
+              <a:rPr lang="en-US" sz="1600" dirty="0">
+                <a:solidFill>
+                  <a:srgbClr val="9AA7B4"/>
+                </a:solidFill>
+                <a:latin typeface="Calibri" pitchFamily="34" charset="0"/>
+                <a:ea typeface="Calibri" pitchFamily="34" charset="-122"/>
+                <a:cs typeface="Calibri" pitchFamily="34" charset="-120"/>
+              </a:rPr>
+              <a:t>Every service ships an operational handbook. For a system that runs unattended, the docs are the reliability layer.</a:t>
+            </a:r>
+            <a:endParaRPr lang="en-US" sz="1600" dirty="0"/>
+          </a:p>
+        </p:txBody>
+      </p:sp>
+      <p:sp>
+        <p:nvSpPr>
+          <p:cNvPr id="5" name="Shape 3"/>
+          <p:cNvSpPr/>
+          <p:nvPr/>
+        </p:nvSpPr>
+        <p:spPr>
+          <a:xfrm>
+            <a:off x="640080" y="2788920"/>
+            <a:ext cx="5029200" cy="914400"/>
           </a:xfrm>
           <a:prstGeom prst="roundRect">
             <a:avLst>
-              <a:gd name="adj" fmla="val 4211"/>
+              <a:gd name="adj" fmla="val 8000"/>
             </a:avLst>
           </a:prstGeom>
           <a:solidFill>
-            <a:srgbClr val="1C2330"/>
+            <a:srgbClr val="161B22"/>
           </a:solidFill>
           <a:ln w="12700">
             <a:solidFill>
@@ -8609,14 +9099,14 @@
       </p:sp>
       <p:sp>
         <p:nvSpPr>
-          <p:cNvPr id="5" name="Text 3"/>
-          <p:cNvSpPr/>
-          <p:nvPr/>
-        </p:nvSpPr>
-        <p:spPr>
-          <a:xfrm>
-            <a:off x="1005840" y="2212848"/>
-            <a:ext cx="4572000" cy="822960"/>
+          <p:cNvPr id="6" name="Text 4"/>
+          <p:cNvSpPr/>
+          <p:nvPr/>
+        </p:nvSpPr>
+        <p:spPr>
+          <a:xfrm>
+            <a:off x="914400" y="2907792"/>
+            <a:ext cx="4572000" cy="320040"/>
           </a:xfrm>
           <a:prstGeom prst="rect">
             <a:avLst/>
@@ -8632,7 +9122,7 @@
               <a:buNone/>
             </a:pPr>
             <a:r>
-              <a:rPr lang="en-US" sz="3800" b="1" dirty="0">
+              <a:rPr lang="en-US" sz="1500" b="1" dirty="0">
                 <a:solidFill>
                   <a:srgbClr val="5EEAD4"/>
                 </a:solidFill>
@@ -8640,22 +9130,22 @@
                 <a:ea typeface="Georgia" pitchFamily="34" charset="-122"/>
                 <a:cs typeface="Georgia" pitchFamily="34" charset="-120"/>
               </a:rPr>
-              <a:t>40,000</a:t>
-            </a:r>
-            <a:endParaRPr lang="en-US" sz="3800" dirty="0"/>
-          </a:p>
-        </p:txBody>
-      </p:sp>
-      <p:sp>
-        <p:nvSpPr>
-          <p:cNvPr id="6" name="Text 4"/>
-          <p:cNvSpPr/>
-          <p:nvPr/>
-        </p:nvSpPr>
-        <p:spPr>
-          <a:xfrm>
-            <a:off x="1024128" y="3063240"/>
-            <a:ext cx="4526280" cy="457200"/>
+              <a:t>Audience-layered</a:t>
+            </a:r>
+            <a:endParaRPr lang="en-US" sz="1500" dirty="0"/>
+          </a:p>
+        </p:txBody>
+      </p:sp>
+      <p:sp>
+        <p:nvSpPr>
+          <p:cNvPr id="7" name="Text 5"/>
+          <p:cNvSpPr/>
+          <p:nvPr/>
+        </p:nvSpPr>
+        <p:spPr>
+          <a:xfrm>
+            <a:off x="914400" y="3246120"/>
+            <a:ext cx="4572000" cy="411480"/>
           </a:xfrm>
           <a:prstGeom prst="rect">
             <a:avLst/>
@@ -8671,7 +9161,7 @@
               <a:buNone/>
             </a:pPr>
             <a:r>
-              <a:rPr lang="en-US" sz="1400" dirty="0">
+              <a:rPr lang="en-US" sz="1250" dirty="0">
                 <a:solidFill>
                   <a:srgbClr val="9AA7B4"/>
                 </a:solidFill>
@@ -8679,30 +9169,30 @@
                 <a:ea typeface="Calibri" pitchFamily="34" charset="-122"/>
                 <a:cs typeface="Calibri" pitchFamily="34" charset="-120"/>
               </a:rPr>
-              <a:t>candidate rows scanned per matching run</a:t>
-            </a:r>
-            <a:endParaRPr lang="en-US" sz="1400" dirty="0"/>
-          </a:p>
-        </p:txBody>
-      </p:sp>
-      <p:sp>
-        <p:nvSpPr>
-          <p:cNvPr id="7" name="Shape 5"/>
-          <p:cNvSpPr/>
-          <p:nvPr/>
-        </p:nvSpPr>
-        <p:spPr>
-          <a:xfrm>
-            <a:off x="6080760" y="1920240"/>
-            <a:ext cx="5120640" cy="1737360"/>
+              <a:t>One-table overview for managers, branch-level depth for developers, same doc.</a:t>
+            </a:r>
+            <a:endParaRPr lang="en-US" sz="1250" dirty="0"/>
+          </a:p>
+        </p:txBody>
+      </p:sp>
+      <p:sp>
+        <p:nvSpPr>
+          <p:cNvPr id="8" name="Shape 6"/>
+          <p:cNvSpPr/>
+          <p:nvPr/>
+        </p:nvSpPr>
+        <p:spPr>
+          <a:xfrm>
+            <a:off x="640080" y="3840480"/>
+            <a:ext cx="5029200" cy="914400"/>
           </a:xfrm>
           <a:prstGeom prst="roundRect">
             <a:avLst>
-              <a:gd name="adj" fmla="val 4211"/>
+              <a:gd name="adj" fmla="val 8000"/>
             </a:avLst>
           </a:prstGeom>
           <a:solidFill>
-            <a:srgbClr val="1C2330"/>
+            <a:srgbClr val="161B22"/>
           </a:solidFill>
           <a:ln w="12700">
             <a:solidFill>
@@ -8714,14 +9204,14 @@
       </p:sp>
       <p:sp>
         <p:nvSpPr>
-          <p:cNvPr id="8" name="Text 6"/>
-          <p:cNvSpPr/>
-          <p:nvPr/>
-        </p:nvSpPr>
-        <p:spPr>
-          <a:xfrm>
-            <a:off x="6446520" y="2212848"/>
-            <a:ext cx="4572000" cy="822960"/>
+          <p:cNvPr id="9" name="Text 7"/>
+          <p:cNvSpPr/>
+          <p:nvPr/>
+        </p:nvSpPr>
+        <p:spPr>
+          <a:xfrm>
+            <a:off x="914400" y="3959352"/>
+            <a:ext cx="4572000" cy="320040"/>
           </a:xfrm>
           <a:prstGeom prst="rect">
             <a:avLst/>
@@ -8737,7 +9227,7 @@
               <a:buNone/>
             </a:pPr>
             <a:r>
-              <a:rPr lang="en-US" sz="3800" b="1" dirty="0">
+              <a:rPr lang="en-US" sz="1500" b="1" dirty="0">
                 <a:solidFill>
                   <a:srgbClr val="5EEAD4"/>
                 </a:solidFill>
@@ -8745,22 +9235,22 @@
                 <a:ea typeface="Georgia" pitchFamily="34" charset="-122"/>
                 <a:cs typeface="Georgia" pitchFamily="34" charset="-120"/>
               </a:rPr>
-              <a:t>20,000+</a:t>
-            </a:r>
-            <a:endParaRPr lang="en-US" sz="3800" dirty="0"/>
-          </a:p>
-        </p:txBody>
-      </p:sp>
-      <p:sp>
-        <p:nvSpPr>
-          <p:cNvPr id="9" name="Text 7"/>
-          <p:cNvSpPr/>
-          <p:nvPr/>
-        </p:nvSpPr>
-        <p:spPr>
-          <a:xfrm>
-            <a:off x="6464808" y="3063240"/>
-            <a:ext cx="4526280" cy="457200"/>
+              <a:t>Operational</a:t>
+            </a:r>
+            <a:endParaRPr lang="en-US" sz="1500" dirty="0"/>
+          </a:p>
+        </p:txBody>
+      </p:sp>
+      <p:sp>
+        <p:nvSpPr>
+          <p:cNvPr id="10" name="Text 8"/>
+          <p:cNvSpPr/>
+          <p:nvPr/>
+        </p:nvSpPr>
+        <p:spPr>
+          <a:xfrm>
+            <a:off x="914400" y="4297680"/>
+            <a:ext cx="4572000" cy="411480"/>
           </a:xfrm>
           <a:prstGeom prst="rect">
             <a:avLst/>
@@ -8776,7 +9266,7 @@
               <a:buNone/>
             </a:pPr>
             <a:r>
-              <a:rPr lang="en-US" sz="1400" dirty="0">
+              <a:rPr lang="en-US" sz="1250" dirty="0">
                 <a:solidFill>
                   <a:srgbClr val="9AA7B4"/>
                 </a:solidFill>
@@ -8784,30 +9274,30 @@
                 <a:ea typeface="Calibri" pitchFamily="34" charset="-122"/>
                 <a:cs typeface="Calibri" pitchFamily="34" charset="-120"/>
               </a:rPr>
-              <a:t>scored per run, 20k+ LLM API calls</a:t>
-            </a:r>
-            <a:endParaRPr lang="en-US" sz="1400" dirty="0"/>
-          </a:p>
-        </p:txBody>
-      </p:sp>
-      <p:sp>
-        <p:nvSpPr>
-          <p:cNvPr id="10" name="Shape 8"/>
-          <p:cNvSpPr/>
-          <p:nvPr/>
-        </p:nvSpPr>
-        <p:spPr>
-          <a:xfrm>
-            <a:off x="640080" y="3886200"/>
-            <a:ext cx="5120640" cy="1737360"/>
+              <a:t>Documents which log line proves which behavior: debug by grep, not by reading source.</a:t>
+            </a:r>
+            <a:endParaRPr lang="en-US" sz="1250" dirty="0"/>
+          </a:p>
+        </p:txBody>
+      </p:sp>
+      <p:sp>
+        <p:nvSpPr>
+          <p:cNvPr id="11" name="Shape 9"/>
+          <p:cNvSpPr/>
+          <p:nvPr/>
+        </p:nvSpPr>
+        <p:spPr>
+          <a:xfrm>
+            <a:off x="640080" y="4892040"/>
+            <a:ext cx="5029200" cy="914400"/>
           </a:xfrm>
           <a:prstGeom prst="roundRect">
             <a:avLst>
-              <a:gd name="adj" fmla="val 4211"/>
+              <a:gd name="adj" fmla="val 8000"/>
             </a:avLst>
           </a:prstGeom>
           <a:solidFill>
-            <a:srgbClr val="1C2330"/>
+            <a:srgbClr val="161B22"/>
           </a:solidFill>
           <a:ln w="12700">
             <a:solidFill>
@@ -8819,14 +9309,14 @@
       </p:sp>
       <p:sp>
         <p:nvSpPr>
-          <p:cNvPr id="11" name="Text 9"/>
-          <p:cNvSpPr/>
-          <p:nvPr/>
-        </p:nvSpPr>
-        <p:spPr>
-          <a:xfrm>
-            <a:off x="1005840" y="4178808"/>
-            <a:ext cx="4572000" cy="822960"/>
+          <p:cNvPr id="12" name="Text 10"/>
+          <p:cNvSpPr/>
+          <p:nvPr/>
+        </p:nvSpPr>
+        <p:spPr>
+          <a:xfrm>
+            <a:off x="914400" y="5010912"/>
+            <a:ext cx="4572000" cy="320040"/>
           </a:xfrm>
           <a:prstGeom prst="rect">
             <a:avLst/>
@@ -8842,7 +9332,7 @@
               <a:buNone/>
             </a:pPr>
             <a:r>
-              <a:rPr lang="en-US" sz="3800" b="1" dirty="0">
+              <a:rPr lang="en-US" sz="1500" b="1" dirty="0">
                 <a:solidFill>
                   <a:srgbClr val="5EEAD4"/>
                 </a:solidFill>
@@ -8850,22 +9340,22 @@
                 <a:ea typeface="Georgia" pitchFamily="34" charset="-122"/>
                 <a:cs typeface="Georgia" pitchFamily="34" charset="-120"/>
               </a:rPr>
-              <a:t>90-120 min</a:t>
-            </a:r>
-            <a:endParaRPr lang="en-US" sz="3800" dirty="0"/>
-          </a:p>
-        </p:txBody>
-      </p:sp>
-      <p:sp>
-        <p:nvSpPr>
-          <p:cNvPr id="12" name="Text 10"/>
-          <p:cNvSpPr/>
-          <p:nvPr/>
-        </p:nvSpPr>
-        <p:spPr>
-          <a:xfrm>
-            <a:off x="1024128" y="5029200"/>
-            <a:ext cx="4526280" cy="457200"/>
+              <a:t>Failure-first</a:t>
+            </a:r>
+            <a:endParaRPr lang="en-US" sz="1500" dirty="0"/>
+          </a:p>
+        </p:txBody>
+      </p:sp>
+      <p:sp>
+        <p:nvSpPr>
+          <p:cNvPr id="13" name="Text 11"/>
+          <p:cNvSpPr/>
+          <p:nvPr/>
+        </p:nvSpPr>
+        <p:spPr>
+          <a:xfrm>
+            <a:off x="914400" y="5349240"/>
+            <a:ext cx="4572000" cy="411480"/>
           </a:xfrm>
           <a:prstGeom prst="rect">
             <a:avLst/>
@@ -8881,7 +9371,7 @@
               <a:buNone/>
             </a:pPr>
             <a:r>
-              <a:rPr lang="en-US" sz="1400" dirty="0">
+              <a:rPr lang="en-US" sz="1250" dirty="0">
                 <a:solidFill>
                   <a:srgbClr val="9AA7B4"/>
                 </a:solidFill>
@@ -8889,30 +9379,30 @@
                 <a:ea typeface="Calibri" pitchFamily="34" charset="-122"/>
                 <a:cs typeface="Calibri" pitchFamily="34" charset="-120"/>
               </a:rPr>
-              <a:t>full run on Railway, with Slack status</a:t>
-            </a:r>
-            <a:endParaRPr lang="en-US" sz="1400" dirty="0"/>
-          </a:p>
-        </p:txBody>
-      </p:sp>
-      <p:sp>
-        <p:nvSpPr>
-          <p:cNvPr id="13" name="Shape 11"/>
-          <p:cNvSpPr/>
-          <p:nvPr/>
-        </p:nvSpPr>
-        <p:spPr>
-          <a:xfrm>
-            <a:off x="6080760" y="3886200"/>
-            <a:ext cx="5120640" cy="1737360"/>
+              <a:t>Maps real symptoms to the exact gate that caused them.</a:t>
+            </a:r>
+            <a:endParaRPr lang="en-US" sz="1250" dirty="0"/>
+          </a:p>
+        </p:txBody>
+      </p:sp>
+      <p:sp>
+        <p:nvSpPr>
+          <p:cNvPr id="14" name="Shape 12"/>
+          <p:cNvSpPr/>
+          <p:nvPr/>
+        </p:nvSpPr>
+        <p:spPr>
+          <a:xfrm>
+            <a:off x="6035040" y="1691640"/>
+            <a:ext cx="5532120" cy="4480560"/>
           </a:xfrm>
           <a:prstGeom prst="roundRect">
             <a:avLst>
-              <a:gd name="adj" fmla="val 4211"/>
+              <a:gd name="adj" fmla="val 1633"/>
             </a:avLst>
           </a:prstGeom>
           <a:solidFill>
-            <a:srgbClr val="1C2330"/>
+            <a:srgbClr val="0A0E14"/>
           </a:solidFill>
           <a:ln w="12700">
             <a:solidFill>
@@ -8924,14 +9414,74 @@
       </p:sp>
       <p:sp>
         <p:nvSpPr>
-          <p:cNvPr id="14" name="Text 12"/>
-          <p:cNvSpPr/>
-          <p:nvPr/>
-        </p:nvSpPr>
-        <p:spPr>
-          <a:xfrm>
-            <a:off x="6446520" y="4178808"/>
-            <a:ext cx="4572000" cy="822960"/>
+          <p:cNvPr id="15" name="Shape 13"/>
+          <p:cNvSpPr/>
+          <p:nvPr/>
+        </p:nvSpPr>
+        <p:spPr>
+          <a:xfrm>
+            <a:off x="6309360" y="1920240"/>
+            <a:ext cx="146304" cy="146304"/>
+          </a:xfrm>
+          <a:prstGeom prst="ellipse">
+            <a:avLst/>
+          </a:prstGeom>
+          <a:solidFill>
+            <a:srgbClr val="E06C75"/>
+          </a:solidFill>
+          <a:ln/>
+        </p:spPr>
+      </p:sp>
+      <p:sp>
+        <p:nvSpPr>
+          <p:cNvPr id="16" name="Shape 14"/>
+          <p:cNvSpPr/>
+          <p:nvPr/>
+        </p:nvSpPr>
+        <p:spPr>
+          <a:xfrm>
+            <a:off x="6601968" y="1920240"/>
+            <a:ext cx="146304" cy="146304"/>
+          </a:xfrm>
+          <a:prstGeom prst="ellipse">
+            <a:avLst/>
+          </a:prstGeom>
+          <a:solidFill>
+            <a:srgbClr val="E5C07B"/>
+          </a:solidFill>
+          <a:ln/>
+        </p:spPr>
+      </p:sp>
+      <p:sp>
+        <p:nvSpPr>
+          <p:cNvPr id="17" name="Shape 15"/>
+          <p:cNvSpPr/>
+          <p:nvPr/>
+        </p:nvSpPr>
+        <p:spPr>
+          <a:xfrm>
+            <a:off x="6894576" y="1920240"/>
+            <a:ext cx="146304" cy="146304"/>
+          </a:xfrm>
+          <a:prstGeom prst="ellipse">
+            <a:avLst/>
+          </a:prstGeom>
+          <a:solidFill>
+            <a:srgbClr val="98C379"/>
+          </a:solidFill>
+          <a:ln/>
+        </p:spPr>
+      </p:sp>
+      <p:sp>
+        <p:nvSpPr>
+          <p:cNvPr id="18" name="Text 16"/>
+          <p:cNvSpPr/>
+          <p:nvPr/>
+        </p:nvSpPr>
+        <p:spPr>
+          <a:xfrm>
+            <a:off x="7315200" y="1874520"/>
+            <a:ext cx="3657600" cy="274320"/>
           </a:xfrm>
           <a:prstGeom prst="rect">
             <a:avLst/>
@@ -8947,95 +9497,191 @@
               <a:buNone/>
             </a:pPr>
             <a:r>
-              <a:rPr lang="en-US" sz="3800" b="1" dirty="0">
+              <a:rPr lang="en-US" sz="1100" dirty="0">
+                <a:solidFill>
+                  <a:srgbClr val="7D8896"/>
+                </a:solidFill>
+                <a:latin typeface="Consolas" pitchFamily="34" charset="0"/>
+                <a:ea typeface="Consolas" pitchFamily="34" charset="-122"/>
+                <a:cs typeface="Consolas" pitchFamily="34" charset="-120"/>
+              </a:rPr>
+              <a:t>troubleshooting.md</a:t>
+            </a:r>
+            <a:endParaRPr lang="en-US" sz="1100" dirty="0"/>
+          </a:p>
+        </p:txBody>
+      </p:sp>
+      <p:sp>
+        <p:nvSpPr>
+          <p:cNvPr id="19" name="Text 17"/>
+          <p:cNvSpPr/>
+          <p:nvPr/>
+        </p:nvSpPr>
+        <p:spPr>
+          <a:xfrm>
+            <a:off x="6355080" y="2331720"/>
+            <a:ext cx="4892040" cy="3657600"/>
+          </a:xfrm>
+          <a:prstGeom prst="rect">
+            <a:avLst/>
+          </a:prstGeom>
+          <a:noFill/>
+          <a:ln/>
+        </p:spPr>
+        <p:txBody>
+          <a:bodyPr wrap="square" rtlCol="0" anchor="t"/>
+          <a:lstStyle/>
+          <a:p>
+            <a:pPr indent="0" marL="0">
+              <a:lnSpc>
+                <a:spcPct val="115000"/>
+              </a:lnSpc>
+              <a:buNone/>
+            </a:pPr>
+            <a:r>
+              <a:rPr lang="en-US" sz="1200" dirty="0">
+                <a:solidFill>
+                  <a:srgbClr val="7D8896"/>
+                </a:solidFill>
+                <a:latin typeface="Consolas" pitchFamily="34" charset="0"/>
+                <a:ea typeface="Consolas" pitchFamily="34" charset="-122"/>
+                <a:cs typeface="Consolas" pitchFamily="34" charset="-120"/>
+              </a:rPr>
+              <a:t>## Troubleshooting
+</a:t>
+            </a:r>
+            <a:pPr indent="0" marL="0">
+              <a:lnSpc>
+                <a:spcPct val="115000"/>
+              </a:lnSpc>
+              <a:buNone/>
+            </a:pPr>
+            <a:r>
+              <a:rPr lang="en-US" sz="1200" b="1" dirty="0">
                 <a:solidFill>
                   <a:srgbClr val="5EEAD4"/>
                 </a:solidFill>
-                <a:latin typeface="Georgia" pitchFamily="34" charset="0"/>
-                <a:ea typeface="Georgia" pitchFamily="34" charset="-122"/>
-                <a:cs typeface="Georgia" pitchFamily="34" charset="-120"/>
-              </a:rPr>
-              <a:t>2,000+/day</a:t>
-            </a:r>
-            <a:endParaRPr lang="en-US" sz="3800" dirty="0"/>
-          </a:p>
-        </p:txBody>
-      </p:sp>
-      <p:sp>
-        <p:nvSpPr>
-          <p:cNvPr id="15" name="Text 13"/>
-          <p:cNvSpPr/>
-          <p:nvPr/>
-        </p:nvSpPr>
-        <p:spPr>
-          <a:xfrm>
-            <a:off x="6464808" y="5029200"/>
-            <a:ext cx="4526280" cy="457200"/>
-          </a:xfrm>
-          <a:prstGeom prst="rect">
-            <a:avLst/>
-          </a:prstGeom>
-          <a:noFill/>
-          <a:ln/>
-        </p:spPr>
-        <p:txBody>
-          <a:bodyPr wrap="square" rtlCol="0" anchor="ctr"/>
-          <a:lstStyle/>
-          <a:p>
+                <a:latin typeface="Consolas" pitchFamily="34" charset="0"/>
+                <a:ea typeface="Consolas" pitchFamily="34" charset="-122"/>
+                <a:cs typeface="Consolas" pitchFamily="34" charset="-120"/>
+              </a:rPr>
+              <a:t>Candidate not considered for a role, check, in order:
+</a:t>
+            </a:r>
             <a:pPr indent="0" marL="0">
-              <a:buNone/>
-            </a:pPr>
-            <a:r>
-              <a:rPr lang="en-US" sz="1400" dirty="0">
-                <a:solidFill>
-                  <a:srgbClr val="9AA7B4"/>
-                </a:solidFill>
-                <a:latin typeface="Calibri" pitchFamily="34" charset="0"/>
-                <a:ea typeface="Calibri" pitchFamily="34" charset="-122"/>
-                <a:cs typeface="Calibri" pitchFamily="34" charset="-120"/>
-              </a:rPr>
-              <a:t>WhatsApp + emails (Twilio + Postmark)</a:t>
-            </a:r>
-            <a:endParaRPr lang="en-US" sz="1400" dirty="0"/>
-          </a:p>
-        </p:txBody>
-      </p:sp>
-      <p:sp>
-        <p:nvSpPr>
-          <p:cNvPr id="16" name="Text 14"/>
-          <p:cNvSpPr/>
-          <p:nvPr/>
-        </p:nvSpPr>
-        <p:spPr>
-          <a:xfrm>
-            <a:off x="640080" y="5943600"/>
-            <a:ext cx="10881360" cy="365760"/>
-          </a:xfrm>
-          <a:prstGeom prst="rect">
-            <a:avLst/>
-          </a:prstGeom>
-          <a:noFill/>
-          <a:ln/>
-        </p:spPr>
-        <p:txBody>
-          <a:bodyPr wrap="square" rtlCol="0" anchor="ctr"/>
-          <a:lstStyle/>
-          <a:p>
-            <a:pPr algn="ctr" indent="0" marL="0">
-              <a:buNone/>
-            </a:pPr>
-            <a:r>
-              <a:rPr lang="en-US" sz="1300" i="1" dirty="0">
-                <a:solidFill>
-                  <a:srgbClr val="7D8896"/>
-                </a:solidFill>
-                <a:latin typeface="Calibri" pitchFamily="34" charset="0"/>
-                <a:ea typeface="Calibri" pitchFamily="34" charset="-122"/>
-                <a:cs typeface="Calibri" pitchFamily="34" charset="-120"/>
-              </a:rPr>
-              <a:t>Manual work that took weeks, now seconds to a couple of hours. Workflow on the previous slides.</a:t>
-            </a:r>
-            <a:endParaRPr lang="en-US" sz="1300" dirty="0"/>
+              <a:lnSpc>
+                <a:spcPct val="115000"/>
+              </a:lnSpc>
+              <a:buNone/>
+            </a:pPr>
+            <a:r>
+              <a:rPr lang="en-US" sz="1200" dirty="0">
+                <a:solidFill>
+                  <a:srgbClr val="E6EDF3"/>
+                </a:solidFill>
+                <a:latin typeface="Consolas" pitchFamily="34" charset="0"/>
+                <a:ea typeface="Consolas" pitchFamily="34" charset="-122"/>
+                <a:cs typeface="Consolas" pitchFamily="34" charset="-120"/>
+              </a:rPr>
+              <a:t>  1. Stage-2 keyword overlap
+  2. Stage-3 hard filters (language, location, score)
+  3. existing scored row (already processed)
+  4. duplicate-email de-duplication
+</a:t>
+            </a:r>
+            <a:pPr indent="0" marL="0">
+              <a:lnSpc>
+                <a:spcPct val="115000"/>
+              </a:lnSpc>
+              <a:buNone/>
+            </a:pPr>
+            <a:r>
+              <a:rPr lang="en-US" sz="1200" b="1" dirty="0">
+                <a:solidFill>
+                  <a:srgbClr val="5EEAD4"/>
+                </a:solidFill>
+                <a:latin typeface="Consolas" pitchFamily="34" charset="0"/>
+                <a:ea typeface="Consolas" pitchFamily="34" charset="-122"/>
+                <a:cs typeface="Consolas" pitchFamily="34" charset="-120"/>
+              </a:rPr>
+              <a:t>Fewer qualified matches than target, expected:
+</a:t>
+            </a:r>
+            <a:pPr indent="0" marL="0">
+              <a:lnSpc>
+                <a:spcPct val="115000"/>
+              </a:lnSpc>
+              <a:buNone/>
+            </a:pPr>
+            <a:r>
+              <a:rPr lang="en-US" sz="1200" dirty="0">
+                <a:solidFill>
+                  <a:srgbClr val="E6EDF3"/>
+                </a:solidFill>
+                <a:latin typeface="Consolas" pitchFamily="34" charset="0"/>
+                <a:ea typeface="Consolas" pitchFamily="34" charset="-122"/>
+                <a:cs typeface="Consolas" pitchFamily="34" charset="-120"/>
+              </a:rPr>
+              <a:t>  Stage 6 backfills below-threshold by descending</a:t>
+            </a:r>
+            <a:endParaRPr lang="en-US" sz="1200" dirty="0"/>
+          </a:p>
+          <a:p>
+            <a:pPr indent="0" marL="0">
+              <a:lnSpc>
+                <a:spcPct val="115000"/>
+              </a:lnSpc>
+              <a:buNone/>
+            </a:pPr>
+            <a:r>
+              <a:rPr lang="en-US" sz="1200" dirty="0">
+                <a:solidFill>
+                  <a:srgbClr val="E6EDF3"/>
+                </a:solidFill>
+                <a:latin typeface="Consolas" pitchFamily="34" charset="0"/>
+                <a:ea typeface="Consolas" pitchFamily="34" charset="-122"/>
+                <a:cs typeface="Consolas" pitchFamily="34" charset="-120"/>
+              </a:rPr>
+              <a:t>  score and logs </a:t>
+            </a:r>
+            <a:endParaRPr lang="en-US" sz="1200" dirty="0"/>
+          </a:p>
+          <a:p>
+            <a:pPr indent="0" marL="0">
+              <a:lnSpc>
+                <a:spcPct val="115000"/>
+              </a:lnSpc>
+              <a:buNone/>
+            </a:pPr>
+            <a:r>
+              <a:rPr lang="en-US" sz="1200" dirty="0">
+                <a:solidFill>
+                  <a:srgbClr val="F0B86E"/>
+                </a:solidFill>
+                <a:latin typeface="Consolas" pitchFamily="34" charset="0"/>
+                <a:ea typeface="Consolas" pitchFamily="34" charset="-122"/>
+                <a:cs typeface="Consolas" pitchFamily="34" charset="-120"/>
+              </a:rPr>
+              <a:t>fallback_selected=true</a:t>
+            </a:r>
+            <a:pPr indent="0" marL="0">
+              <a:lnSpc>
+                <a:spcPct val="115000"/>
+              </a:lnSpc>
+              <a:buNone/>
+            </a:pPr>
+            <a:r>
+              <a:rPr lang="en-US" sz="1200" dirty="0">
+                <a:solidFill>
+                  <a:srgbClr val="E6EDF3"/>
+                </a:solidFill>
+                <a:latin typeface="Consolas" pitchFamily="34" charset="0"/>
+                <a:ea typeface="Consolas" pitchFamily="34" charset="-122"/>
+                <a:cs typeface="Consolas" pitchFamily="34" charset="-120"/>
+              </a:rPr>
+              <a:t> per row.</a:t>
+            </a:r>
+            <a:endParaRPr lang="en-US" sz="1200" dirty="0"/>
           </a:p>
         </p:txBody>
       </p:sp>

</xml_diff>